<commit_message>
Update Q3 audit report with Alejandra + rebuild PPT for compatibility
- Added Alejandra Velez Alicea, MD (from PDF export): 10 charts,
  avg 72.9%, Corrective Education Required, rank #11 of 13.
- Program total now: 13 providers, 130 charts, avg 76.4%.
- Distribution: 3 Needs Improvement, 10 Corrective Education Required.

Rebuilt PPT without the embedded chart (which was causing open failures
for the user). Replaced with a shape-based bar visualization that
renders in every PowerPoint version and preview app.

Word doc updated to match: cover, exec summary, ranked table, band
sections, recommendations, and Alejandra data-source note.

Co-Authored-By: Claude Opus 4.7 <noreply@anthropic.com>
Claude-Session: https://claude.ai/code/session_01FQCsD1ZdbqSqbtLgYtoLBe
</commit_message>
<xml_diff>
--- a/docs/Q3_2026_Provider_Audit_Report.pptx
+++ b/docs/Q3_2026_Provider_Audit_Report.pptx
@@ -118,160 +118,6 @@
     </a:lvl9pPr>
   </p:defaultTextStyle>
 </p:presentation>
-</file>
-
-<file path=ppt/charts/chart1.xml><?xml version="1.0" encoding="utf-8"?>
-<c:chartSpace xmlns:c="http://schemas.openxmlformats.org/drawingml/2006/chart" xmlns:a="http://schemas.openxmlformats.org/drawingml/2006/main" xmlns:r="http://schemas.openxmlformats.org/officeDocument/2006/relationships">
-  <c:date1904 val="0"/>
-  <c:chart>
-    <c:title>
-      <c:tx>
-        <c:rich>
-          <a:bodyPr/>
-          <a:lstStyle/>
-          <a:p>
-            <a:r>
-              <a:rPr sz="1400">
-                <a:solidFill>
-                  <a:srgbClr val="0F172A"/>
-                </a:solidFill>
-              </a:rPr>
-              <a:t>Provider count per band</a:t>
-            </a:r>
-          </a:p>
-        </c:rich>
-      </c:tx>
-      <c:layout/>
-      <c:overlay val="0"/>
-    </c:title>
-    <c:autoTitleDeleted val="0"/>
-    <c:plotArea>
-      <c:barChart>
-        <c:barDir val="col"/>
-        <c:grouping val="clustered"/>
-        <c:ser>
-          <c:idx val="0"/>
-          <c:order val="0"/>
-          <c:tx>
-            <c:strRef>
-              <c:f>Sheet1!$B$1</c:f>
-              <c:strCache>
-                <c:ptCount val="1"/>
-                <c:pt idx="0">
-                  <c:v>Providers</c:v>
-                </c:pt>
-              </c:strCache>
-            </c:strRef>
-          </c:tx>
-          <c:cat>
-            <c:strRef>
-              <c:f>Sheet1!$A$2:$A$5</c:f>
-              <c:strCache>
-                <c:ptCount val="4"/>
-                <c:pt idx="0">
-                  <c:v>Excellent</c:v>
-                </c:pt>
-                <c:pt idx="1">
-                  <c:v>Meets</c:v>
-                </c:pt>
-                <c:pt idx="2">
-                  <c:v>Needs Impr</c:v>
-                </c:pt>
-                <c:pt idx="3">
-                  <c:v>Corrective</c:v>
-                </c:pt>
-              </c:strCache>
-            </c:strRef>
-          </c:cat>
-          <c:val>
-            <c:numRef>
-              <c:f>Sheet1!$B$2:$B$5</c:f>
-              <c:numCache>
-                <c:formatCode>General</c:formatCode>
-                <c:ptCount val="4"/>
-                <c:pt idx="0">
-                  <c:v>0</c:v>
-                </c:pt>
-                <c:pt idx="1">
-                  <c:v>0</c:v>
-                </c:pt>
-                <c:pt idx="2">
-                  <c:v>3</c:v>
-                </c:pt>
-                <c:pt idx="3">
-                  <c:v>9</c:v>
-                </c:pt>
-              </c:numCache>
-            </c:numRef>
-          </c:val>
-        </c:ser>
-        <c:dLbls>
-          <c:txPr>
-            <a:bodyPr/>
-            <a:lstStyle/>
-            <a:p>
-              <a:pPr>
-                <a:defRPr sz="1200" b="1"/>
-              </a:pPr>
-            </a:p>
-          </c:txPr>
-          <c:showLegendKey val="0"/>
-          <c:showVal val="1"/>
-          <c:showCatName val="0"/>
-          <c:showSerName val="0"/>
-          <c:showPercent val="0"/>
-          <c:showBubbleSize val="0"/>
-          <c:showLeaderLines val="1"/>
-        </c:dLbls>
-        <c:axId val="-2068027336"/>
-        <c:axId val="-2113994440"/>
-      </c:barChart>
-      <c:catAx>
-        <c:axId val="-2068027336"/>
-        <c:scaling>
-          <c:orientation val="minMax"/>
-        </c:scaling>
-        <c:delete val="0"/>
-        <c:axPos val="b"/>
-        <c:majorTickMark val="out"/>
-        <c:minorTickMark val="none"/>
-        <c:tickLblPos val="nextTo"/>
-        <c:crossAx val="-2113994440"/>
-        <c:crosses val="autoZero"/>
-        <c:auto val="1"/>
-        <c:lblAlgn val="ctr"/>
-        <c:lblOffset val="100"/>
-        <c:noMultiLvlLbl val="0"/>
-      </c:catAx>
-      <c:valAx>
-        <c:axId val="-2113994440"/>
-        <c:scaling/>
-        <c:delete val="0"/>
-        <c:axPos val="l"/>
-        <c:majorGridlines/>
-        <c:majorTickMark val="out"/>
-        <c:minorTickMark val="none"/>
-        <c:tickLblPos val="nextTo"/>
-        <c:crossAx val="-2068027336"/>
-        <c:crosses val="autoZero"/>
-      </c:valAx>
-    </c:plotArea>
-    <c:dispBlanksAs val="gap"/>
-  </c:chart>
-  <c:txPr>
-    <a:bodyPr/>
-    <a:lstStyle/>
-    <a:p>
-      <a:pPr>
-        <a:defRPr sz="1800"/>
-      </a:pPr>
-      <a:endParaRPr lang="en-US"/>
-    </a:p>
-  </c:txPr>
-  <c:externalData r:id="rId1">
-    <c:autoUpdate val="0"/>
-  </c:externalData>
-</c:chartSpace>
 </file>
 
 <file path=ppt/slideLayouts/slideLayout1.xml><?xml version="1.0" encoding="utf-8"?>
@@ -3408,7 +3254,7 @@
                 </a:solidFill>
                 <a:latin typeface="Calibri"/>
               </a:rPr>
-              <a:t>Q3 2026 · HealthProMed · Coding &amp; CDI Department</a:t>
+              <a:t>Q3 2026 - HealthProMed - Coding &amp; CDI Department</a:t>
             </a:r>
           </a:p>
         </p:txBody>
@@ -3443,7 +3289,7 @@
                 </a:solidFill>
                 <a:latin typeface="Calibri"/>
               </a:rPr>
-              <a:t>12 providers · 120 audited claims · 6 payers</a:t>
+              <a:t>13 providers - 130 audited claims - 6 payers</a:t>
             </a:r>
           </a:p>
         </p:txBody>
@@ -3478,7 +3324,7 @@
                 </a:solidFill>
                 <a:latin typeface="Calibri"/>
               </a:rPr>
-              <a:t>Prepared by Eric Galan · Coding &amp; CDI Lead</a:t>
+              <a:t>Prepared by Eric Galan - Coding &amp; CDI Lead</a:t>
             </a:r>
           </a:p>
         </p:txBody>
@@ -3575,7 +3421,7 @@
                 </a:solidFill>
                 <a:latin typeface="Calibri"/>
               </a:rPr>
-              <a:t>Recommendations — Short-term (next 30 days)</a:t>
+              <a:t>Recommendations - Short-term (next 30 days)</a:t>
             </a:r>
           </a:p>
         </p:txBody>
@@ -3702,7 +3548,7 @@
                 </a:solidFill>
                 <a:latin typeface="Calibri"/>
               </a:rPr>
-              <a:t>     (target 60–90 days from education date).</a:t>
+              <a:t>     (target 60-90 days from education date).</a:t>
             </a:r>
           </a:p>
           <a:p>
@@ -3762,7 +3608,7 @@
                 </a:solidFill>
                 <a:latin typeface="Calibri"/>
               </a:rPr>
-              <a:t>4.  Convert Alejandra Velez Alicea's PDF audit to the standard workbook</a:t>
+              <a:t>4.  Migrate Alejandra Velez Alicea's audit from PDF into the standard workbook</a:t>
             </a:r>
           </a:p>
           <a:p>
@@ -3774,7 +3620,7 @@
                 </a:solidFill>
                 <a:latin typeface="Calibri"/>
               </a:rPr>
-              <a:t>     format so she's included in the next quarterly rollup.</a:t>
+              <a:t>     format so future rollups auto-populate.</a:t>
             </a:r>
           </a:p>
         </p:txBody>
@@ -3853,7 +3699,7 @@
                 </a:solidFill>
                 <a:latin typeface="Calibri"/>
               </a:rPr>
-              <a:t>HealthProMed · Q3 2026 Provider Audit Report</a:t>
+              <a:t>HealthProMed - Q3 2026 Provider Audit Report</a:t>
             </a:r>
           </a:p>
         </p:txBody>
@@ -3985,7 +3831,7 @@
                 </a:solidFill>
                 <a:latin typeface="Calibri"/>
               </a:rPr>
-              <a:t>Recommendations — Structural (next quarter)</a:t>
+              <a:t>Recommendations - Structural (next quarter)</a:t>
             </a:r>
           </a:p>
         </p:txBody>
@@ -4076,7 +3922,7 @@
                 </a:solidFill>
                 <a:latin typeface="Calibri"/>
               </a:rPr>
-              <a:t>     • EHR template review — where are documentation gaps built in?</a:t>
+              <a:t>     - EHR template review - where are documentation gaps built in?</a:t>
             </a:r>
           </a:p>
           <a:p>
@@ -4088,7 +3934,7 @@
                 </a:solidFill>
                 <a:latin typeface="Calibri"/>
               </a:rPr>
-              <a:t>     • Provider onboarding — is documentation training part of it?</a:t>
+              <a:t>     - Provider onboarding - is documentation training part of it?</a:t>
             </a:r>
           </a:p>
           <a:p>
@@ -4100,7 +3946,7 @@
                 </a:solidFill>
                 <a:latin typeface="Calibri"/>
               </a:rPr>
-              <a:t>     • Copy-forward workflow — is it being audited?</a:t>
+              <a:t>     - Copy-forward workflow - is it being audited?</a:t>
             </a:r>
           </a:p>
           <a:p>
@@ -4136,7 +3982,7 @@
                 </a:solidFill>
                 <a:latin typeface="Calibri"/>
               </a:rPr>
-              <a:t>     (2 providers) — test whether it moves scores to 90%+.</a:t>
+              <a:t>     (2 providers) - test whether it moves scores to 90%+.</a:t>
             </a:r>
           </a:p>
           <a:p>
@@ -4275,7 +4121,7 @@
                 </a:solidFill>
                 <a:latin typeface="Calibri"/>
               </a:rPr>
-              <a:t>HealthProMed · Q3 2026 Provider Audit Report</a:t>
+              <a:t>HealthProMed - Q3 2026 Provider Audit Report</a:t>
             </a:r>
           </a:p>
         </p:txBody>
@@ -4407,7 +4253,7 @@
                 </a:solidFill>
                 <a:latin typeface="Calibri"/>
               </a:rPr>
-              <a:t>Pending items</a:t>
+              <a:t>Data source note - Alejandra Velez Alicea, MD</a:t>
             </a:r>
           </a:p>
         </p:txBody>
@@ -4421,7 +4267,7 @@
         <p:spPr>
           <a:xfrm>
             <a:off x="457200" y="1371600"/>
-            <a:ext cx="11338560" cy="2286000"/>
+            <a:ext cx="11338560" cy="2743200"/>
           </a:xfrm>
           <a:prstGeom prst="rect">
             <a:avLst/>
@@ -4480,13 +4326,13 @@
           <a:p>
             <a:pPr algn="l"/>
             <a:r>
-              <a:rPr sz="2000" b="1">
+              <a:rPr sz="1800" b="1">
                 <a:solidFill>
                   <a:srgbClr val="0F6E6E"/>
                 </a:solidFill>
                 <a:latin typeface="Calibri"/>
               </a:rPr>
-              <a:t>Alejandra Velez Alicea, MD</a:t>
+              <a:t>Alejandra Velez Alicea, MD - included in this quarter's ranking</a:t>
             </a:r>
           </a:p>
         </p:txBody>
@@ -4500,7 +4346,7 @@
         <p:spPr>
           <a:xfrm>
             <a:off x="640080" y="2011680"/>
-            <a:ext cx="10972800" cy="1371600"/>
+            <a:ext cx="10972800" cy="2286000"/>
           </a:xfrm>
           <a:prstGeom prst="rect">
             <a:avLst/>
@@ -4521,7 +4367,7 @@
                 </a:solidFill>
                 <a:latin typeface="Calibri"/>
               </a:rPr>
-              <a:t>• Audit exists but is in PDF format (not the standard workbook).</a:t>
+              <a:t>- Compliance score: 72.9% (Corrective Education Required, rank #11 of 13)</a:t>
             </a:r>
           </a:p>
           <a:p>
@@ -4533,7 +4379,7 @@
                 </a:solidFill>
                 <a:latin typeface="Calibri"/>
               </a:rPr>
-              <a:t>• Excluded from this quarter's automated ranking.</a:t>
+              <a:t>- 10 claims audited (DOS 06/10/2026 - 09/06/2026)</a:t>
             </a:r>
           </a:p>
           <a:p>
@@ -4545,7 +4391,7 @@
                 </a:solidFill>
                 <a:latin typeface="Calibri"/>
               </a:rPr>
-              <a:t>• Action: transcribe to the standard workbook for inclusion in Q4 rollup.</a:t>
+              <a:t>- Data source: extracted from PDF export of the Provider Metrics tab</a:t>
             </a:r>
           </a:p>
           <a:p>
@@ -4557,7 +4403,19 @@
                 </a:solidFill>
                 <a:latin typeface="Calibri"/>
               </a:rPr>
-              <a:t>• Estimated time: 30 minutes.</a:t>
+              <a:t>- Recommendation: migrate to the standard Excel workbook format so</a:t>
+            </a:r>
+          </a:p>
+          <a:p>
+            <a:pPr algn="l"/>
+            <a:r>
+              <a:rPr sz="1400" b="0">
+                <a:solidFill>
+                  <a:srgbClr val="0F172A"/>
+                </a:solidFill>
+                <a:latin typeface="Calibri"/>
+              </a:rPr>
+              <a:t>   future rollups auto-populate without manual PDF conversion.</a:t>
             </a:r>
           </a:p>
         </p:txBody>
@@ -4570,7 +4428,7 @@
         </p:nvSpPr>
         <p:spPr>
           <a:xfrm>
-            <a:off x="457200" y="3931920"/>
+            <a:off x="457200" y="4480560"/>
             <a:ext cx="10972800" cy="457200"/>
           </a:xfrm>
           <a:prstGeom prst="rect">
@@ -4605,8 +4463,8 @@
         </p:nvSpPr>
         <p:spPr>
           <a:xfrm>
-            <a:off x="640080" y="4389120"/>
-            <a:ext cx="10972800" cy="2011680"/>
+            <a:off x="640080" y="4937760"/>
+            <a:ext cx="10972800" cy="1463040"/>
           </a:xfrm>
           <a:prstGeom prst="rect">
             <a:avLst/>
@@ -4621,49 +4479,49 @@
           <a:p>
             <a:pPr algn="l"/>
             <a:r>
-              <a:rPr sz="1400" b="0">
+              <a:rPr sz="1300" b="0">
                 <a:solidFill>
                   <a:srgbClr val="0F172A"/>
                 </a:solidFill>
                 <a:latin typeface="Calibri"/>
               </a:rPr>
-              <a:t>• Confirm 9 corrective-plan providers with Medical Director this week.</a:t>
-            </a:r>
-          </a:p>
-          <a:p>
-            <a:pPr algn="l"/>
-            <a:r>
-              <a:rPr sz="1400" b="0">
+              <a:t>- Confirm the 10 corrective-plan providers with Medical Director this week.</a:t>
+            </a:r>
+          </a:p>
+          <a:p>
+            <a:pPr algn="l"/>
+            <a:r>
+              <a:rPr sz="1300" b="0">
                 <a:solidFill>
                   <a:srgbClr val="0F172A"/>
                 </a:solidFill>
                 <a:latin typeface="Calibri"/>
               </a:rPr>
-              <a:t>• Schedule group education session in October.</a:t>
-            </a:r>
-          </a:p>
-          <a:p>
-            <a:pPr algn="l"/>
-            <a:r>
-              <a:rPr sz="1400" b="0">
+              <a:t>- Schedule group education session in October.</a:t>
+            </a:r>
+          </a:p>
+          <a:p>
+            <a:pPr algn="l"/>
+            <a:r>
+              <a:rPr sz="1300" b="0">
                 <a:solidFill>
                   <a:srgbClr val="0F172A"/>
                 </a:solidFill>
                 <a:latin typeface="Calibri"/>
               </a:rPr>
-              <a:t>• Refresh HCC lists for all 12 providers before Q4 cycle.</a:t>
-            </a:r>
-          </a:p>
-          <a:p>
-            <a:pPr algn="l"/>
-            <a:r>
-              <a:rPr sz="1400" b="0">
+              <a:t>- Refresh HCC lists for all 13 providers before Q4 cycle.</a:t>
+            </a:r>
+          </a:p>
+          <a:p>
+            <a:pPr algn="l"/>
+            <a:r>
+              <a:rPr sz="1300" b="0">
                 <a:solidFill>
                   <a:srgbClr val="0F172A"/>
                 </a:solidFill>
                 <a:latin typeface="Calibri"/>
               </a:rPr>
-              <a:t>• Prepare Q4 audit sample pull (mid-October).</a:t>
+              <a:t>- Prepare Q4 audit sample pull (mid-October).</a:t>
             </a:r>
           </a:p>
         </p:txBody>
@@ -4742,7 +4600,7 @@
                 </a:solidFill>
                 <a:latin typeface="Calibri"/>
               </a:rPr>
-              <a:t>HealthProMed · Q3 2026 Provider Audit Report</a:t>
+              <a:t>HealthProMed - Q3 2026 Provider Audit Report</a:t>
             </a:r>
           </a:p>
         </p:txBody>
@@ -4988,7 +4846,7 @@
                 </a:solidFill>
                 <a:latin typeface="Calibri"/>
               </a:rPr>
-              <a:t>1.  Approve the 9 Corrective Education plans and support the 1-on-1 sessions.</a:t>
+              <a:t>1.  Approve the 10 Corrective Education plans and support the 1-on-1 sessions.</a:t>
             </a:r>
           </a:p>
           <a:p>
@@ -5163,7 +5021,7 @@
                 </a:solidFill>
                 <a:latin typeface="Calibri"/>
               </a:rPr>
-              <a:t>HealthProMed · Q3 2026 Provider Audit Report</a:t>
+              <a:t>HealthProMed - Q3 2026 Provider Audit Report</a:t>
             </a:r>
           </a:p>
         </p:txBody>
@@ -5374,7 +5232,7 @@
                 </a:solidFill>
                 <a:latin typeface="Calibri"/>
               </a:rPr>
-              <a:t>All 12 provider audit workbooks are archived and available for review.</a:t>
+              <a:t>All 13 provider audits are archived and available for review.</a:t>
             </a:r>
           </a:p>
         </p:txBody>
@@ -5409,7 +5267,7 @@
                 </a:solidFill>
                 <a:latin typeface="Calibri"/>
               </a:rPr>
-              <a:t>Eric Galan · Coding &amp; CDI Lead</a:t>
+              <a:t>Eric Galan - Coding &amp; CDI Lead</a:t>
             </a:r>
           </a:p>
         </p:txBody>
@@ -5565,7 +5423,7 @@
                 </a:solidFill>
                 <a:latin typeface="Calibri"/>
               </a:rPr>
-              <a:t>3.  All providers ranked (highest → lowest)</a:t>
+              <a:t>3.  All providers ranked (highest to lowest)</a:t>
             </a:r>
           </a:p>
           <a:p>
@@ -5589,7 +5447,7 @@
                 </a:solidFill>
                 <a:latin typeface="Calibri"/>
               </a:rPr>
-              <a:t>5.  Corrective Education Required (9 providers)</a:t>
+              <a:t>5.  Corrective Education Required (10 providers)</a:t>
             </a:r>
           </a:p>
           <a:p>
@@ -5601,7 +5459,7 @@
                 </a:solidFill>
                 <a:latin typeface="Calibri"/>
               </a:rPr>
-              <a:t>6.  Critical finding — systemic pattern</a:t>
+              <a:t>6.  Critical finding - systemic pattern</a:t>
             </a:r>
           </a:p>
           <a:p>
@@ -5613,7 +5471,7 @@
                 </a:solidFill>
                 <a:latin typeface="Calibri"/>
               </a:rPr>
-              <a:t>7.  Recommendations (immediate · short-term · structural)</a:t>
+              <a:t>7.  Recommendations (immediate - short-term - structural)</a:t>
             </a:r>
           </a:p>
           <a:p>
@@ -5625,7 +5483,7 @@
                 </a:solidFill>
                 <a:latin typeface="Calibri"/>
               </a:rPr>
-              <a:t>8.  Pending items + next steps</a:t>
+              <a:t>8.  Data source note + next steps</a:t>
             </a:r>
           </a:p>
         </p:txBody>
@@ -5704,7 +5562,7 @@
                 </a:solidFill>
                 <a:latin typeface="Calibri"/>
               </a:rPr>
-              <a:t>HealthProMed · Q3 2026 Provider Audit Report</a:t>
+              <a:t>HealthProMed - Q3 2026 Provider Audit Report</a:t>
             </a:r>
           </a:p>
         </p:txBody>
@@ -5985,7 +5843,7 @@
                 </a:solidFill>
                 <a:latin typeface="Calibri"/>
               </a:rPr>
-              <a:t>12</a:t>
+              <a:t>13</a:t>
             </a:r>
           </a:p>
         </p:txBody>
@@ -6099,7 +5957,7 @@
                 </a:solidFill>
                 <a:latin typeface="Calibri"/>
               </a:rPr>
-              <a:t>120</a:t>
+              <a:t>130</a:t>
             </a:r>
           </a:p>
         </p:txBody>
@@ -6213,7 +6071,7 @@
                 </a:solidFill>
                 <a:latin typeface="Calibri"/>
               </a:rPr>
-              <a:t>76.7%</a:t>
+              <a:t>76.4%</a:t>
             </a:r>
           </a:p>
         </p:txBody>
@@ -6406,7 +6264,7 @@
                 </a:solidFill>
                 <a:latin typeface="Calibri"/>
               </a:rPr>
-              <a:t>• 12 providers audited across the July–September 2026 cycle (120 charts total).</a:t>
+              <a:t>- 13 providers audited across the July-September 2026 cycle (130 charts total).</a:t>
             </a:r>
           </a:p>
           <a:p>
@@ -6430,7 +6288,7 @@
                 </a:solidFill>
                 <a:latin typeface="Calibri"/>
               </a:rPr>
-              <a:t>• 0 providers reached Excellent (≥95%). 0 providers reached Meets Expectations (90-94%).</a:t>
+              <a:t>- 0 providers reached Excellent (&gt;=95%). 0 providers reached Meets Expectations (90-94%).</a:t>
             </a:r>
           </a:p>
           <a:p>
@@ -6442,7 +6300,7 @@
                 </a:solidFill>
                 <a:latin typeface="Calibri"/>
               </a:rPr>
-              <a:t>• 3 providers scored Needs Improvement (80-89%) — targeted education recommended.</a:t>
+              <a:t>- 3 providers scored Needs Improvement (80-89%) - targeted education recommended.</a:t>
             </a:r>
           </a:p>
           <a:p>
@@ -6454,7 +6312,7 @@
                 </a:solidFill>
                 <a:latin typeface="Calibri"/>
               </a:rPr>
-              <a:t>• 9 providers scored below 80% — formal Corrective Education Plans required.</a:t>
+              <a:t>- 10 providers scored below 80% - formal Corrective Education Plans required.</a:t>
             </a:r>
           </a:p>
           <a:p>
@@ -6478,7 +6336,7 @@
                 </a:solidFill>
                 <a:latin typeface="Calibri"/>
               </a:rPr>
-              <a:t>• Program-wide average of 76.7% indicates a systemic documentation issue,</a:t>
+              <a:t>- Program-wide average of 76.4% indicates a systemic documentation issue,</a:t>
             </a:r>
           </a:p>
           <a:p>
@@ -6569,7 +6427,7 @@
                 </a:solidFill>
                 <a:latin typeface="Calibri"/>
               </a:rPr>
-              <a:t>HealthProMed · Q3 2026 Provider Audit Report</a:t>
+              <a:t>HealthProMed - Q3 2026 Provider Audit Report</a:t>
             </a:r>
           </a:p>
         </p:txBody>
@@ -6736,7 +6594,7 @@
                 </a:solidFill>
                 <a:latin typeface="Calibri"/>
               </a:rPr>
-              <a:t>Distribution of the 12 providers across performance bands</a:t>
+              <a:t>Distribution of providers across performance bands</a:t>
             </a:r>
           </a:p>
         </p:txBody>
@@ -6843,13 +6701,13 @@
                     <a:p>
                       <a:pPr algn="l"/>
                       <a:r>
-                        <a:rPr sz="1000">
+                        <a:rPr sz="950">
                           <a:solidFill>
                             <a:srgbClr val="0F172A"/>
                           </a:solidFill>
                           <a:latin typeface="Calibri"/>
                         </a:rPr>
-                        <a:t>Excellent (≥95%)</a:t>
+                        <a:t>Excellent (&gt;=95%)</a:t>
                       </a:r>
                     </a:p>
                   </a:txBody>
@@ -6866,7 +6724,7 @@
                     <a:p>
                       <a:pPr algn="l"/>
                       <a:r>
-                        <a:rPr sz="1000">
+                        <a:rPr sz="950">
                           <a:solidFill>
                             <a:srgbClr val="0F172A"/>
                           </a:solidFill>
@@ -6889,7 +6747,7 @@
                     <a:p>
                       <a:pPr algn="l"/>
                       <a:r>
-                        <a:rPr sz="1000">
+                        <a:rPr sz="950">
                           <a:solidFill>
                             <a:srgbClr val="0F172A"/>
                           </a:solidFill>
@@ -6914,7 +6772,7 @@
                     <a:p>
                       <a:pPr algn="l"/>
                       <a:r>
-                        <a:rPr sz="1000">
+                        <a:rPr sz="950">
                           <a:solidFill>
                             <a:srgbClr val="0F172A"/>
                           </a:solidFill>
@@ -6937,7 +6795,7 @@
                     <a:p>
                       <a:pPr algn="l"/>
                       <a:r>
-                        <a:rPr sz="1000">
+                        <a:rPr sz="950">
                           <a:solidFill>
                             <a:srgbClr val="0F172A"/>
                           </a:solidFill>
@@ -6960,7 +6818,7 @@
                     <a:p>
                       <a:pPr algn="l"/>
                       <a:r>
-                        <a:rPr sz="1000">
+                        <a:rPr sz="950">
                           <a:solidFill>
                             <a:srgbClr val="0F172A"/>
                           </a:solidFill>
@@ -6985,7 +6843,7 @@
                     <a:p>
                       <a:pPr algn="l"/>
                       <a:r>
-                        <a:rPr sz="1000">
+                        <a:rPr sz="950">
                           <a:solidFill>
                             <a:srgbClr val="0F172A"/>
                           </a:solidFill>
@@ -7008,7 +6866,7 @@
                     <a:p>
                       <a:pPr algn="l"/>
                       <a:r>
-                        <a:rPr sz="1000">
+                        <a:rPr sz="950">
                           <a:solidFill>
                             <a:srgbClr val="0F172A"/>
                           </a:solidFill>
@@ -7031,7 +6889,7 @@
                     <a:p>
                       <a:pPr algn="l"/>
                       <a:r>
-                        <a:rPr sz="1000">
+                        <a:rPr sz="950">
                           <a:solidFill>
                             <a:srgbClr val="0F172A"/>
                           </a:solidFill>
@@ -7056,7 +6914,7 @@
                     <a:p>
                       <a:pPr algn="l"/>
                       <a:r>
-                        <a:rPr sz="1000">
+                        <a:rPr sz="950">
                           <a:solidFill>
                             <a:srgbClr val="0F172A"/>
                           </a:solidFill>
@@ -7079,13 +6937,13 @@
                     <a:p>
                       <a:pPr algn="l"/>
                       <a:r>
-                        <a:rPr sz="1000">
+                        <a:rPr sz="950">
                           <a:solidFill>
                             <a:srgbClr val="0F172A"/>
                           </a:solidFill>
                           <a:latin typeface="Calibri"/>
                         </a:rPr>
-                        <a:t>9</a:t>
+                        <a:t>10</a:t>
                       </a:r>
                     </a:p>
                   </a:txBody>
@@ -7102,7 +6960,7 @@
                     <a:p>
                       <a:pPr algn="l"/>
                       <a:r>
-                        <a:rPr sz="1000">
+                        <a:rPr sz="950">
                           <a:solidFill>
                             <a:srgbClr val="0F172A"/>
                           </a:solidFill>
@@ -7123,34 +6981,358 @@
           </a:graphicData>
         </a:graphic>
       </p:graphicFrame>
-      <p:graphicFrame>
-        <p:nvGraphicFramePr>
-          <p:cNvPr id="6" name="Chart 5"/>
-          <p:cNvGraphicFramePr>
-            <a:graphicFrameLocks noGrp="1"/>
-          </p:cNvGraphicFramePr>
-          <p:nvPr/>
-        </p:nvGraphicFramePr>
-        <p:xfrm>
-          <a:off x="6675120" y="1463040"/>
-          <a:ext cx="5120640" cy="4023360"/>
-        </p:xfrm>
-        <a:graphic>
-          <a:graphicData uri="http://schemas.openxmlformats.org/drawingml/2006/chart">
-            <c:chart xmlns:c="http://schemas.openxmlformats.org/drawingml/2006/chart" r:id="rId2"/>
-          </a:graphicData>
-        </a:graphic>
-      </p:graphicFrame>
-      <p:sp>
-        <p:nvSpPr>
-          <p:cNvPr id="7" name="Rectangle 6"/>
+      <p:sp>
+        <p:nvSpPr>
+          <p:cNvPr id="6" name="TextBox 5"/>
+          <p:cNvSpPr txBox="1"/>
+          <p:nvPr/>
+        </p:nvSpPr>
+        <p:spPr>
+          <a:xfrm>
+            <a:off x="6675120" y="1463040"/>
+            <a:ext cx="5120640" cy="365760"/>
+          </a:xfrm>
+          <a:prstGeom prst="rect">
+            <a:avLst/>
+          </a:prstGeom>
+          <a:noFill/>
+        </p:spPr>
+        <p:txBody>
+          <a:bodyPr wrap="square" lIns="45720" rIns="45720" tIns="18288" bIns="18288" anchor="t">
+            <a:spAutoFit/>
+          </a:bodyPr>
+          <a:lstStyle/>
+          <a:p>
+            <a:pPr algn="l"/>
+            <a:r>
+              <a:rPr sz="1400" b="1">
+                <a:solidFill>
+                  <a:srgbClr val="0F172A"/>
+                </a:solidFill>
+                <a:latin typeface="Calibri"/>
+              </a:rPr>
+              <a:t>Provider count per band</a:t>
+            </a:r>
+          </a:p>
+        </p:txBody>
+      </p:sp>
+      <p:sp>
+        <p:nvSpPr>
+          <p:cNvPr id="7" name="TextBox 6"/>
+          <p:cNvSpPr txBox="1"/>
+          <p:nvPr/>
+        </p:nvSpPr>
+        <p:spPr>
+          <a:xfrm>
+            <a:off x="6675120" y="2011680"/>
+            <a:ext cx="1280160" cy="640080"/>
+          </a:xfrm>
+          <a:prstGeom prst="rect">
+            <a:avLst/>
+          </a:prstGeom>
+          <a:noFill/>
+        </p:spPr>
+        <p:txBody>
+          <a:bodyPr wrap="square" lIns="45720" rIns="45720" tIns="18288" bIns="18288" anchor="ctr">
+            <a:spAutoFit/>
+          </a:bodyPr>
+          <a:lstStyle/>
+          <a:p>
+            <a:pPr algn="l"/>
+            <a:r>
+              <a:rPr sz="1200" b="1">
+                <a:solidFill>
+                  <a:srgbClr val="0F172A"/>
+                </a:solidFill>
+                <a:latin typeface="Calibri"/>
+              </a:rPr>
+              <a:t>Excellent</a:t>
+            </a:r>
+          </a:p>
+        </p:txBody>
+      </p:sp>
+      <p:sp>
+        <p:nvSpPr>
+          <p:cNvPr id="8" name="Rectangle 7"/>
           <p:cNvSpPr/>
           <p:nvPr/>
         </p:nvSpPr>
         <p:spPr>
           <a:xfrm>
-            <a:off x="457200" y="5669280"/>
-            <a:ext cx="11338560" cy="640080"/>
+            <a:off x="8046720" y="2148840"/>
+            <a:ext cx="4114800" cy="365760"/>
+          </a:xfrm>
+          <a:prstGeom prst="rect">
+            <a:avLst/>
+          </a:prstGeom>
+          <a:solidFill>
+            <a:srgbClr val="E6F4F1"/>
+          </a:solidFill>
+          <a:ln>
+            <a:noFill/>
+          </a:ln>
+          <a:effectLst/>
+        </p:spPr>
+        <p:style>
+          <a:lnRef idx="1">
+            <a:schemeClr val="accent1"/>
+          </a:lnRef>
+          <a:fillRef idx="3">
+            <a:schemeClr val="accent1"/>
+          </a:fillRef>
+          <a:effectRef idx="2">
+            <a:schemeClr val="accent1"/>
+          </a:effectRef>
+          <a:fontRef idx="minor">
+            <a:schemeClr val="lt1"/>
+          </a:fontRef>
+        </p:style>
+        <p:txBody>
+          <a:bodyPr rtlCol="0" anchor="ctr"/>
+          <a:lstStyle/>
+          <a:p>
+            <a:pPr algn="ctr"/>
+          </a:p>
+        </p:txBody>
+      </p:sp>
+      <p:sp>
+        <p:nvSpPr>
+          <p:cNvPr id="9" name="TextBox 8"/>
+          <p:cNvSpPr txBox="1"/>
+          <p:nvPr/>
+        </p:nvSpPr>
+        <p:spPr>
+          <a:xfrm>
+            <a:off x="12298680" y="2011680"/>
+            <a:ext cx="548640" cy="640080"/>
+          </a:xfrm>
+          <a:prstGeom prst="rect">
+            <a:avLst/>
+          </a:prstGeom>
+          <a:noFill/>
+        </p:spPr>
+        <p:txBody>
+          <a:bodyPr wrap="square" lIns="45720" rIns="45720" tIns="18288" bIns="18288" anchor="ctr">
+            <a:spAutoFit/>
+          </a:bodyPr>
+          <a:lstStyle/>
+          <a:p>
+            <a:pPr algn="l"/>
+            <a:r>
+              <a:rPr sz="1800" b="1">
+                <a:solidFill>
+                  <a:srgbClr val="1E40AF"/>
+                </a:solidFill>
+                <a:latin typeface="Calibri"/>
+              </a:rPr>
+              <a:t>0</a:t>
+            </a:r>
+          </a:p>
+        </p:txBody>
+      </p:sp>
+      <p:sp>
+        <p:nvSpPr>
+          <p:cNvPr id="10" name="TextBox 9"/>
+          <p:cNvSpPr txBox="1"/>
+          <p:nvPr/>
+        </p:nvSpPr>
+        <p:spPr>
+          <a:xfrm>
+            <a:off x="6675120" y="2880360"/>
+            <a:ext cx="1280160" cy="640080"/>
+          </a:xfrm>
+          <a:prstGeom prst="rect">
+            <a:avLst/>
+          </a:prstGeom>
+          <a:noFill/>
+        </p:spPr>
+        <p:txBody>
+          <a:bodyPr wrap="square" lIns="45720" rIns="45720" tIns="18288" bIns="18288" anchor="ctr">
+            <a:spAutoFit/>
+          </a:bodyPr>
+          <a:lstStyle/>
+          <a:p>
+            <a:pPr algn="l"/>
+            <a:r>
+              <a:rPr sz="1200" b="1">
+                <a:solidFill>
+                  <a:srgbClr val="0F172A"/>
+                </a:solidFill>
+                <a:latin typeface="Calibri"/>
+              </a:rPr>
+              <a:t>Meets</a:t>
+            </a:r>
+          </a:p>
+        </p:txBody>
+      </p:sp>
+      <p:sp>
+        <p:nvSpPr>
+          <p:cNvPr id="11" name="Rectangle 10"/>
+          <p:cNvSpPr/>
+          <p:nvPr/>
+        </p:nvSpPr>
+        <p:spPr>
+          <a:xfrm>
+            <a:off x="8046720" y="3017520"/>
+            <a:ext cx="4114800" cy="365760"/>
+          </a:xfrm>
+          <a:prstGeom prst="rect">
+            <a:avLst/>
+          </a:prstGeom>
+          <a:solidFill>
+            <a:srgbClr val="E6F4F1"/>
+          </a:solidFill>
+          <a:ln>
+            <a:noFill/>
+          </a:ln>
+          <a:effectLst/>
+        </p:spPr>
+        <p:style>
+          <a:lnRef idx="1">
+            <a:schemeClr val="accent1"/>
+          </a:lnRef>
+          <a:fillRef idx="3">
+            <a:schemeClr val="accent1"/>
+          </a:fillRef>
+          <a:effectRef idx="2">
+            <a:schemeClr val="accent1"/>
+          </a:effectRef>
+          <a:fontRef idx="minor">
+            <a:schemeClr val="lt1"/>
+          </a:fontRef>
+        </p:style>
+        <p:txBody>
+          <a:bodyPr rtlCol="0" anchor="ctr"/>
+          <a:lstStyle/>
+          <a:p>
+            <a:pPr algn="ctr"/>
+          </a:p>
+        </p:txBody>
+      </p:sp>
+      <p:sp>
+        <p:nvSpPr>
+          <p:cNvPr id="12" name="TextBox 11"/>
+          <p:cNvSpPr txBox="1"/>
+          <p:nvPr/>
+        </p:nvSpPr>
+        <p:spPr>
+          <a:xfrm>
+            <a:off x="12298680" y="2880360"/>
+            <a:ext cx="548640" cy="640080"/>
+          </a:xfrm>
+          <a:prstGeom prst="rect">
+            <a:avLst/>
+          </a:prstGeom>
+          <a:noFill/>
+        </p:spPr>
+        <p:txBody>
+          <a:bodyPr wrap="square" lIns="45720" rIns="45720" tIns="18288" bIns="18288" anchor="ctr">
+            <a:spAutoFit/>
+          </a:bodyPr>
+          <a:lstStyle/>
+          <a:p>
+            <a:pPr algn="l"/>
+            <a:r>
+              <a:rPr sz="1800" b="1">
+                <a:solidFill>
+                  <a:srgbClr val="16A34A"/>
+                </a:solidFill>
+                <a:latin typeface="Calibri"/>
+              </a:rPr>
+              <a:t>0</a:t>
+            </a:r>
+          </a:p>
+        </p:txBody>
+      </p:sp>
+      <p:sp>
+        <p:nvSpPr>
+          <p:cNvPr id="13" name="TextBox 12"/>
+          <p:cNvSpPr txBox="1"/>
+          <p:nvPr/>
+        </p:nvSpPr>
+        <p:spPr>
+          <a:xfrm>
+            <a:off x="6675120" y="3749040"/>
+            <a:ext cx="1280160" cy="640080"/>
+          </a:xfrm>
+          <a:prstGeom prst="rect">
+            <a:avLst/>
+          </a:prstGeom>
+          <a:noFill/>
+        </p:spPr>
+        <p:txBody>
+          <a:bodyPr wrap="square" lIns="45720" rIns="45720" tIns="18288" bIns="18288" anchor="ctr">
+            <a:spAutoFit/>
+          </a:bodyPr>
+          <a:lstStyle/>
+          <a:p>
+            <a:pPr algn="l"/>
+            <a:r>
+              <a:rPr sz="1200" b="1">
+                <a:solidFill>
+                  <a:srgbClr val="0F172A"/>
+                </a:solidFill>
+                <a:latin typeface="Calibri"/>
+              </a:rPr>
+              <a:t>Needs Impr</a:t>
+            </a:r>
+          </a:p>
+        </p:txBody>
+      </p:sp>
+      <p:sp>
+        <p:nvSpPr>
+          <p:cNvPr id="14" name="Rectangle 13"/>
+          <p:cNvSpPr/>
+          <p:nvPr/>
+        </p:nvSpPr>
+        <p:spPr>
+          <a:xfrm>
+            <a:off x="8046720" y="3886200"/>
+            <a:ext cx="4114800" cy="365760"/>
+          </a:xfrm>
+          <a:prstGeom prst="rect">
+            <a:avLst/>
+          </a:prstGeom>
+          <a:solidFill>
+            <a:srgbClr val="E6F4F1"/>
+          </a:solidFill>
+          <a:ln>
+            <a:noFill/>
+          </a:ln>
+          <a:effectLst/>
+        </p:spPr>
+        <p:style>
+          <a:lnRef idx="1">
+            <a:schemeClr val="accent1"/>
+          </a:lnRef>
+          <a:fillRef idx="3">
+            <a:schemeClr val="accent1"/>
+          </a:fillRef>
+          <a:effectRef idx="2">
+            <a:schemeClr val="accent1"/>
+          </a:effectRef>
+          <a:fontRef idx="minor">
+            <a:schemeClr val="lt1"/>
+          </a:fontRef>
+        </p:style>
+        <p:txBody>
+          <a:bodyPr rtlCol="0" anchor="ctr"/>
+          <a:lstStyle/>
+          <a:p>
+            <a:pPr algn="ctr"/>
+          </a:p>
+        </p:txBody>
+      </p:sp>
+      <p:sp>
+        <p:nvSpPr>
+          <p:cNvPr id="15" name="Rectangle 14"/>
+          <p:cNvSpPr/>
+          <p:nvPr/>
+        </p:nvSpPr>
+        <p:spPr>
+          <a:xfrm>
+            <a:off x="8046720" y="3886200"/>
+            <a:ext cx="1234440" cy="365760"/>
           </a:xfrm>
           <a:prstGeom prst="rect">
             <a:avLst/>
@@ -7187,14 +7369,14 @@
       </p:sp>
       <p:sp>
         <p:nvSpPr>
-          <p:cNvPr id="8" name="TextBox 7"/>
+          <p:cNvPr id="16" name="TextBox 15"/>
           <p:cNvSpPr txBox="1"/>
           <p:nvPr/>
         </p:nvSpPr>
         <p:spPr>
           <a:xfrm>
-            <a:off x="640080" y="5760720"/>
-            <a:ext cx="10972800" cy="457200"/>
+            <a:off x="12298680" y="3749040"/>
+            <a:ext cx="548640" cy="640080"/>
           </a:xfrm>
           <a:prstGeom prst="rect">
             <a:avLst/>
@@ -7209,27 +7391,62 @@
           <a:p>
             <a:pPr algn="l"/>
             <a:r>
-              <a:rPr sz="1300" b="1">
+              <a:rPr sz="1800" b="1">
                 <a:solidFill>
                   <a:srgbClr val="B45309"/>
                 </a:solidFill>
                 <a:latin typeface="Calibri"/>
               </a:rPr>
-              <a:t>⚠  Zero providers reached Meets Expectations or Excellent — this is a program-level signal.</a:t>
-            </a:r>
-          </a:p>
-        </p:txBody>
-      </p:sp>
-      <p:sp>
-        <p:nvSpPr>
-          <p:cNvPr id="9" name="Rectangle 8"/>
+              <a:t>3</a:t>
+            </a:r>
+          </a:p>
+        </p:txBody>
+      </p:sp>
+      <p:sp>
+        <p:nvSpPr>
+          <p:cNvPr id="17" name="TextBox 16"/>
+          <p:cNvSpPr txBox="1"/>
+          <p:nvPr/>
+        </p:nvSpPr>
+        <p:spPr>
+          <a:xfrm>
+            <a:off x="6675120" y="4617720"/>
+            <a:ext cx="1280160" cy="640080"/>
+          </a:xfrm>
+          <a:prstGeom prst="rect">
+            <a:avLst/>
+          </a:prstGeom>
+          <a:noFill/>
+        </p:spPr>
+        <p:txBody>
+          <a:bodyPr wrap="square" lIns="45720" rIns="45720" tIns="18288" bIns="18288" anchor="ctr">
+            <a:spAutoFit/>
+          </a:bodyPr>
+          <a:lstStyle/>
+          <a:p>
+            <a:pPr algn="l"/>
+            <a:r>
+              <a:rPr sz="1200" b="1">
+                <a:solidFill>
+                  <a:srgbClr val="0F172A"/>
+                </a:solidFill>
+                <a:latin typeface="Calibri"/>
+              </a:rPr>
+              <a:t>Corrective</a:t>
+            </a:r>
+          </a:p>
+        </p:txBody>
+      </p:sp>
+      <p:sp>
+        <p:nvSpPr>
+          <p:cNvPr id="18" name="Rectangle 17"/>
           <p:cNvSpPr/>
           <p:nvPr/>
         </p:nvSpPr>
         <p:spPr>
           <a:xfrm>
-            <a:off x="0" y="6537960"/>
-            <a:ext cx="12188952" cy="320040"/>
+            <a:off x="8046720" y="4754880"/>
+            <a:ext cx="4114800" cy="365760"/>
           </a:xfrm>
           <a:prstGeom prst="rect">
             <a:avLst/>
@@ -7266,7 +7483,209 @@
       </p:sp>
       <p:sp>
         <p:nvSpPr>
-          <p:cNvPr id="10" name="TextBox 9"/>
+          <p:cNvPr id="19" name="Rectangle 18"/>
+          <p:cNvSpPr/>
+          <p:nvPr/>
+        </p:nvSpPr>
+        <p:spPr>
+          <a:xfrm>
+            <a:off x="8046720" y="4754880"/>
+            <a:ext cx="4114800" cy="365760"/>
+          </a:xfrm>
+          <a:prstGeom prst="rect">
+            <a:avLst/>
+          </a:prstGeom>
+          <a:solidFill>
+            <a:srgbClr val="F8C9C9"/>
+          </a:solidFill>
+          <a:ln>
+            <a:noFill/>
+          </a:ln>
+          <a:effectLst/>
+        </p:spPr>
+        <p:style>
+          <a:lnRef idx="1">
+            <a:schemeClr val="accent1"/>
+          </a:lnRef>
+          <a:fillRef idx="3">
+            <a:schemeClr val="accent1"/>
+          </a:fillRef>
+          <a:effectRef idx="2">
+            <a:schemeClr val="accent1"/>
+          </a:effectRef>
+          <a:fontRef idx="minor">
+            <a:schemeClr val="lt1"/>
+          </a:fontRef>
+        </p:style>
+        <p:txBody>
+          <a:bodyPr rtlCol="0" anchor="ctr"/>
+          <a:lstStyle/>
+          <a:p>
+            <a:pPr algn="ctr"/>
+          </a:p>
+        </p:txBody>
+      </p:sp>
+      <p:sp>
+        <p:nvSpPr>
+          <p:cNvPr id="20" name="TextBox 19"/>
+          <p:cNvSpPr txBox="1"/>
+          <p:nvPr/>
+        </p:nvSpPr>
+        <p:spPr>
+          <a:xfrm>
+            <a:off x="12298680" y="4617720"/>
+            <a:ext cx="548640" cy="640080"/>
+          </a:xfrm>
+          <a:prstGeom prst="rect">
+            <a:avLst/>
+          </a:prstGeom>
+          <a:noFill/>
+        </p:spPr>
+        <p:txBody>
+          <a:bodyPr wrap="square" lIns="45720" rIns="45720" tIns="18288" bIns="18288" anchor="ctr">
+            <a:spAutoFit/>
+          </a:bodyPr>
+          <a:lstStyle/>
+          <a:p>
+            <a:pPr algn="l"/>
+            <a:r>
+              <a:rPr sz="1800" b="1">
+                <a:solidFill>
+                  <a:srgbClr val="B02424"/>
+                </a:solidFill>
+                <a:latin typeface="Calibri"/>
+              </a:rPr>
+              <a:t>10</a:t>
+            </a:r>
+          </a:p>
+        </p:txBody>
+      </p:sp>
+      <p:sp>
+        <p:nvSpPr>
+          <p:cNvPr id="21" name="Rectangle 20"/>
+          <p:cNvSpPr/>
+          <p:nvPr/>
+        </p:nvSpPr>
+        <p:spPr>
+          <a:xfrm>
+            <a:off x="457200" y="5669280"/>
+            <a:ext cx="11338560" cy="640080"/>
+          </a:xfrm>
+          <a:prstGeom prst="rect">
+            <a:avLst/>
+          </a:prstGeom>
+          <a:solidFill>
+            <a:srgbClr val="FDE9C0"/>
+          </a:solidFill>
+          <a:ln>
+            <a:noFill/>
+          </a:ln>
+          <a:effectLst/>
+        </p:spPr>
+        <p:style>
+          <a:lnRef idx="1">
+            <a:schemeClr val="accent1"/>
+          </a:lnRef>
+          <a:fillRef idx="3">
+            <a:schemeClr val="accent1"/>
+          </a:fillRef>
+          <a:effectRef idx="2">
+            <a:schemeClr val="accent1"/>
+          </a:effectRef>
+          <a:fontRef idx="minor">
+            <a:schemeClr val="lt1"/>
+          </a:fontRef>
+        </p:style>
+        <p:txBody>
+          <a:bodyPr rtlCol="0" anchor="ctr"/>
+          <a:lstStyle/>
+          <a:p>
+            <a:pPr algn="ctr"/>
+          </a:p>
+        </p:txBody>
+      </p:sp>
+      <p:sp>
+        <p:nvSpPr>
+          <p:cNvPr id="22" name="TextBox 21"/>
+          <p:cNvSpPr txBox="1"/>
+          <p:nvPr/>
+        </p:nvSpPr>
+        <p:spPr>
+          <a:xfrm>
+            <a:off x="640080" y="5760720"/>
+            <a:ext cx="10972800" cy="457200"/>
+          </a:xfrm>
+          <a:prstGeom prst="rect">
+            <a:avLst/>
+          </a:prstGeom>
+          <a:noFill/>
+        </p:spPr>
+        <p:txBody>
+          <a:bodyPr wrap="square" lIns="45720" rIns="45720" tIns="18288" bIns="18288" anchor="ctr">
+            <a:spAutoFit/>
+          </a:bodyPr>
+          <a:lstStyle/>
+          <a:p>
+            <a:pPr algn="l"/>
+            <a:r>
+              <a:rPr sz="1300" b="1">
+                <a:solidFill>
+                  <a:srgbClr val="B45309"/>
+                </a:solidFill>
+                <a:latin typeface="Calibri"/>
+              </a:rPr>
+              <a:t>Zero providers reached Meets Expectations or Excellent - this is a program-level signal.</a:t>
+            </a:r>
+          </a:p>
+        </p:txBody>
+      </p:sp>
+      <p:sp>
+        <p:nvSpPr>
+          <p:cNvPr id="23" name="Rectangle 22"/>
+          <p:cNvSpPr/>
+          <p:nvPr/>
+        </p:nvSpPr>
+        <p:spPr>
+          <a:xfrm>
+            <a:off x="0" y="6537960"/>
+            <a:ext cx="12188952" cy="320040"/>
+          </a:xfrm>
+          <a:prstGeom prst="rect">
+            <a:avLst/>
+          </a:prstGeom>
+          <a:solidFill>
+            <a:srgbClr val="E6F4F1"/>
+          </a:solidFill>
+          <a:ln>
+            <a:noFill/>
+          </a:ln>
+          <a:effectLst/>
+        </p:spPr>
+        <p:style>
+          <a:lnRef idx="1">
+            <a:schemeClr val="accent1"/>
+          </a:lnRef>
+          <a:fillRef idx="3">
+            <a:schemeClr val="accent1"/>
+          </a:fillRef>
+          <a:effectRef idx="2">
+            <a:schemeClr val="accent1"/>
+          </a:effectRef>
+          <a:fontRef idx="minor">
+            <a:schemeClr val="lt1"/>
+          </a:fontRef>
+        </p:style>
+        <p:txBody>
+          <a:bodyPr rtlCol="0" anchor="ctr"/>
+          <a:lstStyle/>
+          <a:p>
+            <a:pPr algn="ctr"/>
+          </a:p>
+        </p:txBody>
+      </p:sp>
+      <p:sp>
+        <p:nvSpPr>
+          <p:cNvPr id="24" name="TextBox 23"/>
           <p:cNvSpPr txBox="1"/>
           <p:nvPr/>
         </p:nvSpPr>
@@ -7294,14 +7713,14 @@
                 </a:solidFill>
                 <a:latin typeface="Calibri"/>
               </a:rPr>
-              <a:t>HealthProMed · Q3 2026 Provider Audit Report</a:t>
-            </a:r>
-          </a:p>
-        </p:txBody>
-      </p:sp>
-      <p:sp>
-        <p:nvSpPr>
-          <p:cNvPr id="11" name="TextBox 10"/>
+              <a:t>HealthProMed - Q3 2026 Provider Audit Report</a:t>
+            </a:r>
+          </a:p>
+        </p:txBody>
+      </p:sp>
+      <p:sp>
+        <p:nvSpPr>
+          <p:cNvPr id="25" name="TextBox 24"/>
           <p:cNvSpPr txBox="1"/>
           <p:nvPr/>
         </p:nvSpPr>
@@ -7461,7 +7880,7 @@
                 </a:solidFill>
                 <a:latin typeface="Calibri"/>
               </a:rPr>
-              <a:t>Highest → lowest compliance % · color-coded by band</a:t>
+              <a:t>Highest to lowest compliance % - color-coded by band</a:t>
             </a:r>
           </a:p>
         </p:txBody>
@@ -7475,8 +7894,8 @@
           <p:nvPr/>
         </p:nvGraphicFramePr>
         <p:xfrm>
-          <a:off x="365760" y="1280160"/>
-          <a:ext cx="11430000" cy="5029200"/>
+          <a:off x="365760" y="1188720"/>
+          <a:ext cx="11430000" cy="5212080"/>
         </p:xfrm>
         <a:graphic>
           <a:graphicData uri="http://schemas.openxmlformats.org/drawingml/2006/table">
@@ -7491,7 +7910,7 @@
                 <a:gridCol w="1371600"/>
                 <a:gridCol w="3429000"/>
               </a:tblGrid>
-              <a:tr h="386861">
+              <a:tr h="372291">
                 <a:tc>
                   <a:txBody>
                     <a:bodyPr wrap="square"/>
@@ -7608,7 +8027,7 @@
                   </a:tcPr>
                 </a:tc>
               </a:tr>
-              <a:tr h="386861">
+              <a:tr h="372291">
                 <a:tc>
                   <a:txBody>
                     <a:bodyPr wrap="square" lIns="54864" rIns="54864" tIns="27432" bIns="27432"/>
@@ -7616,7 +8035,7 @@
                     <a:p>
                       <a:pPr algn="l"/>
                       <a:r>
-                        <a:rPr sz="1000">
+                        <a:rPr sz="950">
                           <a:solidFill>
                             <a:srgbClr val="0F172A"/>
                           </a:solidFill>
@@ -7639,7 +8058,7 @@
                     <a:p>
                       <a:pPr algn="l"/>
                       <a:r>
-                        <a:rPr sz="1000">
+                        <a:rPr sz="950">
                           <a:solidFill>
                             <a:srgbClr val="0F172A"/>
                           </a:solidFill>
@@ -7662,7 +8081,7 @@
                     <a:p>
                       <a:pPr algn="l"/>
                       <a:r>
-                        <a:rPr sz="1000">
+                        <a:rPr sz="950">
                           <a:solidFill>
                             <a:srgbClr val="0F172A"/>
                           </a:solidFill>
@@ -7685,7 +8104,7 @@
                     <a:p>
                       <a:pPr algn="l"/>
                       <a:r>
-                        <a:rPr sz="1000">
+                        <a:rPr sz="950">
                           <a:solidFill>
                             <a:srgbClr val="0F172A"/>
                           </a:solidFill>
@@ -7708,7 +8127,7 @@
                     <a:p>
                       <a:pPr algn="l"/>
                       <a:r>
-                        <a:rPr sz="1000">
+                        <a:rPr sz="950">
                           <a:solidFill>
                             <a:srgbClr val="0F172A"/>
                           </a:solidFill>
@@ -7725,7 +8144,7 @@
                   </a:tcPr>
                 </a:tc>
               </a:tr>
-              <a:tr h="386861">
+              <a:tr h="372291">
                 <a:tc>
                   <a:txBody>
                     <a:bodyPr wrap="square" lIns="54864" rIns="54864" tIns="27432" bIns="27432"/>
@@ -7733,7 +8152,7 @@
                     <a:p>
                       <a:pPr algn="l"/>
                       <a:r>
-                        <a:rPr sz="1000">
+                        <a:rPr sz="950">
                           <a:solidFill>
                             <a:srgbClr val="0F172A"/>
                           </a:solidFill>
@@ -7756,7 +8175,7 @@
                     <a:p>
                       <a:pPr algn="l"/>
                       <a:r>
-                        <a:rPr sz="1000">
+                        <a:rPr sz="950">
                           <a:solidFill>
                             <a:srgbClr val="0F172A"/>
                           </a:solidFill>
@@ -7779,7 +8198,7 @@
                     <a:p>
                       <a:pPr algn="l"/>
                       <a:r>
-                        <a:rPr sz="1000">
+                        <a:rPr sz="950">
                           <a:solidFill>
                             <a:srgbClr val="0F172A"/>
                           </a:solidFill>
@@ -7802,7 +8221,7 @@
                     <a:p>
                       <a:pPr algn="l"/>
                       <a:r>
-                        <a:rPr sz="1000">
+                        <a:rPr sz="950">
                           <a:solidFill>
                             <a:srgbClr val="0F172A"/>
                           </a:solidFill>
@@ -7825,7 +8244,7 @@
                     <a:p>
                       <a:pPr algn="l"/>
                       <a:r>
-                        <a:rPr sz="1000">
+                        <a:rPr sz="950">
                           <a:solidFill>
                             <a:srgbClr val="0F172A"/>
                           </a:solidFill>
@@ -7842,7 +8261,7 @@
                   </a:tcPr>
                 </a:tc>
               </a:tr>
-              <a:tr h="386861">
+              <a:tr h="372291">
                 <a:tc>
                   <a:txBody>
                     <a:bodyPr wrap="square" lIns="54864" rIns="54864" tIns="27432" bIns="27432"/>
@@ -7850,7 +8269,7 @@
                     <a:p>
                       <a:pPr algn="l"/>
                       <a:r>
-                        <a:rPr sz="1000">
+                        <a:rPr sz="950">
                           <a:solidFill>
                             <a:srgbClr val="0F172A"/>
                           </a:solidFill>
@@ -7873,7 +8292,7 @@
                     <a:p>
                       <a:pPr algn="l"/>
                       <a:r>
-                        <a:rPr sz="1000">
+                        <a:rPr sz="950">
                           <a:solidFill>
                             <a:srgbClr val="0F172A"/>
                           </a:solidFill>
@@ -7896,7 +8315,7 @@
                     <a:p>
                       <a:pPr algn="l"/>
                       <a:r>
-                        <a:rPr sz="1000">
+                        <a:rPr sz="950">
                           <a:solidFill>
                             <a:srgbClr val="0F172A"/>
                           </a:solidFill>
@@ -7919,7 +8338,7 @@
                     <a:p>
                       <a:pPr algn="l"/>
                       <a:r>
-                        <a:rPr sz="1000">
+                        <a:rPr sz="950">
                           <a:solidFill>
                             <a:srgbClr val="0F172A"/>
                           </a:solidFill>
@@ -7942,7 +8361,7 @@
                     <a:p>
                       <a:pPr algn="l"/>
                       <a:r>
-                        <a:rPr sz="1000">
+                        <a:rPr sz="950">
                           <a:solidFill>
                             <a:srgbClr val="0F172A"/>
                           </a:solidFill>
@@ -7959,7 +8378,7 @@
                   </a:tcPr>
                 </a:tc>
               </a:tr>
-              <a:tr h="386861">
+              <a:tr h="372291">
                 <a:tc>
                   <a:txBody>
                     <a:bodyPr wrap="square" lIns="54864" rIns="54864" tIns="27432" bIns="27432"/>
@@ -7967,7 +8386,7 @@
                     <a:p>
                       <a:pPr algn="l"/>
                       <a:r>
-                        <a:rPr sz="1000">
+                        <a:rPr sz="950">
                           <a:solidFill>
                             <a:srgbClr val="0F172A"/>
                           </a:solidFill>
@@ -7990,7 +8409,7 @@
                     <a:p>
                       <a:pPr algn="l"/>
                       <a:r>
-                        <a:rPr sz="1000">
+                        <a:rPr sz="950">
                           <a:solidFill>
                             <a:srgbClr val="0F172A"/>
                           </a:solidFill>
@@ -8013,7 +8432,7 @@
                     <a:p>
                       <a:pPr algn="l"/>
                       <a:r>
-                        <a:rPr sz="1000">
+                        <a:rPr sz="950">
                           <a:solidFill>
                             <a:srgbClr val="0F172A"/>
                           </a:solidFill>
@@ -8036,7 +8455,7 @@
                     <a:p>
                       <a:pPr algn="l"/>
                       <a:r>
-                        <a:rPr sz="1000">
+                        <a:rPr sz="950">
                           <a:solidFill>
                             <a:srgbClr val="0F172A"/>
                           </a:solidFill>
@@ -8059,7 +8478,7 @@
                     <a:p>
                       <a:pPr algn="l"/>
                       <a:r>
-                        <a:rPr sz="1000">
+                        <a:rPr sz="950">
                           <a:solidFill>
                             <a:srgbClr val="0F172A"/>
                           </a:solidFill>
@@ -8076,7 +8495,7 @@
                   </a:tcPr>
                 </a:tc>
               </a:tr>
-              <a:tr h="386861">
+              <a:tr h="372291">
                 <a:tc>
                   <a:txBody>
                     <a:bodyPr wrap="square" lIns="54864" rIns="54864" tIns="27432" bIns="27432"/>
@@ -8084,7 +8503,7 @@
                     <a:p>
                       <a:pPr algn="l"/>
                       <a:r>
-                        <a:rPr sz="1000">
+                        <a:rPr sz="950">
                           <a:solidFill>
                             <a:srgbClr val="0F172A"/>
                           </a:solidFill>
@@ -8107,7 +8526,7 @@
                     <a:p>
                       <a:pPr algn="l"/>
                       <a:r>
-                        <a:rPr sz="1000">
+                        <a:rPr sz="950">
                           <a:solidFill>
                             <a:srgbClr val="0F172A"/>
                           </a:solidFill>
@@ -8130,7 +8549,7 @@
                     <a:p>
                       <a:pPr algn="l"/>
                       <a:r>
-                        <a:rPr sz="1000">
+                        <a:rPr sz="950">
                           <a:solidFill>
                             <a:srgbClr val="0F172A"/>
                           </a:solidFill>
@@ -8153,7 +8572,7 @@
                     <a:p>
                       <a:pPr algn="l"/>
                       <a:r>
-                        <a:rPr sz="1000">
+                        <a:rPr sz="950">
                           <a:solidFill>
                             <a:srgbClr val="0F172A"/>
                           </a:solidFill>
@@ -8176,7 +8595,7 @@
                     <a:p>
                       <a:pPr algn="l"/>
                       <a:r>
-                        <a:rPr sz="1000">
+                        <a:rPr sz="950">
                           <a:solidFill>
                             <a:srgbClr val="0F172A"/>
                           </a:solidFill>
@@ -8193,7 +8612,7 @@
                   </a:tcPr>
                 </a:tc>
               </a:tr>
-              <a:tr h="386861">
+              <a:tr h="372291">
                 <a:tc>
                   <a:txBody>
                     <a:bodyPr wrap="square" lIns="54864" rIns="54864" tIns="27432" bIns="27432"/>
@@ -8201,7 +8620,7 @@
                     <a:p>
                       <a:pPr algn="l"/>
                       <a:r>
-                        <a:rPr sz="1000">
+                        <a:rPr sz="950">
                           <a:solidFill>
                             <a:srgbClr val="0F172A"/>
                           </a:solidFill>
@@ -8224,7 +8643,7 @@
                     <a:p>
                       <a:pPr algn="l"/>
                       <a:r>
-                        <a:rPr sz="1000">
+                        <a:rPr sz="950">
                           <a:solidFill>
                             <a:srgbClr val="0F172A"/>
                           </a:solidFill>
@@ -8247,7 +8666,7 @@
                     <a:p>
                       <a:pPr algn="l"/>
                       <a:r>
-                        <a:rPr sz="1000">
+                        <a:rPr sz="950">
                           <a:solidFill>
                             <a:srgbClr val="0F172A"/>
                           </a:solidFill>
@@ -8270,7 +8689,7 @@
                     <a:p>
                       <a:pPr algn="l"/>
                       <a:r>
-                        <a:rPr sz="1000">
+                        <a:rPr sz="950">
                           <a:solidFill>
                             <a:srgbClr val="0F172A"/>
                           </a:solidFill>
@@ -8293,7 +8712,7 @@
                     <a:p>
                       <a:pPr algn="l"/>
                       <a:r>
-                        <a:rPr sz="1000">
+                        <a:rPr sz="950">
                           <a:solidFill>
                             <a:srgbClr val="0F172A"/>
                           </a:solidFill>
@@ -8310,7 +8729,7 @@
                   </a:tcPr>
                 </a:tc>
               </a:tr>
-              <a:tr h="386861">
+              <a:tr h="372291">
                 <a:tc>
                   <a:txBody>
                     <a:bodyPr wrap="square" lIns="54864" rIns="54864" tIns="27432" bIns="27432"/>
@@ -8318,7 +8737,7 @@
                     <a:p>
                       <a:pPr algn="l"/>
                       <a:r>
-                        <a:rPr sz="1000">
+                        <a:rPr sz="950">
                           <a:solidFill>
                             <a:srgbClr val="0F172A"/>
                           </a:solidFill>
@@ -8341,7 +8760,7 @@
                     <a:p>
                       <a:pPr algn="l"/>
                       <a:r>
-                        <a:rPr sz="1000">
+                        <a:rPr sz="950">
                           <a:solidFill>
                             <a:srgbClr val="0F172A"/>
                           </a:solidFill>
@@ -8364,7 +8783,7 @@
                     <a:p>
                       <a:pPr algn="l"/>
                       <a:r>
-                        <a:rPr sz="1000">
+                        <a:rPr sz="950">
                           <a:solidFill>
                             <a:srgbClr val="0F172A"/>
                           </a:solidFill>
@@ -8387,7 +8806,7 @@
                     <a:p>
                       <a:pPr algn="l"/>
                       <a:r>
-                        <a:rPr sz="1000">
+                        <a:rPr sz="950">
                           <a:solidFill>
                             <a:srgbClr val="0F172A"/>
                           </a:solidFill>
@@ -8410,7 +8829,7 @@
                     <a:p>
                       <a:pPr algn="l"/>
                       <a:r>
-                        <a:rPr sz="1000">
+                        <a:rPr sz="950">
                           <a:solidFill>
                             <a:srgbClr val="0F172A"/>
                           </a:solidFill>
@@ -8427,7 +8846,7 @@
                   </a:tcPr>
                 </a:tc>
               </a:tr>
-              <a:tr h="386861">
+              <a:tr h="372291">
                 <a:tc>
                   <a:txBody>
                     <a:bodyPr wrap="square" lIns="54864" rIns="54864" tIns="27432" bIns="27432"/>
@@ -8435,7 +8854,7 @@
                     <a:p>
                       <a:pPr algn="l"/>
                       <a:r>
-                        <a:rPr sz="1000">
+                        <a:rPr sz="950">
                           <a:solidFill>
                             <a:srgbClr val="0F172A"/>
                           </a:solidFill>
@@ -8458,7 +8877,7 @@
                     <a:p>
                       <a:pPr algn="l"/>
                       <a:r>
-                        <a:rPr sz="1000">
+                        <a:rPr sz="950">
                           <a:solidFill>
                             <a:srgbClr val="0F172A"/>
                           </a:solidFill>
@@ -8481,7 +8900,7 @@
                     <a:p>
                       <a:pPr algn="l"/>
                       <a:r>
-                        <a:rPr sz="1000">
+                        <a:rPr sz="950">
                           <a:solidFill>
                             <a:srgbClr val="0F172A"/>
                           </a:solidFill>
@@ -8504,7 +8923,7 @@
                     <a:p>
                       <a:pPr algn="l"/>
                       <a:r>
-                        <a:rPr sz="1000">
+                        <a:rPr sz="950">
                           <a:solidFill>
                             <a:srgbClr val="0F172A"/>
                           </a:solidFill>
@@ -8527,7 +8946,7 @@
                     <a:p>
                       <a:pPr algn="l"/>
                       <a:r>
-                        <a:rPr sz="1000">
+                        <a:rPr sz="950">
                           <a:solidFill>
                             <a:srgbClr val="0F172A"/>
                           </a:solidFill>
@@ -8544,7 +8963,7 @@
                   </a:tcPr>
                 </a:tc>
               </a:tr>
-              <a:tr h="386861">
+              <a:tr h="372291">
                 <a:tc>
                   <a:txBody>
                     <a:bodyPr wrap="square" lIns="54864" rIns="54864" tIns="27432" bIns="27432"/>
@@ -8552,7 +8971,7 @@
                     <a:p>
                       <a:pPr algn="l"/>
                       <a:r>
-                        <a:rPr sz="1000">
+                        <a:rPr sz="950">
                           <a:solidFill>
                             <a:srgbClr val="0F172A"/>
                           </a:solidFill>
@@ -8575,7 +8994,7 @@
                     <a:p>
                       <a:pPr algn="l"/>
                       <a:r>
-                        <a:rPr sz="1000">
+                        <a:rPr sz="950">
                           <a:solidFill>
                             <a:srgbClr val="0F172A"/>
                           </a:solidFill>
@@ -8598,7 +9017,7 @@
                     <a:p>
                       <a:pPr algn="l"/>
                       <a:r>
-                        <a:rPr sz="1000">
+                        <a:rPr sz="950">
                           <a:solidFill>
                             <a:srgbClr val="0F172A"/>
                           </a:solidFill>
@@ -8621,7 +9040,7 @@
                     <a:p>
                       <a:pPr algn="l"/>
                       <a:r>
-                        <a:rPr sz="1000">
+                        <a:rPr sz="950">
                           <a:solidFill>
                             <a:srgbClr val="0F172A"/>
                           </a:solidFill>
@@ -8644,7 +9063,7 @@
                     <a:p>
                       <a:pPr algn="l"/>
                       <a:r>
-                        <a:rPr sz="1000">
+                        <a:rPr sz="950">
                           <a:solidFill>
                             <a:srgbClr val="0F172A"/>
                           </a:solidFill>
@@ -8661,7 +9080,7 @@
                   </a:tcPr>
                 </a:tc>
               </a:tr>
-              <a:tr h="386861">
+              <a:tr h="372291">
                 <a:tc>
                   <a:txBody>
                     <a:bodyPr wrap="square" lIns="54864" rIns="54864" tIns="27432" bIns="27432"/>
@@ -8669,7 +9088,7 @@
                     <a:p>
                       <a:pPr algn="l"/>
                       <a:r>
-                        <a:rPr sz="1000">
+                        <a:rPr sz="950">
                           <a:solidFill>
                             <a:srgbClr val="0F172A"/>
                           </a:solidFill>
@@ -8692,7 +9111,7 @@
                     <a:p>
                       <a:pPr algn="l"/>
                       <a:r>
-                        <a:rPr sz="1000">
+                        <a:rPr sz="950">
                           <a:solidFill>
                             <a:srgbClr val="0F172A"/>
                           </a:solidFill>
@@ -8715,7 +9134,7 @@
                     <a:p>
                       <a:pPr algn="l"/>
                       <a:r>
-                        <a:rPr sz="1000">
+                        <a:rPr sz="950">
                           <a:solidFill>
                             <a:srgbClr val="0F172A"/>
                           </a:solidFill>
@@ -8738,7 +9157,7 @@
                     <a:p>
                       <a:pPr algn="l"/>
                       <a:r>
-                        <a:rPr sz="1000">
+                        <a:rPr sz="950">
                           <a:solidFill>
                             <a:srgbClr val="0F172A"/>
                           </a:solidFill>
@@ -8761,7 +9180,7 @@
                     <a:p>
                       <a:pPr algn="l"/>
                       <a:r>
-                        <a:rPr sz="1000">
+                        <a:rPr sz="950">
                           <a:solidFill>
                             <a:srgbClr val="0F172A"/>
                           </a:solidFill>
@@ -8778,7 +9197,7 @@
                   </a:tcPr>
                 </a:tc>
               </a:tr>
-              <a:tr h="386861">
+              <a:tr h="372291">
                 <a:tc>
                   <a:txBody>
                     <a:bodyPr wrap="square" lIns="54864" rIns="54864" tIns="27432" bIns="27432"/>
@@ -8786,7 +9205,7 @@
                     <a:p>
                       <a:pPr algn="l"/>
                       <a:r>
-                        <a:rPr sz="1000">
+                        <a:rPr sz="950">
                           <a:solidFill>
                             <a:srgbClr val="0F172A"/>
                           </a:solidFill>
@@ -8809,12 +9228,129 @@
                     <a:p>
                       <a:pPr algn="l"/>
                       <a:r>
-                        <a:rPr sz="1000">
+                        <a:rPr sz="950">
                           <a:solidFill>
                             <a:srgbClr val="0F172A"/>
                           </a:solidFill>
                           <a:latin typeface="Calibri"/>
                         </a:rPr>
+                        <a:t>Alejandra Velez Alicea, MD</a:t>
+                      </a:r>
+                    </a:p>
+                  </a:txBody>
+                  <a:tcPr>
+                    <a:solidFill>
+                      <a:srgbClr val="F8C9C9"/>
+                    </a:solidFill>
+                  </a:tcPr>
+                </a:tc>
+                <a:tc>
+                  <a:txBody>
+                    <a:bodyPr wrap="square" lIns="54864" rIns="54864" tIns="27432" bIns="27432"/>
+                    <a:lstStyle/>
+                    <a:p>
+                      <a:pPr algn="l"/>
+                      <a:r>
+                        <a:rPr sz="950">
+                          <a:solidFill>
+                            <a:srgbClr val="0F172A"/>
+                          </a:solidFill>
+                          <a:latin typeface="Calibri"/>
+                        </a:rPr>
+                        <a:t>MMM Vital</a:t>
+                      </a:r>
+                    </a:p>
+                  </a:txBody>
+                  <a:tcPr>
+                    <a:solidFill>
+                      <a:srgbClr val="F8C9C9"/>
+                    </a:solidFill>
+                  </a:tcPr>
+                </a:tc>
+                <a:tc>
+                  <a:txBody>
+                    <a:bodyPr wrap="square" lIns="54864" rIns="54864" tIns="27432" bIns="27432"/>
+                    <a:lstStyle/>
+                    <a:p>
+                      <a:pPr algn="l"/>
+                      <a:r>
+                        <a:rPr sz="950">
+                          <a:solidFill>
+                            <a:srgbClr val="0F172A"/>
+                          </a:solidFill>
+                          <a:latin typeface="Calibri"/>
+                        </a:rPr>
+                        <a:t>72.9%</a:t>
+                      </a:r>
+                    </a:p>
+                  </a:txBody>
+                  <a:tcPr>
+                    <a:solidFill>
+                      <a:srgbClr val="F8C9C9"/>
+                    </a:solidFill>
+                  </a:tcPr>
+                </a:tc>
+                <a:tc>
+                  <a:txBody>
+                    <a:bodyPr wrap="square" lIns="54864" rIns="54864" tIns="27432" bIns="27432"/>
+                    <a:lstStyle/>
+                    <a:p>
+                      <a:pPr algn="l"/>
+                      <a:r>
+                        <a:rPr sz="950">
+                          <a:solidFill>
+                            <a:srgbClr val="0F172A"/>
+                          </a:solidFill>
+                          <a:latin typeface="Calibri"/>
+                        </a:rPr>
+                        <a:t>Corrective Education Required</a:t>
+                      </a:r>
+                    </a:p>
+                  </a:txBody>
+                  <a:tcPr>
+                    <a:solidFill>
+                      <a:srgbClr val="F8C9C9"/>
+                    </a:solidFill>
+                  </a:tcPr>
+                </a:tc>
+              </a:tr>
+              <a:tr h="372291">
+                <a:tc>
+                  <a:txBody>
+                    <a:bodyPr wrap="square" lIns="54864" rIns="54864" tIns="27432" bIns="27432"/>
+                    <a:lstStyle/>
+                    <a:p>
+                      <a:pPr algn="l"/>
+                      <a:r>
+                        <a:rPr sz="950">
+                          <a:solidFill>
+                            <a:srgbClr val="0F172A"/>
+                          </a:solidFill>
+                          <a:latin typeface="Calibri"/>
+                        </a:rPr>
+                        <a:t>12</a:t>
+                      </a:r>
+                    </a:p>
+                  </a:txBody>
+                  <a:tcPr>
+                    <a:solidFill>
+                      <a:srgbClr val="F8C9C9"/>
+                    </a:solidFill>
+                  </a:tcPr>
+                </a:tc>
+                <a:tc>
+                  <a:txBody>
+                    <a:bodyPr wrap="square" lIns="54864" rIns="54864" tIns="27432" bIns="27432"/>
+                    <a:lstStyle/>
+                    <a:p>
+                      <a:pPr algn="l"/>
+                      <a:r>
+                        <a:rPr sz="950">
+                          <a:solidFill>
+                            <a:srgbClr val="0F172A"/>
+                          </a:solidFill>
+                          <a:latin typeface="Calibri"/>
+                        </a:rPr>
                         <a:t>Yolis Guerrero del Rio, MD</a:t>
                       </a:r>
                     </a:p>
@@ -8832,7 +9368,7 @@
                     <a:p>
                       <a:pPr algn="l"/>
                       <a:r>
-                        <a:rPr sz="1000">
+                        <a:rPr sz="950">
                           <a:solidFill>
                             <a:srgbClr val="0F172A"/>
                           </a:solidFill>
@@ -8855,7 +9391,7 @@
                     <a:p>
                       <a:pPr algn="l"/>
                       <a:r>
-                        <a:rPr sz="1000">
+                        <a:rPr sz="950">
                           <a:solidFill>
                             <a:srgbClr val="0F172A"/>
                           </a:solidFill>
@@ -8878,7 +9414,7 @@
                     <a:p>
                       <a:pPr algn="l"/>
                       <a:r>
-                        <a:rPr sz="1000">
+                        <a:rPr sz="950">
                           <a:solidFill>
                             <a:srgbClr val="0F172A"/>
                           </a:solidFill>
@@ -8895,7 +9431,7 @@
                   </a:tcPr>
                 </a:tc>
               </a:tr>
-              <a:tr h="386868">
+              <a:tr h="372297">
                 <a:tc>
                   <a:txBody>
                     <a:bodyPr wrap="square" lIns="54864" rIns="54864" tIns="27432" bIns="27432"/>
@@ -8903,13 +9439,13 @@
                     <a:p>
                       <a:pPr algn="l"/>
                       <a:r>
-                        <a:rPr sz="1000">
+                        <a:rPr sz="950">
                           <a:solidFill>
                             <a:srgbClr val="0F172A"/>
                           </a:solidFill>
                           <a:latin typeface="Calibri"/>
                         </a:rPr>
-                        <a:t>12</a:t>
+                        <a:t>13</a:t>
                       </a:r>
                     </a:p>
                   </a:txBody>
@@ -8926,7 +9462,7 @@
                     <a:p>
                       <a:pPr algn="l"/>
                       <a:r>
-                        <a:rPr sz="1000">
+                        <a:rPr sz="950">
                           <a:solidFill>
                             <a:srgbClr val="0F172A"/>
                           </a:solidFill>
@@ -8949,7 +9485,7 @@
                     <a:p>
                       <a:pPr algn="l"/>
                       <a:r>
-                        <a:rPr sz="1000">
+                        <a:rPr sz="950">
                           <a:solidFill>
                             <a:srgbClr val="0F172A"/>
                           </a:solidFill>
@@ -8972,7 +9508,7 @@
                     <a:p>
                       <a:pPr algn="l"/>
                       <a:r>
-                        <a:rPr sz="1000">
+                        <a:rPr sz="950">
                           <a:solidFill>
                             <a:srgbClr val="0F172A"/>
                           </a:solidFill>
@@ -8995,7 +9531,7 @@
                     <a:p>
                       <a:pPr algn="l"/>
                       <a:r>
-                        <a:rPr sz="1000">
+                        <a:rPr sz="950">
                           <a:solidFill>
                             <a:srgbClr val="0F172A"/>
                           </a:solidFill>
@@ -9090,7 +9626,7 @@
                 </a:solidFill>
                 <a:latin typeface="Calibri"/>
               </a:rPr>
-              <a:t>HealthProMed · Q3 2026 Provider Audit Report</a:t>
+              <a:t>HealthProMed - Q3 2026 Provider Audit Report</a:t>
             </a:r>
           </a:p>
         </p:txBody>
@@ -9257,7 +9793,7 @@
                 </a:solidFill>
                 <a:latin typeface="Calibri"/>
               </a:rPr>
-              <a:t>3 providers · targeted education, monitor next cycle, target 90%+</a:t>
+              <a:t>3 providers - targeted education, monitor next cycle, target 90%+</a:t>
             </a:r>
           </a:p>
         </p:txBody>
@@ -9388,7 +9924,7 @@
                     <a:p>
                       <a:pPr algn="l"/>
                       <a:r>
-                        <a:rPr sz="1000">
+                        <a:rPr sz="950">
                           <a:solidFill>
                             <a:srgbClr val="0F172A"/>
                           </a:solidFill>
@@ -9411,7 +9947,7 @@
                     <a:p>
                       <a:pPr algn="l"/>
                       <a:r>
-                        <a:rPr sz="1000">
+                        <a:rPr sz="950">
                           <a:solidFill>
                             <a:srgbClr val="0F172A"/>
                           </a:solidFill>
@@ -9434,7 +9970,7 @@
                     <a:p>
                       <a:pPr algn="l"/>
                       <a:r>
-                        <a:rPr sz="1000">
+                        <a:rPr sz="950">
                           <a:solidFill>
                             <a:srgbClr val="0F172A"/>
                           </a:solidFill>
@@ -9457,13 +9993,13 @@
                     <a:p>
                       <a:pPr algn="l"/>
                       <a:r>
-                        <a:rPr sz="1000">
+                        <a:rPr sz="950">
                           <a:solidFill>
                             <a:srgbClr val="0F172A"/>
                           </a:solidFill>
                           <a:latin typeface="Calibri"/>
                         </a:rPr>
-                        <a:t>Send provider tip · monitor next audit cycle · target: 90%+</a:t>
+                        <a:t>Send provider tip - monitor next cycle - target 90%+</a:t>
                       </a:r>
                     </a:p>
                   </a:txBody>
@@ -9482,7 +10018,7 @@
                     <a:p>
                       <a:pPr algn="l"/>
                       <a:r>
-                        <a:rPr sz="1000">
+                        <a:rPr sz="950">
                           <a:solidFill>
                             <a:srgbClr val="0F172A"/>
                           </a:solidFill>
@@ -9505,7 +10041,7 @@
                     <a:p>
                       <a:pPr algn="l"/>
                       <a:r>
-                        <a:rPr sz="1000">
+                        <a:rPr sz="950">
                           <a:solidFill>
                             <a:srgbClr val="0F172A"/>
                           </a:solidFill>
@@ -9528,7 +10064,7 @@
                     <a:p>
                       <a:pPr algn="l"/>
                       <a:r>
-                        <a:rPr sz="1000">
+                        <a:rPr sz="950">
                           <a:solidFill>
                             <a:srgbClr val="0F172A"/>
                           </a:solidFill>
@@ -9551,13 +10087,13 @@
                     <a:p>
                       <a:pPr algn="l"/>
                       <a:r>
-                        <a:rPr sz="1000">
+                        <a:rPr sz="950">
                           <a:solidFill>
                             <a:srgbClr val="0F172A"/>
                           </a:solidFill>
                           <a:latin typeface="Calibri"/>
                         </a:rPr>
-                        <a:t>Send provider tip · monitor next audit cycle · target: 90%+</a:t>
+                        <a:t>Send provider tip - monitor next cycle - target 90%+</a:t>
                       </a:r>
                     </a:p>
                   </a:txBody>
@@ -9576,7 +10112,7 @@
                     <a:p>
                       <a:pPr algn="l"/>
                       <a:r>
-                        <a:rPr sz="1000">
+                        <a:rPr sz="950">
                           <a:solidFill>
                             <a:srgbClr val="0F172A"/>
                           </a:solidFill>
@@ -9599,7 +10135,7 @@
                     <a:p>
                       <a:pPr algn="l"/>
                       <a:r>
-                        <a:rPr sz="1000">
+                        <a:rPr sz="950">
                           <a:solidFill>
                             <a:srgbClr val="0F172A"/>
                           </a:solidFill>
@@ -9622,7 +10158,7 @@
                     <a:p>
                       <a:pPr algn="l"/>
                       <a:r>
-                        <a:rPr sz="1000">
+                        <a:rPr sz="950">
                           <a:solidFill>
                             <a:srgbClr val="0F172A"/>
                           </a:solidFill>
@@ -9645,13 +10181,13 @@
                     <a:p>
                       <a:pPr algn="l"/>
                       <a:r>
-                        <a:rPr sz="1000">
+                        <a:rPr sz="950">
                           <a:solidFill>
                             <a:srgbClr val="0F172A"/>
                           </a:solidFill>
                           <a:latin typeface="Calibri"/>
                         </a:rPr>
-                        <a:t>Send provider tip · monitor next audit cycle · target: 90%+</a:t>
+                        <a:t>Send provider tip - monitor next cycle - target 90%+</a:t>
                       </a:r>
                     </a:p>
                   </a:txBody>
@@ -9740,7 +10276,7 @@
                 </a:solidFill>
                 <a:latin typeface="Calibri"/>
               </a:rPr>
-              <a:t>Immediate action for these 3 providers:</a:t>
+              <a:t>Immediate action for these providers:</a:t>
             </a:r>
           </a:p>
         </p:txBody>
@@ -9775,7 +10311,7 @@
                 </a:solidFill>
                 <a:latin typeface="Calibri"/>
               </a:rPr>
-              <a:t>• Send a 1-page provider tip highlighting their top 2 documentation deficiencies.</a:t>
+              <a:t>- Send a 1-page provider tip highlighting their top 2 documentation deficiencies.</a:t>
             </a:r>
           </a:p>
           <a:p>
@@ -9787,7 +10323,7 @@
                 </a:solidFill>
                 <a:latin typeface="Calibri"/>
               </a:rPr>
-              <a:t>• Include their scorecard and specific chart examples (masked).</a:t>
+              <a:t>- Include their scorecard and specific chart examples (masked).</a:t>
             </a:r>
           </a:p>
           <a:p>
@@ -9799,7 +10335,7 @@
                 </a:solidFill>
                 <a:latin typeface="Calibri"/>
               </a:rPr>
-              <a:t>• Monitor closely — re-audit in the next monthly cycle.</a:t>
+              <a:t>- Monitor closely - re-audit in the next monthly cycle.</a:t>
             </a:r>
           </a:p>
           <a:p>
@@ -9811,7 +10347,7 @@
                 </a:solidFill>
                 <a:latin typeface="Calibri"/>
               </a:rPr>
-              <a:t>• Target: move all 3 into Meets Expectations (≥90%) within one cycle.</a:t>
+              <a:t>- Target: move all into Meets Expectations (&gt;=90%) within one cycle.</a:t>
             </a:r>
           </a:p>
         </p:txBody>
@@ -9890,7 +10426,7 @@
                 </a:solidFill>
                 <a:latin typeface="Calibri"/>
               </a:rPr>
-              <a:t>HealthProMed · Q3 2026 Provider Audit Report</a:t>
+              <a:t>HealthProMed - Q3 2026 Provider Audit Report</a:t>
             </a:r>
           </a:p>
         </p:txBody>
@@ -10057,7 +10593,7 @@
                 </a:solidFill>
                 <a:latin typeface="Calibri"/>
               </a:rPr>
-              <a:t>9 providers · formal plan + 1-on-1 education + re-audit in 60-90 days</a:t>
+              <a:t>10 providers - formal plan + 1-on-1 education + re-audit in 60-90 days</a:t>
             </a:r>
           </a:p>
         </p:txBody>
@@ -10086,7 +10622,7 @@
                 <a:gridCol w="1143000"/>
                 <a:gridCol w="4343400"/>
               </a:tblGrid>
-              <a:tr h="502920">
+              <a:tr h="457200">
                 <a:tc>
                   <a:txBody>
                     <a:bodyPr wrap="square"/>
@@ -10180,7 +10716,7 @@
                   </a:tcPr>
                 </a:tc>
               </a:tr>
-              <a:tr h="502920">
+              <a:tr h="457200">
                 <a:tc>
                   <a:txBody>
                     <a:bodyPr wrap="square" lIns="54864" rIns="54864" tIns="27432" bIns="27432"/>
@@ -10188,7 +10724,7 @@
                     <a:p>
                       <a:pPr algn="l"/>
                       <a:r>
-                        <a:rPr sz="1000">
+                        <a:rPr sz="950">
                           <a:solidFill>
                             <a:srgbClr val="0F172A"/>
                           </a:solidFill>
@@ -10211,7 +10747,7 @@
                     <a:p>
                       <a:pPr algn="l"/>
                       <a:r>
-                        <a:rPr sz="1000">
+                        <a:rPr sz="950">
                           <a:solidFill>
                             <a:srgbClr val="0F172A"/>
                           </a:solidFill>
@@ -10234,7 +10770,7 @@
                     <a:p>
                       <a:pPr algn="l"/>
                       <a:r>
-                        <a:rPr sz="1000">
+                        <a:rPr sz="950">
                           <a:solidFill>
                             <a:srgbClr val="0F172A"/>
                           </a:solidFill>
@@ -10257,13 +10793,13 @@
                     <a:p>
                       <a:pPr algn="l"/>
                       <a:r>
-                        <a:rPr sz="1000">
+                        <a:rPr sz="950">
                           <a:solidFill>
                             <a:srgbClr val="0F172A"/>
                           </a:solidFill>
                           <a:latin typeface="Calibri"/>
                         </a:rPr>
-                        <a:t>Open plan · 1-on-1 education · re-audit 60-90 d</a:t>
+                        <a:t>Open plan - 1-on-1 education - re-audit 60-90 d</a:t>
                       </a:r>
                     </a:p>
                   </a:txBody>
@@ -10274,7 +10810,7 @@
                   </a:tcPr>
                 </a:tc>
               </a:tr>
-              <a:tr h="502920">
+              <a:tr h="457200">
                 <a:tc>
                   <a:txBody>
                     <a:bodyPr wrap="square" lIns="54864" rIns="54864" tIns="27432" bIns="27432"/>
@@ -10282,7 +10818,7 @@
                     <a:p>
                       <a:pPr algn="l"/>
                       <a:r>
-                        <a:rPr sz="1000">
+                        <a:rPr sz="950">
                           <a:solidFill>
                             <a:srgbClr val="0F172A"/>
                           </a:solidFill>
@@ -10305,7 +10841,7 @@
                     <a:p>
                       <a:pPr algn="l"/>
                       <a:r>
-                        <a:rPr sz="1000">
+                        <a:rPr sz="950">
                           <a:solidFill>
                             <a:srgbClr val="0F172A"/>
                           </a:solidFill>
@@ -10328,7 +10864,7 @@
                     <a:p>
                       <a:pPr algn="l"/>
                       <a:r>
-                        <a:rPr sz="1000">
+                        <a:rPr sz="950">
                           <a:solidFill>
                             <a:srgbClr val="0F172A"/>
                           </a:solidFill>
@@ -10351,13 +10887,13 @@
                     <a:p>
                       <a:pPr algn="l"/>
                       <a:r>
-                        <a:rPr sz="1000">
+                        <a:rPr sz="950">
                           <a:solidFill>
                             <a:srgbClr val="0F172A"/>
                           </a:solidFill>
                           <a:latin typeface="Calibri"/>
                         </a:rPr>
-                        <a:t>Open plan · 1-on-1 education · re-audit 60-90 d</a:t>
+                        <a:t>Open plan - 1-on-1 education - re-audit 60-90 d</a:t>
                       </a:r>
                     </a:p>
                   </a:txBody>
@@ -10368,7 +10904,7 @@
                   </a:tcPr>
                 </a:tc>
               </a:tr>
-              <a:tr h="502920">
+              <a:tr h="457200">
                 <a:tc>
                   <a:txBody>
                     <a:bodyPr wrap="square" lIns="54864" rIns="54864" tIns="27432" bIns="27432"/>
@@ -10376,7 +10912,7 @@
                     <a:p>
                       <a:pPr algn="l"/>
                       <a:r>
-                        <a:rPr sz="1000">
+                        <a:rPr sz="950">
                           <a:solidFill>
                             <a:srgbClr val="0F172A"/>
                           </a:solidFill>
@@ -10399,7 +10935,7 @@
                     <a:p>
                       <a:pPr algn="l"/>
                       <a:r>
-                        <a:rPr sz="1000">
+                        <a:rPr sz="950">
                           <a:solidFill>
                             <a:srgbClr val="0F172A"/>
                           </a:solidFill>
@@ -10422,7 +10958,7 @@
                     <a:p>
                       <a:pPr algn="l"/>
                       <a:r>
-                        <a:rPr sz="1000">
+                        <a:rPr sz="950">
                           <a:solidFill>
                             <a:srgbClr val="0F172A"/>
                           </a:solidFill>
@@ -10445,13 +10981,13 @@
                     <a:p>
                       <a:pPr algn="l"/>
                       <a:r>
-                        <a:rPr sz="1000">
+                        <a:rPr sz="950">
                           <a:solidFill>
                             <a:srgbClr val="0F172A"/>
                           </a:solidFill>
                           <a:latin typeface="Calibri"/>
                         </a:rPr>
-                        <a:t>Open plan · 1-on-1 education · re-audit 60-90 d</a:t>
+                        <a:t>Open plan - 1-on-1 education - re-audit 60-90 d</a:t>
                       </a:r>
                     </a:p>
                   </a:txBody>
@@ -10462,7 +10998,7 @@
                   </a:tcPr>
                 </a:tc>
               </a:tr>
-              <a:tr h="502920">
+              <a:tr h="457200">
                 <a:tc>
                   <a:txBody>
                     <a:bodyPr wrap="square" lIns="54864" rIns="54864" tIns="27432" bIns="27432"/>
@@ -10470,7 +11006,7 @@
                     <a:p>
                       <a:pPr algn="l"/>
                       <a:r>
-                        <a:rPr sz="1000">
+                        <a:rPr sz="950">
                           <a:solidFill>
                             <a:srgbClr val="0F172A"/>
                           </a:solidFill>
@@ -10493,7 +11029,7 @@
                     <a:p>
                       <a:pPr algn="l"/>
                       <a:r>
-                        <a:rPr sz="1000">
+                        <a:rPr sz="950">
                           <a:solidFill>
                             <a:srgbClr val="0F172A"/>
                           </a:solidFill>
@@ -10516,7 +11052,7 @@
                     <a:p>
                       <a:pPr algn="l"/>
                       <a:r>
-                        <a:rPr sz="1000">
+                        <a:rPr sz="950">
                           <a:solidFill>
                             <a:srgbClr val="0F172A"/>
                           </a:solidFill>
@@ -10539,13 +11075,13 @@
                     <a:p>
                       <a:pPr algn="l"/>
                       <a:r>
-                        <a:rPr sz="1000">
+                        <a:rPr sz="950">
                           <a:solidFill>
                             <a:srgbClr val="0F172A"/>
                           </a:solidFill>
                           <a:latin typeface="Calibri"/>
                         </a:rPr>
-                        <a:t>Open plan · 1-on-1 education · re-audit 60-90 d</a:t>
+                        <a:t>Open plan - 1-on-1 education - re-audit 60-90 d</a:t>
                       </a:r>
                     </a:p>
                   </a:txBody>
@@ -10556,7 +11092,7 @@
                   </a:tcPr>
                 </a:tc>
               </a:tr>
-              <a:tr h="502920">
+              <a:tr h="457200">
                 <a:tc>
                   <a:txBody>
                     <a:bodyPr wrap="square" lIns="54864" rIns="54864" tIns="27432" bIns="27432"/>
@@ -10564,7 +11100,7 @@
                     <a:p>
                       <a:pPr algn="l"/>
                       <a:r>
-                        <a:rPr sz="1000">
+                        <a:rPr sz="950">
                           <a:solidFill>
                             <a:srgbClr val="0F172A"/>
                           </a:solidFill>
@@ -10587,7 +11123,7 @@
                     <a:p>
                       <a:pPr algn="l"/>
                       <a:r>
-                        <a:rPr sz="1000">
+                        <a:rPr sz="950">
                           <a:solidFill>
                             <a:srgbClr val="0F172A"/>
                           </a:solidFill>
@@ -10610,7 +11146,7 @@
                     <a:p>
                       <a:pPr algn="l"/>
                       <a:r>
-                        <a:rPr sz="1000">
+                        <a:rPr sz="950">
                           <a:solidFill>
                             <a:srgbClr val="0F172A"/>
                           </a:solidFill>
@@ -10633,13 +11169,13 @@
                     <a:p>
                       <a:pPr algn="l"/>
                       <a:r>
-                        <a:rPr sz="1000">
+                        <a:rPr sz="950">
                           <a:solidFill>
                             <a:srgbClr val="0F172A"/>
                           </a:solidFill>
                           <a:latin typeface="Calibri"/>
                         </a:rPr>
-                        <a:t>Open plan · 1-on-1 education · re-audit 60-90 d</a:t>
+                        <a:t>Open plan - 1-on-1 education - re-audit 60-90 d</a:t>
                       </a:r>
                     </a:p>
                   </a:txBody>
@@ -10650,7 +11186,7 @@
                   </a:tcPr>
                 </a:tc>
               </a:tr>
-              <a:tr h="502920">
+              <a:tr h="457200">
                 <a:tc>
                   <a:txBody>
                     <a:bodyPr wrap="square" lIns="54864" rIns="54864" tIns="27432" bIns="27432"/>
@@ -10658,7 +11194,7 @@
                     <a:p>
                       <a:pPr algn="l"/>
                       <a:r>
-                        <a:rPr sz="1000">
+                        <a:rPr sz="950">
                           <a:solidFill>
                             <a:srgbClr val="0F172A"/>
                           </a:solidFill>
@@ -10681,7 +11217,7 @@
                     <a:p>
                       <a:pPr algn="l"/>
                       <a:r>
-                        <a:rPr sz="1000">
+                        <a:rPr sz="950">
                           <a:solidFill>
                             <a:srgbClr val="0F172A"/>
                           </a:solidFill>
@@ -10704,7 +11240,7 @@
                     <a:p>
                       <a:pPr algn="l"/>
                       <a:r>
-                        <a:rPr sz="1000">
+                        <a:rPr sz="950">
                           <a:solidFill>
                             <a:srgbClr val="0F172A"/>
                           </a:solidFill>
@@ -10727,13 +11263,13 @@
                     <a:p>
                       <a:pPr algn="l"/>
                       <a:r>
-                        <a:rPr sz="1000">
+                        <a:rPr sz="950">
                           <a:solidFill>
                             <a:srgbClr val="0F172A"/>
                           </a:solidFill>
                           <a:latin typeface="Calibri"/>
                         </a:rPr>
-                        <a:t>Open plan · 1-on-1 education · re-audit 60-90 d</a:t>
+                        <a:t>Open plan - 1-on-1 education - re-audit 60-90 d</a:t>
                       </a:r>
                     </a:p>
                   </a:txBody>
@@ -10744,7 +11280,7 @@
                   </a:tcPr>
                 </a:tc>
               </a:tr>
-              <a:tr h="502920">
+              <a:tr h="457200">
                 <a:tc>
                   <a:txBody>
                     <a:bodyPr wrap="square" lIns="54864" rIns="54864" tIns="27432" bIns="27432"/>
@@ -10752,7 +11288,7 @@
                     <a:p>
                       <a:pPr algn="l"/>
                       <a:r>
-                        <a:rPr sz="1000">
+                        <a:rPr sz="950">
                           <a:solidFill>
                             <a:srgbClr val="0F172A"/>
                           </a:solidFill>
@@ -10775,7 +11311,7 @@
                     <a:p>
                       <a:pPr algn="l"/>
                       <a:r>
-                        <a:rPr sz="1000">
+                        <a:rPr sz="950">
                           <a:solidFill>
                             <a:srgbClr val="0F172A"/>
                           </a:solidFill>
@@ -10798,7 +11334,7 @@
                     <a:p>
                       <a:pPr algn="l"/>
                       <a:r>
-                        <a:rPr sz="1000">
+                        <a:rPr sz="950">
                           <a:solidFill>
                             <a:srgbClr val="0F172A"/>
                           </a:solidFill>
@@ -10821,13 +11357,13 @@
                     <a:p>
                       <a:pPr algn="l"/>
                       <a:r>
-                        <a:rPr sz="1000">
+                        <a:rPr sz="950">
                           <a:solidFill>
                             <a:srgbClr val="0F172A"/>
                           </a:solidFill>
                           <a:latin typeface="Calibri"/>
                         </a:rPr>
-                        <a:t>Open plan · 1-on-1 education · re-audit 60-90 d</a:t>
+                        <a:t>Open plan - 1-on-1 education - re-audit 60-90 d</a:t>
                       </a:r>
                     </a:p>
                   </a:txBody>
@@ -10838,7 +11374,7 @@
                   </a:tcPr>
                 </a:tc>
               </a:tr>
-              <a:tr h="502920">
+              <a:tr h="457200">
                 <a:tc>
                   <a:txBody>
                     <a:bodyPr wrap="square" lIns="54864" rIns="54864" tIns="27432" bIns="27432"/>
@@ -10846,18 +11382,206 @@
                     <a:p>
                       <a:pPr algn="l"/>
                       <a:r>
-                        <a:rPr sz="1000">
+                        <a:rPr sz="950">
                           <a:solidFill>
                             <a:srgbClr val="0F172A"/>
                           </a:solidFill>
                           <a:latin typeface="Calibri"/>
                         </a:rPr>
+                        <a:t>Alejandra Velez Alicea, MD</a:t>
+                      </a:r>
+                    </a:p>
+                  </a:txBody>
+                  <a:tcPr>
+                    <a:solidFill>
+                      <a:srgbClr val="E6F4F1"/>
+                    </a:solidFill>
+                  </a:tcPr>
+                </a:tc>
+                <a:tc>
+                  <a:txBody>
+                    <a:bodyPr wrap="square" lIns="54864" rIns="54864" tIns="27432" bIns="27432"/>
+                    <a:lstStyle/>
+                    <a:p>
+                      <a:pPr algn="l"/>
+                      <a:r>
+                        <a:rPr sz="950">
+                          <a:solidFill>
+                            <a:srgbClr val="0F172A"/>
+                          </a:solidFill>
+                          <a:latin typeface="Calibri"/>
+                        </a:rPr>
+                        <a:t>MMM Vital</a:t>
+                      </a:r>
+                    </a:p>
+                  </a:txBody>
+                  <a:tcPr>
+                    <a:solidFill>
+                      <a:srgbClr val="E6F4F1"/>
+                    </a:solidFill>
+                  </a:tcPr>
+                </a:tc>
+                <a:tc>
+                  <a:txBody>
+                    <a:bodyPr wrap="square" lIns="54864" rIns="54864" tIns="27432" bIns="27432"/>
+                    <a:lstStyle/>
+                    <a:p>
+                      <a:pPr algn="l"/>
+                      <a:r>
+                        <a:rPr sz="950">
+                          <a:solidFill>
+                            <a:srgbClr val="0F172A"/>
+                          </a:solidFill>
+                          <a:latin typeface="Calibri"/>
+                        </a:rPr>
+                        <a:t>72.9%</a:t>
+                      </a:r>
+                    </a:p>
+                  </a:txBody>
+                  <a:tcPr>
+                    <a:solidFill>
+                      <a:srgbClr val="E6F4F1"/>
+                    </a:solidFill>
+                  </a:tcPr>
+                </a:tc>
+                <a:tc>
+                  <a:txBody>
+                    <a:bodyPr wrap="square" lIns="54864" rIns="54864" tIns="27432" bIns="27432"/>
+                    <a:lstStyle/>
+                    <a:p>
+                      <a:pPr algn="l"/>
+                      <a:r>
+                        <a:rPr sz="950">
+                          <a:solidFill>
+                            <a:srgbClr val="0F172A"/>
+                          </a:solidFill>
+                          <a:latin typeface="Calibri"/>
+                        </a:rPr>
+                        <a:t>Open plan - 1-on-1 education - re-audit 60-90 d</a:t>
+                      </a:r>
+                    </a:p>
+                  </a:txBody>
+                  <a:tcPr>
+                    <a:solidFill>
+                      <a:srgbClr val="E6F4F1"/>
+                    </a:solidFill>
+                  </a:tcPr>
+                </a:tc>
+              </a:tr>
+              <a:tr h="457200">
+                <a:tc>
+                  <a:txBody>
+                    <a:bodyPr wrap="square" lIns="54864" rIns="54864" tIns="27432" bIns="27432"/>
+                    <a:lstStyle/>
+                    <a:p>
+                      <a:pPr algn="l"/>
+                      <a:r>
+                        <a:rPr sz="950">
+                          <a:solidFill>
+                            <a:srgbClr val="0F172A"/>
+                          </a:solidFill>
+                          <a:latin typeface="Calibri"/>
+                        </a:rPr>
                         <a:t>Yolis Guerrero del Rio, MD</a:t>
                       </a:r>
                     </a:p>
                   </a:txBody>
                   <a:tcPr>
                     <a:solidFill>
+                      <a:srgbClr val="FFFFFF"/>
+                    </a:solidFill>
+                  </a:tcPr>
+                </a:tc>
+                <a:tc>
+                  <a:txBody>
+                    <a:bodyPr wrap="square" lIns="54864" rIns="54864" tIns="27432" bIns="27432"/>
+                    <a:lstStyle/>
+                    <a:p>
+                      <a:pPr algn="l"/>
+                      <a:r>
+                        <a:rPr sz="950">
+                          <a:solidFill>
+                            <a:srgbClr val="0F172A"/>
+                          </a:solidFill>
+                          <a:latin typeface="Calibri"/>
+                        </a:rPr>
+                        <a:t>MCS Classicare</a:t>
+                      </a:r>
+                    </a:p>
+                  </a:txBody>
+                  <a:tcPr>
+                    <a:solidFill>
+                      <a:srgbClr val="FFFFFF"/>
+                    </a:solidFill>
+                  </a:tcPr>
+                </a:tc>
+                <a:tc>
+                  <a:txBody>
+                    <a:bodyPr wrap="square" lIns="54864" rIns="54864" tIns="27432" bIns="27432"/>
+                    <a:lstStyle/>
+                    <a:p>
+                      <a:pPr algn="l"/>
+                      <a:r>
+                        <a:rPr sz="950">
+                          <a:solidFill>
+                            <a:srgbClr val="0F172A"/>
+                          </a:solidFill>
+                          <a:latin typeface="Calibri"/>
+                        </a:rPr>
+                        <a:t>72.0%</a:t>
+                      </a:r>
+                    </a:p>
+                  </a:txBody>
+                  <a:tcPr>
+                    <a:solidFill>
+                      <a:srgbClr val="FFFFFF"/>
+                    </a:solidFill>
+                  </a:tcPr>
+                </a:tc>
+                <a:tc>
+                  <a:txBody>
+                    <a:bodyPr wrap="square" lIns="54864" rIns="54864" tIns="27432" bIns="27432"/>
+                    <a:lstStyle/>
+                    <a:p>
+                      <a:pPr algn="l"/>
+                      <a:r>
+                        <a:rPr sz="950">
+                          <a:solidFill>
+                            <a:srgbClr val="0F172A"/>
+                          </a:solidFill>
+                          <a:latin typeface="Calibri"/>
+                        </a:rPr>
+                        <a:t>Open plan - 1-on-1 education - re-audit 60-90 d</a:t>
+                      </a:r>
+                    </a:p>
+                  </a:txBody>
+                  <a:tcPr>
+                    <a:solidFill>
+                      <a:srgbClr val="FFFFFF"/>
+                    </a:solidFill>
+                  </a:tcPr>
+                </a:tc>
+              </a:tr>
+              <a:tr h="457200">
+                <a:tc>
+                  <a:txBody>
+                    <a:bodyPr wrap="square" lIns="54864" rIns="54864" tIns="27432" bIns="27432"/>
+                    <a:lstStyle/>
+                    <a:p>
+                      <a:pPr algn="l"/>
+                      <a:r>
+                        <a:rPr sz="950">
+                          <a:solidFill>
+                            <a:srgbClr val="0F172A"/>
+                          </a:solidFill>
+                          <a:latin typeface="Calibri"/>
+                        </a:rPr>
+                        <a:t>Ivette Perez Pagan, MD</a:t>
+                      </a:r>
+                    </a:p>
+                  </a:txBody>
+                  <a:tcPr>
+                    <a:solidFill>
                       <a:srgbClr val="E6F4F1"/>
                     </a:solidFill>
                   </a:tcPr>
@@ -10869,13 +11593,13 @@
                     <a:p>
                       <a:pPr algn="l"/>
                       <a:r>
-                        <a:rPr sz="1000">
+                        <a:rPr sz="950">
                           <a:solidFill>
                             <a:srgbClr val="0F172A"/>
                           </a:solidFill>
                           <a:latin typeface="Calibri"/>
                         </a:rPr>
-                        <a:t>MCS Classicare</a:t>
+                        <a:t>MMM Vital Capitado</a:t>
                       </a:r>
                     </a:p>
                   </a:txBody>
@@ -10892,13 +11616,13 @@
                     <a:p>
                       <a:pPr algn="l"/>
                       <a:r>
-                        <a:rPr sz="1000">
+                        <a:rPr sz="950">
                           <a:solidFill>
                             <a:srgbClr val="0F172A"/>
                           </a:solidFill>
                           <a:latin typeface="Calibri"/>
                         </a:rPr>
-                        <a:t>72.0%</a:t>
+                        <a:t>68.9%</a:t>
                       </a:r>
                     </a:p>
                   </a:txBody>
@@ -10915,113 +11639,19 @@
                     <a:p>
                       <a:pPr algn="l"/>
                       <a:r>
-                        <a:rPr sz="1000">
+                        <a:rPr sz="950">
                           <a:solidFill>
                             <a:srgbClr val="0F172A"/>
                           </a:solidFill>
                           <a:latin typeface="Calibri"/>
                         </a:rPr>
-                        <a:t>Open plan · 1-on-1 education · re-audit 60-90 d</a:t>
+                        <a:t>Open plan - 1-on-1 education - re-audit 60-90 d</a:t>
                       </a:r>
                     </a:p>
                   </a:txBody>
                   <a:tcPr>
                     <a:solidFill>
                       <a:srgbClr val="E6F4F1"/>
-                    </a:solidFill>
-                  </a:tcPr>
-                </a:tc>
-              </a:tr>
-              <a:tr h="502920">
-                <a:tc>
-                  <a:txBody>
-                    <a:bodyPr wrap="square" lIns="54864" rIns="54864" tIns="27432" bIns="27432"/>
-                    <a:lstStyle/>
-                    <a:p>
-                      <a:pPr algn="l"/>
-                      <a:r>
-                        <a:rPr sz="1000">
-                          <a:solidFill>
-                            <a:srgbClr val="0F172A"/>
-                          </a:solidFill>
-                          <a:latin typeface="Calibri"/>
-                        </a:rPr>
-                        <a:t>Ivette Perez Pagan, MD</a:t>
-                      </a:r>
-                    </a:p>
-                  </a:txBody>
-                  <a:tcPr>
-                    <a:solidFill>
-                      <a:srgbClr val="FFFFFF"/>
-                    </a:solidFill>
-                  </a:tcPr>
-                </a:tc>
-                <a:tc>
-                  <a:txBody>
-                    <a:bodyPr wrap="square" lIns="54864" rIns="54864" tIns="27432" bIns="27432"/>
-                    <a:lstStyle/>
-                    <a:p>
-                      <a:pPr algn="l"/>
-                      <a:r>
-                        <a:rPr sz="1000">
-                          <a:solidFill>
-                            <a:srgbClr val="0F172A"/>
-                          </a:solidFill>
-                          <a:latin typeface="Calibri"/>
-                        </a:rPr>
-                        <a:t>MMM Vital Capitado</a:t>
-                      </a:r>
-                    </a:p>
-                  </a:txBody>
-                  <a:tcPr>
-                    <a:solidFill>
-                      <a:srgbClr val="FFFFFF"/>
-                    </a:solidFill>
-                  </a:tcPr>
-                </a:tc>
-                <a:tc>
-                  <a:txBody>
-                    <a:bodyPr wrap="square" lIns="54864" rIns="54864" tIns="27432" bIns="27432"/>
-                    <a:lstStyle/>
-                    <a:p>
-                      <a:pPr algn="l"/>
-                      <a:r>
-                        <a:rPr sz="1000">
-                          <a:solidFill>
-                            <a:srgbClr val="0F172A"/>
-                          </a:solidFill>
-                          <a:latin typeface="Calibri"/>
-                        </a:rPr>
-                        <a:t>68.9%</a:t>
-                      </a:r>
-                    </a:p>
-                  </a:txBody>
-                  <a:tcPr>
-                    <a:solidFill>
-                      <a:srgbClr val="FFFFFF"/>
-                    </a:solidFill>
-                  </a:tcPr>
-                </a:tc>
-                <a:tc>
-                  <a:txBody>
-                    <a:bodyPr wrap="square" lIns="54864" rIns="54864" tIns="27432" bIns="27432"/>
-                    <a:lstStyle/>
-                    <a:p>
-                      <a:pPr algn="l"/>
-                      <a:r>
-                        <a:rPr sz="1000">
-                          <a:solidFill>
-                            <a:srgbClr val="0F172A"/>
-                          </a:solidFill>
-                          <a:latin typeface="Calibri"/>
-                        </a:rPr>
-                        <a:t>Open plan · 1-on-1 education · re-audit 60-90 d</a:t>
-                      </a:r>
-                    </a:p>
-                  </a:txBody>
-                  <a:tcPr>
-                    <a:solidFill>
-                      <a:srgbClr val="FFFFFF"/>
                     </a:solidFill>
                   </a:tcPr>
                 </a:tc>
@@ -11104,7 +11734,7 @@
                 </a:solidFill>
                 <a:latin typeface="Calibri"/>
               </a:rPr>
-              <a:t>HealthProMed · Q3 2026 Provider Audit Report</a:t>
+              <a:t>HealthProMed - Q3 2026 Provider Audit Report</a:t>
             </a:r>
           </a:p>
         </p:txBody>
@@ -11271,7 +11901,7 @@
                 </a:solidFill>
                 <a:latin typeface="Calibri"/>
               </a:rPr>
-              <a:t>The pattern suggests a systemic issue, not an individual-provider issue</a:t>
+              <a:t>The pattern suggests a systemic issue, not individual providers</a:t>
             </a:r>
           </a:p>
         </p:txBody>
@@ -11350,7 +11980,7 @@
                 </a:solidFill>
                 <a:latin typeface="Calibri"/>
               </a:rPr>
-              <a:t>0 of 12 providers reached Meets Expectations (≥90%).</a:t>
+              <a:t>0 of 13 providers reached Meets Expectations (&gt;=90%).</a:t>
             </a:r>
           </a:p>
           <a:p>
@@ -11362,7 +11992,7 @@
                 </a:solidFill>
                 <a:latin typeface="Calibri"/>
               </a:rPr>
-              <a:t>9 of 12 providers scored below 80%.</a:t>
+              <a:t>10 of 13 providers scored below 80%.</a:t>
             </a:r>
           </a:p>
         </p:txBody>
@@ -11432,7 +12062,7 @@
                 </a:solidFill>
                 <a:latin typeface="Calibri"/>
               </a:rPr>
-              <a:t>• When the majority of providers underperform on the same audit, the</a:t>
+              <a:t>- When the majority of providers underperform on the same audit, the</a:t>
             </a:r>
           </a:p>
           <a:p>
@@ -11468,7 +12098,7 @@
                 </a:solidFill>
                 <a:latin typeface="Calibri"/>
               </a:rPr>
-              <a:t>• More likely: EHR templates leave documentation gaps · training gaps in what</a:t>
+              <a:t>- More likely: EHR templates leave documentation gaps - training gaps in what</a:t>
             </a:r>
           </a:p>
           <a:p>
@@ -11480,7 +12110,7 @@
                 </a:solidFill>
                 <a:latin typeface="Calibri"/>
               </a:rPr>
-              <a:t>   'complete documentation' means · copy-forward workflow habits · onboarding gaps.</a:t>
+              <a:t>   'complete documentation' means - copy-forward workflow habits - onboarding gaps.</a:t>
             </a:r>
           </a:p>
           <a:p>
@@ -11504,7 +12134,7 @@
                 </a:solidFill>
                 <a:latin typeface="Calibri"/>
               </a:rPr>
-              <a:t>• Treating this as 9 separate corrective plans in isolation will consume enormous</a:t>
+              <a:t>- Treating this as 10 separate corrective plans in isolation will consume enormous</a:t>
             </a:r>
           </a:p>
           <a:p>
@@ -11595,7 +12225,7 @@
                 </a:solidFill>
                 <a:latin typeface="Calibri"/>
               </a:rPr>
-              <a:t>HealthProMed · Q3 2026 Provider Audit Report</a:t>
+              <a:t>HealthProMed - Q3 2026 Provider Audit Report</a:t>
             </a:r>
           </a:p>
         </p:txBody>
@@ -11727,7 +12357,7 @@
                 </a:solidFill>
                 <a:latin typeface="Calibri"/>
               </a:rPr>
-              <a:t>Recommendations — Immediate (this week)</a:t>
+              <a:t>Recommendations - Immediate (this week)</a:t>
             </a:r>
           </a:p>
         </p:txBody>
@@ -11806,7 +12436,7 @@
                 </a:solidFill>
                 <a:latin typeface="Calibri"/>
               </a:rPr>
-              <a:t>1.  Open Corrective Education plans for all 9 providers in the &lt;80% band.</a:t>
+              <a:t>1.  Open Corrective Education plans for all 10 providers in the &lt;80% band.</a:t>
             </a:r>
           </a:p>
           <a:p>
@@ -11830,7 +12460,7 @@
                 </a:solidFill>
                 <a:latin typeface="Calibri"/>
               </a:rPr>
-              <a:t>2.  Schedule 1-on-1 education sessions with each of the 9 providers.</a:t>
+              <a:t>2.  Schedule 1-on-1 education sessions with each of the 10 providers.</a:t>
             </a:r>
           </a:p>
           <a:p>
@@ -11854,7 +12484,7 @@
                 </a:solidFill>
                 <a:latin typeface="Calibri"/>
               </a:rPr>
-              <a:t>3.  Send monthly scorecard emails to all 12 providers — include band,</a:t>
+              <a:t>3.  Send monthly scorecard emails to all 13 providers - include band,</a:t>
             </a:r>
           </a:p>
           <a:p>
@@ -11890,7 +12520,7 @@
                 </a:solidFill>
                 <a:latin typeface="Calibri"/>
               </a:rPr>
-              <a:t>4.  Notify the Medical Director of the 9 corrective-plan providers</a:t>
+              <a:t>4.  Notify the Medical Director of the 10 corrective-plan providers</a:t>
             </a:r>
           </a:p>
           <a:p>
@@ -12005,7 +12635,7 @@
                 </a:solidFill>
                 <a:latin typeface="Calibri"/>
               </a:rPr>
-              <a:t>HealthProMed · Q3 2026 Provider Audit Report</a:t>
+              <a:t>HealthProMed - Q3 2026 Provider Audit Report</a:t>
             </a:r>
           </a:p>
         </p:txBody>

</xml_diff>

<commit_message>
Add 'What this means for HealthProMed' impact slide to Q3 audit deck
New slide 9 - a 4-quadrant executive impact panel translating the raw
audit finding into business, compliance, and care implications:

  Q1  Revenue integrity risk (RAF loss, denial exposure)
  Q2  Compliance / regulatory exposure (RADV, OIG, audit posture)
  Q3  Quality reporting impact (HEDIS, Stars, UDS)
  Q4  Opportunity, not crisis (measurable baseline, systemic fix)

Bottom line: this is a fixable, high-value opportunity - not a
personnel problem. Reframes the finding for leadership.

Deck now 15 slides. Agenda updated. Subsequent slide numbers and
footer page counts renumbered to match.

Co-Authored-By: Claude Opus 4.7 <noreply@anthropic.com>
Claude-Session: https://claude.ai/code/session_01FQCsD1ZdbqSqbtLgYtoLBe
</commit_message>
<xml_diff>
--- a/docs/Q3_2026_Provider_Audit_Report.pptx
+++ b/docs/Q3_2026_Provider_Audit_Report.pptx
@@ -19,6 +19,7 @@
     <p:sldId id="267" r:id="rId18"/>
     <p:sldId id="268" r:id="rId19"/>
     <p:sldId id="269" r:id="rId20"/>
+    <p:sldId id="270" r:id="rId21"/>
   </p:sldIdLst>
   <p:sldSz cx="12188952" cy="6858000" type="screen4x3"/>
   <p:notesSz cx="6858000" cy="9144000"/>
@@ -3421,7 +3422,7 @@
                 </a:solidFill>
                 <a:latin typeface="Calibri"/>
               </a:rPr>
-              <a:t>Recommendations - Short-term (next 30 days)</a:t>
+              <a:t>Recommendations - Immediate (this week)</a:t>
             </a:r>
           </a:p>
         </p:txBody>
@@ -3441,7 +3442,7 @@
             <a:avLst/>
           </a:prstGeom>
           <a:solidFill>
-            <a:srgbClr val="B45309"/>
+            <a:srgbClr val="B02424"/>
           </a:solidFill>
           <a:ln>
             <a:noFill/>
@@ -3500,7 +3501,7 @@
                 </a:solidFill>
                 <a:latin typeface="Calibri"/>
               </a:rPr>
-              <a:t>1.  Deliver a 1-hour group education session to all providers focused on</a:t>
+              <a:t>1.  Open Corrective Education plans for all 10 providers in the &lt;80% band.</a:t>
             </a:r>
           </a:p>
           <a:p>
@@ -3512,7 +3513,7 @@
                 </a:solidFill>
                 <a:latin typeface="Calibri"/>
               </a:rPr>
-              <a:t>     the top 3 recurring deficiencies across this cycle.</a:t>
+              <a:t/>
             </a:r>
           </a:p>
           <a:p>
@@ -3524,6 +3525,18 @@
                 </a:solidFill>
                 <a:latin typeface="Calibri"/>
               </a:rPr>
+              <a:t>2.  Schedule 1-on-1 education sessions with each of the 10 providers.</a:t>
+            </a:r>
+          </a:p>
+          <a:p>
+            <a:pPr algn="l"/>
+            <a:r>
+              <a:rPr sz="1600" b="0">
+                <a:solidFill>
+                  <a:srgbClr val="0F172A"/>
+                </a:solidFill>
+                <a:latin typeface="Calibri"/>
+              </a:rPr>
               <a:t/>
             </a:r>
           </a:p>
@@ -3536,7 +3549,7 @@
                 </a:solidFill>
                 <a:latin typeface="Calibri"/>
               </a:rPr>
-              <a:t>2.  Re-audit each corrective-plan provider on a rolling schedule</a:t>
+              <a:t>3.  Send monthly scorecard emails to all 13 providers - include band,</a:t>
             </a:r>
           </a:p>
           <a:p>
@@ -3548,7 +3561,7 @@
                 </a:solidFill>
                 <a:latin typeface="Calibri"/>
               </a:rPr>
-              <a:t>     (target 60-90 days from education date).</a:t>
+              <a:t>     top deficiencies, and next audit date.</a:t>
             </a:r>
           </a:p>
           <a:p>
@@ -3572,7 +3585,7 @@
                 </a:solidFill>
                 <a:latin typeface="Calibri"/>
               </a:rPr>
-              <a:t>3.  Update the KPI Tracker Monthly Data tab with this cycle's data</a:t>
+              <a:t>4.  Notify the Medical Director of the 10 corrective-plan providers</a:t>
             </a:r>
           </a:p>
           <a:p>
@@ -3584,7 +3597,7 @@
                 </a:solidFill>
                 <a:latin typeface="Calibri"/>
               </a:rPr>
-              <a:t>     so leadership sees the baseline trend line begin.</a:t>
+              <a:t>     so leadership can support the education effort.</a:t>
             </a:r>
           </a:p>
           <a:p>
@@ -3608,19 +3621,7 @@
                 </a:solidFill>
                 <a:latin typeface="Calibri"/>
               </a:rPr>
-              <a:t>4.  Migrate Alejandra Velez Alicea's audit from PDF into the standard workbook</a:t>
-            </a:r>
-          </a:p>
-          <a:p>
-            <a:pPr algn="l"/>
-            <a:r>
-              <a:rPr sz="1600" b="0">
-                <a:solidFill>
-                  <a:srgbClr val="0F172A"/>
-                </a:solidFill>
-                <a:latin typeface="Calibri"/>
-              </a:rPr>
-              <a:t>     format so future rollups auto-populate.</a:t>
+              <a:t>5.  Log all corrective plans in the KPI Tracker under 'Corrective plans opened'.</a:t>
             </a:r>
           </a:p>
         </p:txBody>
@@ -3734,7 +3735,7 @@
                 </a:solidFill>
                 <a:latin typeface="Calibri"/>
               </a:rPr>
-              <a:t>10 / 14</a:t>
+              <a:t>10 / 15</a:t>
             </a:r>
           </a:p>
         </p:txBody>
@@ -3831,7 +3832,7 @@
                 </a:solidFill>
                 <a:latin typeface="Calibri"/>
               </a:rPr>
-              <a:t>Recommendations - Structural (next quarter)</a:t>
+              <a:t>Recommendations - Short-term (next 30 days)</a:t>
             </a:r>
           </a:p>
         </p:txBody>
@@ -3851,7 +3852,7 @@
             <a:avLst/>
           </a:prstGeom>
           <a:solidFill>
-            <a:srgbClr val="0F6E6E"/>
+            <a:srgbClr val="B45309"/>
           </a:solidFill>
           <a:ln>
             <a:noFill/>
@@ -3904,91 +3905,103 @@
           <a:p>
             <a:pPr algn="l"/>
             <a:r>
-              <a:rPr sz="1500" b="0">
+              <a:rPr sz="1600" b="0">
                 <a:solidFill>
                   <a:srgbClr val="0F172A"/>
                 </a:solidFill>
                 <a:latin typeface="Calibri"/>
               </a:rPr>
-              <a:t>1.  Investigate root causes of the systemic pattern:</a:t>
-            </a:r>
-          </a:p>
-          <a:p>
-            <a:pPr algn="l"/>
-            <a:r>
-              <a:rPr sz="1500" b="0">
+              <a:t>1.  Deliver a 1-hour group education session to all providers focused on</a:t>
+            </a:r>
+          </a:p>
+          <a:p>
+            <a:pPr algn="l"/>
+            <a:r>
+              <a:rPr sz="1600" b="0">
                 <a:solidFill>
                   <a:srgbClr val="0F172A"/>
                 </a:solidFill>
                 <a:latin typeface="Calibri"/>
               </a:rPr>
-              <a:t>     - EHR template review - where are documentation gaps built in?</a:t>
-            </a:r>
-          </a:p>
-          <a:p>
-            <a:pPr algn="l"/>
-            <a:r>
-              <a:rPr sz="1500" b="0">
+              <a:t>     the top 3 recurring deficiencies across this cycle.</a:t>
+            </a:r>
+          </a:p>
+          <a:p>
+            <a:pPr algn="l"/>
+            <a:r>
+              <a:rPr sz="1600" b="0">
                 <a:solidFill>
                   <a:srgbClr val="0F172A"/>
                 </a:solidFill>
                 <a:latin typeface="Calibri"/>
               </a:rPr>
-              <a:t>     - Provider onboarding - is documentation training part of it?</a:t>
-            </a:r>
-          </a:p>
-          <a:p>
-            <a:pPr algn="l"/>
-            <a:r>
-              <a:rPr sz="1500" b="0">
+              <a:t/>
+            </a:r>
+          </a:p>
+          <a:p>
+            <a:pPr algn="l"/>
+            <a:r>
+              <a:rPr sz="1600" b="0">
                 <a:solidFill>
                   <a:srgbClr val="0F172A"/>
                 </a:solidFill>
                 <a:latin typeface="Calibri"/>
               </a:rPr>
-              <a:t>     - Copy-forward workflow - is it being audited?</a:t>
-            </a:r>
-          </a:p>
-          <a:p>
-            <a:pPr algn="l"/>
-            <a:r>
-              <a:rPr sz="1500" b="0">
+              <a:t>2.  Re-audit each corrective-plan provider on a rolling schedule</a:t>
+            </a:r>
+          </a:p>
+          <a:p>
+            <a:pPr algn="l"/>
+            <a:r>
+              <a:rPr sz="1600" b="0">
                 <a:solidFill>
                   <a:srgbClr val="0F172A"/>
                 </a:solidFill>
                 <a:latin typeface="Calibri"/>
               </a:rPr>
+              <a:t>     (target 60-90 days from education date).</a:t>
+            </a:r>
+          </a:p>
+          <a:p>
+            <a:pPr algn="l"/>
+            <a:r>
+              <a:rPr sz="1600" b="0">
+                <a:solidFill>
+                  <a:srgbClr val="0F172A"/>
+                </a:solidFill>
+                <a:latin typeface="Calibri"/>
+              </a:rPr>
               <a:t/>
             </a:r>
           </a:p>
           <a:p>
             <a:pPr algn="l"/>
             <a:r>
-              <a:rPr sz="1500" b="0">
+              <a:rPr sz="1600" b="0">
                 <a:solidFill>
                   <a:srgbClr val="0F172A"/>
                 </a:solidFill>
                 <a:latin typeface="Calibri"/>
               </a:rPr>
-              <a:t>2.  Pilot a structured documentation intervention with one clinic</a:t>
-            </a:r>
-          </a:p>
-          <a:p>
-            <a:pPr algn="l"/>
-            <a:r>
-              <a:rPr sz="1500" b="0">
+              <a:t>3.  Update the KPI Tracker Monthly Data tab with this cycle's data</a:t>
+            </a:r>
+          </a:p>
+          <a:p>
+            <a:pPr algn="l"/>
+            <a:r>
+              <a:rPr sz="1600" b="0">
                 <a:solidFill>
                   <a:srgbClr val="0F172A"/>
                 </a:solidFill>
                 <a:latin typeface="Calibri"/>
               </a:rPr>
-              <a:t>     (2 providers) - test whether it moves scores to 90%+.</a:t>
-            </a:r>
-          </a:p>
-          <a:p>
-            <a:pPr algn="l"/>
-            <a:r>
-              <a:rPr sz="1500" b="0">
+              <a:t>     so leadership sees the baseline trend line begin.</a:t>
+            </a:r>
+          </a:p>
+          <a:p>
+            <a:pPr algn="l"/>
+            <a:r>
+              <a:rPr sz="1600" b="0">
                 <a:solidFill>
                   <a:srgbClr val="0F172A"/>
                 </a:solidFill>
@@ -4000,49 +4013,25 @@
           <a:p>
             <a:pPr algn="l"/>
             <a:r>
-              <a:rPr sz="1500" b="0">
+              <a:rPr sz="1600" b="0">
                 <a:solidFill>
                   <a:srgbClr val="0F172A"/>
                 </a:solidFill>
                 <a:latin typeface="Calibri"/>
               </a:rPr>
-              <a:t>3.  Escalate the systemic finding to the Compliance Committee</a:t>
-            </a:r>
-          </a:p>
-          <a:p>
-            <a:pPr algn="l"/>
-            <a:r>
-              <a:rPr sz="1500" b="0">
+              <a:t>4.  Migrate Alejandra Velez Alicea's audit from PDF into the standard workbook</a:t>
+            </a:r>
+          </a:p>
+          <a:p>
+            <a:pPr algn="l"/>
+            <a:r>
+              <a:rPr sz="1600" b="0">
                 <a:solidFill>
                   <a:srgbClr val="0F172A"/>
                 </a:solidFill>
                 <a:latin typeface="Calibri"/>
               </a:rPr>
-              <a:t>     and Revenue Integrity leadership.</a:t>
-            </a:r>
-          </a:p>
-          <a:p>
-            <a:pPr algn="l"/>
-            <a:r>
-              <a:rPr sz="1500" b="0">
-                <a:solidFill>
-                  <a:srgbClr val="0F172A"/>
-                </a:solidFill>
-                <a:latin typeface="Calibri"/>
-              </a:rPr>
-              <a:t/>
-            </a:r>
-          </a:p>
-          <a:p>
-            <a:pPr algn="l"/>
-            <a:r>
-              <a:rPr sz="1500" b="0">
-                <a:solidFill>
-                  <a:srgbClr val="0F172A"/>
-                </a:solidFill>
-                <a:latin typeface="Calibri"/>
-              </a:rPr>
-              <a:t>4.  Prepare 6-month business case for the first CRC hire.</a:t>
+              <a:t>     format so future rollups auto-populate.</a:t>
             </a:r>
           </a:p>
         </p:txBody>
@@ -4156,7 +4145,7 @@
                 </a:solidFill>
                 <a:latin typeface="Calibri"/>
               </a:rPr>
-              <a:t>11 / 14</a:t>
+              <a:t>11 / 15</a:t>
             </a:r>
           </a:p>
         </p:txBody>
@@ -4253,7 +4242,7 @@
                 </a:solidFill>
                 <a:latin typeface="Calibri"/>
               </a:rPr>
-              <a:t>Data source note - Alejandra Velez Alicea, MD</a:t>
+              <a:t>Recommendations - Structural (next quarter)</a:t>
             </a:r>
           </a:p>
         </p:txBody>
@@ -4266,8 +4255,219 @@
         </p:nvSpPr>
         <p:spPr>
           <a:xfrm>
-            <a:off x="457200" y="1371600"/>
-            <a:ext cx="11338560" cy="2743200"/>
+            <a:off x="457200" y="1280160"/>
+            <a:ext cx="137160" cy="5029200"/>
+          </a:xfrm>
+          <a:prstGeom prst="rect">
+            <a:avLst/>
+          </a:prstGeom>
+          <a:solidFill>
+            <a:srgbClr val="0F6E6E"/>
+          </a:solidFill>
+          <a:ln>
+            <a:noFill/>
+          </a:ln>
+          <a:effectLst/>
+        </p:spPr>
+        <p:style>
+          <a:lnRef idx="1">
+            <a:schemeClr val="accent1"/>
+          </a:lnRef>
+          <a:fillRef idx="3">
+            <a:schemeClr val="accent1"/>
+          </a:fillRef>
+          <a:effectRef idx="2">
+            <a:schemeClr val="accent1"/>
+          </a:effectRef>
+          <a:fontRef idx="minor">
+            <a:schemeClr val="lt1"/>
+          </a:fontRef>
+        </p:style>
+        <p:txBody>
+          <a:bodyPr rtlCol="0" anchor="ctr"/>
+          <a:lstStyle/>
+          <a:p>
+            <a:pPr algn="ctr"/>
+          </a:p>
+        </p:txBody>
+      </p:sp>
+      <p:sp>
+        <p:nvSpPr>
+          <p:cNvPr id="5" name="TextBox 4"/>
+          <p:cNvSpPr txBox="1"/>
+          <p:nvPr/>
+        </p:nvSpPr>
+        <p:spPr>
+          <a:xfrm>
+            <a:off x="731520" y="1280160"/>
+            <a:ext cx="10972800" cy="5029200"/>
+          </a:xfrm>
+          <a:prstGeom prst="rect">
+            <a:avLst/>
+          </a:prstGeom>
+          <a:noFill/>
+        </p:spPr>
+        <p:txBody>
+          <a:bodyPr wrap="square" lIns="45720" rIns="45720" tIns="18288" bIns="18288" anchor="t">
+            <a:spAutoFit/>
+          </a:bodyPr>
+          <a:lstStyle/>
+          <a:p>
+            <a:pPr algn="l"/>
+            <a:r>
+              <a:rPr sz="1500" b="0">
+                <a:solidFill>
+                  <a:srgbClr val="0F172A"/>
+                </a:solidFill>
+                <a:latin typeface="Calibri"/>
+              </a:rPr>
+              <a:t>1.  Investigate root causes of the systemic pattern:</a:t>
+            </a:r>
+          </a:p>
+          <a:p>
+            <a:pPr algn="l"/>
+            <a:r>
+              <a:rPr sz="1500" b="0">
+                <a:solidFill>
+                  <a:srgbClr val="0F172A"/>
+                </a:solidFill>
+                <a:latin typeface="Calibri"/>
+              </a:rPr>
+              <a:t>     - EHR template review - where are documentation gaps built in?</a:t>
+            </a:r>
+          </a:p>
+          <a:p>
+            <a:pPr algn="l"/>
+            <a:r>
+              <a:rPr sz="1500" b="0">
+                <a:solidFill>
+                  <a:srgbClr val="0F172A"/>
+                </a:solidFill>
+                <a:latin typeface="Calibri"/>
+              </a:rPr>
+              <a:t>     - Provider onboarding - is documentation training part of it?</a:t>
+            </a:r>
+          </a:p>
+          <a:p>
+            <a:pPr algn="l"/>
+            <a:r>
+              <a:rPr sz="1500" b="0">
+                <a:solidFill>
+                  <a:srgbClr val="0F172A"/>
+                </a:solidFill>
+                <a:latin typeface="Calibri"/>
+              </a:rPr>
+              <a:t>     - Copy-forward workflow - is it being audited?</a:t>
+            </a:r>
+          </a:p>
+          <a:p>
+            <a:pPr algn="l"/>
+            <a:r>
+              <a:rPr sz="1500" b="0">
+                <a:solidFill>
+                  <a:srgbClr val="0F172A"/>
+                </a:solidFill>
+                <a:latin typeface="Calibri"/>
+              </a:rPr>
+              <a:t/>
+            </a:r>
+          </a:p>
+          <a:p>
+            <a:pPr algn="l"/>
+            <a:r>
+              <a:rPr sz="1500" b="0">
+                <a:solidFill>
+                  <a:srgbClr val="0F172A"/>
+                </a:solidFill>
+                <a:latin typeface="Calibri"/>
+              </a:rPr>
+              <a:t>2.  Pilot a structured documentation intervention with one clinic</a:t>
+            </a:r>
+          </a:p>
+          <a:p>
+            <a:pPr algn="l"/>
+            <a:r>
+              <a:rPr sz="1500" b="0">
+                <a:solidFill>
+                  <a:srgbClr val="0F172A"/>
+                </a:solidFill>
+                <a:latin typeface="Calibri"/>
+              </a:rPr>
+              <a:t>     (2 providers) - test whether it moves scores to 90%+.</a:t>
+            </a:r>
+          </a:p>
+          <a:p>
+            <a:pPr algn="l"/>
+            <a:r>
+              <a:rPr sz="1500" b="0">
+                <a:solidFill>
+                  <a:srgbClr val="0F172A"/>
+                </a:solidFill>
+                <a:latin typeface="Calibri"/>
+              </a:rPr>
+              <a:t/>
+            </a:r>
+          </a:p>
+          <a:p>
+            <a:pPr algn="l"/>
+            <a:r>
+              <a:rPr sz="1500" b="0">
+                <a:solidFill>
+                  <a:srgbClr val="0F172A"/>
+                </a:solidFill>
+                <a:latin typeface="Calibri"/>
+              </a:rPr>
+              <a:t>3.  Escalate the systemic finding to the Compliance Committee</a:t>
+            </a:r>
+          </a:p>
+          <a:p>
+            <a:pPr algn="l"/>
+            <a:r>
+              <a:rPr sz="1500" b="0">
+                <a:solidFill>
+                  <a:srgbClr val="0F172A"/>
+                </a:solidFill>
+                <a:latin typeface="Calibri"/>
+              </a:rPr>
+              <a:t>     and Revenue Integrity leadership.</a:t>
+            </a:r>
+          </a:p>
+          <a:p>
+            <a:pPr algn="l"/>
+            <a:r>
+              <a:rPr sz="1500" b="0">
+                <a:solidFill>
+                  <a:srgbClr val="0F172A"/>
+                </a:solidFill>
+                <a:latin typeface="Calibri"/>
+              </a:rPr>
+              <a:t/>
+            </a:r>
+          </a:p>
+          <a:p>
+            <a:pPr algn="l"/>
+            <a:r>
+              <a:rPr sz="1500" b="0">
+                <a:solidFill>
+                  <a:srgbClr val="0F172A"/>
+                </a:solidFill>
+                <a:latin typeface="Calibri"/>
+              </a:rPr>
+              <a:t>4.  Prepare 6-month business case for the first CRC hire.</a:t>
+            </a:r>
+          </a:p>
+        </p:txBody>
+      </p:sp>
+      <p:sp>
+        <p:nvSpPr>
+          <p:cNvPr id="6" name="Rectangle 5"/>
+          <p:cNvSpPr/>
+          <p:nvPr/>
+        </p:nvSpPr>
+        <p:spPr>
+          <a:xfrm>
+            <a:off x="0" y="6537960"/>
+            <a:ext cx="12188952" cy="320040"/>
           </a:xfrm>
           <a:prstGeom prst="rect">
             <a:avLst/>
@@ -4304,14 +4504,14 @@
       </p:sp>
       <p:sp>
         <p:nvSpPr>
-          <p:cNvPr id="5" name="TextBox 4"/>
+          <p:cNvPr id="7" name="TextBox 6"/>
           <p:cNvSpPr txBox="1"/>
           <p:nvPr/>
         </p:nvSpPr>
         <p:spPr>
           <a:xfrm>
-            <a:off x="640080" y="1508760"/>
-            <a:ext cx="10972800" cy="457200"/>
+            <a:off x="365760" y="6565392"/>
+            <a:ext cx="5486400" cy="274320"/>
           </a:xfrm>
           <a:prstGeom prst="rect">
             <a:avLst/>
@@ -4326,27 +4526,27 @@
           <a:p>
             <a:pPr algn="l"/>
             <a:r>
-              <a:rPr sz="1800" b="1">
-                <a:solidFill>
-                  <a:srgbClr val="0F6E6E"/>
-                </a:solidFill>
-                <a:latin typeface="Calibri"/>
-              </a:rPr>
-              <a:t>Alejandra Velez Alicea, MD - included in this quarter's ranking</a:t>
-            </a:r>
-          </a:p>
-        </p:txBody>
-      </p:sp>
-      <p:sp>
-        <p:nvSpPr>
-          <p:cNvPr id="6" name="TextBox 5"/>
+              <a:rPr sz="900" b="0">
+                <a:solidFill>
+                  <a:srgbClr val="555555"/>
+                </a:solidFill>
+                <a:latin typeface="Calibri"/>
+              </a:rPr>
+              <a:t>HealthProMed - Q3 2026 Provider Audit Report</a:t>
+            </a:r>
+          </a:p>
+        </p:txBody>
+      </p:sp>
+      <p:sp>
+        <p:nvSpPr>
+          <p:cNvPr id="8" name="TextBox 7"/>
           <p:cNvSpPr txBox="1"/>
           <p:nvPr/>
         </p:nvSpPr>
         <p:spPr>
           <a:xfrm>
-            <a:off x="640080" y="2011680"/>
-            <a:ext cx="10972800" cy="2286000"/>
+            <a:off x="10515600" y="6565392"/>
+            <a:ext cx="1371600" cy="274320"/>
           </a:xfrm>
           <a:prstGeom prst="rect">
             <a:avLst/>
@@ -4359,240 +4559,7 @@
           </a:bodyPr>
           <a:lstStyle/>
           <a:p>
-            <a:pPr algn="l"/>
-            <a:r>
-              <a:rPr sz="1400" b="0">
-                <a:solidFill>
-                  <a:srgbClr val="0F172A"/>
-                </a:solidFill>
-                <a:latin typeface="Calibri"/>
-              </a:rPr>
-              <a:t>- Compliance score: 72.9% (Corrective Education Required, rank #11 of 13)</a:t>
-            </a:r>
-          </a:p>
-          <a:p>
-            <a:pPr algn="l"/>
-            <a:r>
-              <a:rPr sz="1400" b="0">
-                <a:solidFill>
-                  <a:srgbClr val="0F172A"/>
-                </a:solidFill>
-                <a:latin typeface="Calibri"/>
-              </a:rPr>
-              <a:t>- 10 claims audited (DOS 06/10/2026 - 09/06/2026)</a:t>
-            </a:r>
-          </a:p>
-          <a:p>
-            <a:pPr algn="l"/>
-            <a:r>
-              <a:rPr sz="1400" b="0">
-                <a:solidFill>
-                  <a:srgbClr val="0F172A"/>
-                </a:solidFill>
-                <a:latin typeface="Calibri"/>
-              </a:rPr>
-              <a:t>- Data source: extracted from PDF export of the Provider Metrics tab</a:t>
-            </a:r>
-          </a:p>
-          <a:p>
-            <a:pPr algn="l"/>
-            <a:r>
-              <a:rPr sz="1400" b="0">
-                <a:solidFill>
-                  <a:srgbClr val="0F172A"/>
-                </a:solidFill>
-                <a:latin typeface="Calibri"/>
-              </a:rPr>
-              <a:t>- Recommendation: migrate to the standard Excel workbook format so</a:t>
-            </a:r>
-          </a:p>
-          <a:p>
-            <a:pPr algn="l"/>
-            <a:r>
-              <a:rPr sz="1400" b="0">
-                <a:solidFill>
-                  <a:srgbClr val="0F172A"/>
-                </a:solidFill>
-                <a:latin typeface="Calibri"/>
-              </a:rPr>
-              <a:t>   future rollups auto-populate without manual PDF conversion.</a:t>
-            </a:r>
-          </a:p>
-        </p:txBody>
-      </p:sp>
-      <p:sp>
-        <p:nvSpPr>
-          <p:cNvPr id="7" name="TextBox 6"/>
-          <p:cNvSpPr txBox="1"/>
-          <p:nvPr/>
-        </p:nvSpPr>
-        <p:spPr>
-          <a:xfrm>
-            <a:off x="457200" y="4480560"/>
-            <a:ext cx="10972800" cy="457200"/>
-          </a:xfrm>
-          <a:prstGeom prst="rect">
-            <a:avLst/>
-          </a:prstGeom>
-          <a:noFill/>
-        </p:spPr>
-        <p:txBody>
-          <a:bodyPr wrap="square" lIns="45720" rIns="45720" tIns="18288" bIns="18288" anchor="t">
-            <a:spAutoFit/>
-          </a:bodyPr>
-          <a:lstStyle/>
-          <a:p>
-            <a:pPr algn="l"/>
-            <a:r>
-              <a:rPr sz="1800" b="1">
-                <a:solidFill>
-                  <a:srgbClr val="0F6E6E"/>
-                </a:solidFill>
-                <a:latin typeface="Calibri"/>
-              </a:rPr>
-              <a:t>Other program follow-ups</a:t>
-            </a:r>
-          </a:p>
-        </p:txBody>
-      </p:sp>
-      <p:sp>
-        <p:nvSpPr>
-          <p:cNvPr id="8" name="TextBox 7"/>
-          <p:cNvSpPr txBox="1"/>
-          <p:nvPr/>
-        </p:nvSpPr>
-        <p:spPr>
-          <a:xfrm>
-            <a:off x="640080" y="4937760"/>
-            <a:ext cx="10972800" cy="1463040"/>
-          </a:xfrm>
-          <a:prstGeom prst="rect">
-            <a:avLst/>
-          </a:prstGeom>
-          <a:noFill/>
-        </p:spPr>
-        <p:txBody>
-          <a:bodyPr wrap="square" lIns="45720" rIns="45720" tIns="18288" bIns="18288" anchor="t">
-            <a:spAutoFit/>
-          </a:bodyPr>
-          <a:lstStyle/>
-          <a:p>
-            <a:pPr algn="l"/>
-            <a:r>
-              <a:rPr sz="1300" b="0">
-                <a:solidFill>
-                  <a:srgbClr val="0F172A"/>
-                </a:solidFill>
-                <a:latin typeface="Calibri"/>
-              </a:rPr>
-              <a:t>- Confirm the 10 corrective-plan providers with Medical Director this week.</a:t>
-            </a:r>
-          </a:p>
-          <a:p>
-            <a:pPr algn="l"/>
-            <a:r>
-              <a:rPr sz="1300" b="0">
-                <a:solidFill>
-                  <a:srgbClr val="0F172A"/>
-                </a:solidFill>
-                <a:latin typeface="Calibri"/>
-              </a:rPr>
-              <a:t>- Schedule group education session in October.</a:t>
-            </a:r>
-          </a:p>
-          <a:p>
-            <a:pPr algn="l"/>
-            <a:r>
-              <a:rPr sz="1300" b="0">
-                <a:solidFill>
-                  <a:srgbClr val="0F172A"/>
-                </a:solidFill>
-                <a:latin typeface="Calibri"/>
-              </a:rPr>
-              <a:t>- Refresh HCC lists for all 13 providers before Q4 cycle.</a:t>
-            </a:r>
-          </a:p>
-          <a:p>
-            <a:pPr algn="l"/>
-            <a:r>
-              <a:rPr sz="1300" b="0">
-                <a:solidFill>
-                  <a:srgbClr val="0F172A"/>
-                </a:solidFill>
-                <a:latin typeface="Calibri"/>
-              </a:rPr>
-              <a:t>- Prepare Q4 audit sample pull (mid-October).</a:t>
-            </a:r>
-          </a:p>
-        </p:txBody>
-      </p:sp>
-      <p:sp>
-        <p:nvSpPr>
-          <p:cNvPr id="9" name="Rectangle 8"/>
-          <p:cNvSpPr/>
-          <p:nvPr/>
-        </p:nvSpPr>
-        <p:spPr>
-          <a:xfrm>
-            <a:off x="0" y="6537960"/>
-            <a:ext cx="12188952" cy="320040"/>
-          </a:xfrm>
-          <a:prstGeom prst="rect">
-            <a:avLst/>
-          </a:prstGeom>
-          <a:solidFill>
-            <a:srgbClr val="E6F4F1"/>
-          </a:solidFill>
-          <a:ln>
-            <a:noFill/>
-          </a:ln>
-          <a:effectLst/>
-        </p:spPr>
-        <p:style>
-          <a:lnRef idx="1">
-            <a:schemeClr val="accent1"/>
-          </a:lnRef>
-          <a:fillRef idx="3">
-            <a:schemeClr val="accent1"/>
-          </a:fillRef>
-          <a:effectRef idx="2">
-            <a:schemeClr val="accent1"/>
-          </a:effectRef>
-          <a:fontRef idx="minor">
-            <a:schemeClr val="lt1"/>
-          </a:fontRef>
-        </p:style>
-        <p:txBody>
-          <a:bodyPr rtlCol="0" anchor="ctr"/>
-          <a:lstStyle/>
-          <a:p>
-            <a:pPr algn="ctr"/>
-          </a:p>
-        </p:txBody>
-      </p:sp>
-      <p:sp>
-        <p:nvSpPr>
-          <p:cNvPr id="10" name="TextBox 9"/>
-          <p:cNvSpPr txBox="1"/>
-          <p:nvPr/>
-        </p:nvSpPr>
-        <p:spPr>
-          <a:xfrm>
-            <a:off x="365760" y="6565392"/>
-            <a:ext cx="5486400" cy="274320"/>
-          </a:xfrm>
-          <a:prstGeom prst="rect">
-            <a:avLst/>
-          </a:prstGeom>
-          <a:noFill/>
-        </p:spPr>
-        <p:txBody>
-          <a:bodyPr wrap="square" lIns="45720" rIns="45720" tIns="18288" bIns="18288" anchor="t">
-            <a:spAutoFit/>
-          </a:bodyPr>
-          <a:lstStyle/>
-          <a:p>
-            <a:pPr algn="l"/>
+            <a:pPr algn="r"/>
             <a:r>
               <a:rPr sz="900" b="0">
                 <a:solidFill>
@@ -4600,42 +4567,7 @@
                 </a:solidFill>
                 <a:latin typeface="Calibri"/>
               </a:rPr>
-              <a:t>HealthProMed - Q3 2026 Provider Audit Report</a:t>
-            </a:r>
-          </a:p>
-        </p:txBody>
-      </p:sp>
-      <p:sp>
-        <p:nvSpPr>
-          <p:cNvPr id="11" name="TextBox 10"/>
-          <p:cNvSpPr txBox="1"/>
-          <p:nvPr/>
-        </p:nvSpPr>
-        <p:spPr>
-          <a:xfrm>
-            <a:off x="10515600" y="6565392"/>
-            <a:ext cx="1371600" cy="274320"/>
-          </a:xfrm>
-          <a:prstGeom prst="rect">
-            <a:avLst/>
-          </a:prstGeom>
-          <a:noFill/>
-        </p:spPr>
-        <p:txBody>
-          <a:bodyPr wrap="square" lIns="45720" rIns="45720" tIns="18288" bIns="18288" anchor="t">
-            <a:spAutoFit/>
-          </a:bodyPr>
-          <a:lstStyle/>
-          <a:p>
-            <a:pPr algn="r"/>
-            <a:r>
-              <a:rPr sz="900" b="0">
-                <a:solidFill>
-                  <a:srgbClr val="555555"/>
-                </a:solidFill>
-                <a:latin typeface="Calibri"/>
-              </a:rPr>
-              <a:t>12 / 14</a:t>
+              <a:t>12 / 15</a:t>
             </a:r>
           </a:p>
         </p:txBody>
@@ -4732,231 +4664,21 @@
                 </a:solidFill>
                 <a:latin typeface="Calibri"/>
               </a:rPr>
-              <a:t>Ask of leadership</a:t>
-            </a:r>
-          </a:p>
-        </p:txBody>
-      </p:sp>
-      <p:sp>
-        <p:nvSpPr>
-          <p:cNvPr id="4" name="TextBox 3"/>
-          <p:cNvSpPr txBox="1"/>
-          <p:nvPr/>
-        </p:nvSpPr>
-        <p:spPr>
-          <a:xfrm>
-            <a:off x="365760" y="868680"/>
-            <a:ext cx="11430000" cy="320040"/>
-          </a:xfrm>
-          <a:prstGeom prst="rect">
-            <a:avLst/>
-          </a:prstGeom>
-          <a:noFill/>
-        </p:spPr>
-        <p:txBody>
-          <a:bodyPr wrap="square" lIns="45720" rIns="45720" tIns="18288" bIns="18288" anchor="t">
-            <a:spAutoFit/>
-          </a:bodyPr>
-          <a:lstStyle/>
-          <a:p>
-            <a:pPr algn="l"/>
-            <a:r>
-              <a:rPr sz="1100" b="0">
-                <a:solidFill>
-                  <a:srgbClr val="555555"/>
-                </a:solidFill>
-                <a:latin typeface="Calibri"/>
-              </a:rPr>
-              <a:t>Support needed to execute the corrective plan</a:t>
-            </a:r>
-          </a:p>
-        </p:txBody>
-      </p:sp>
-      <p:sp>
-        <p:nvSpPr>
-          <p:cNvPr id="5" name="Rectangle 4"/>
+              <a:t>Data source note - Alejandra Velez Alicea, MD</a:t>
+            </a:r>
+          </a:p>
+        </p:txBody>
+      </p:sp>
+      <p:sp>
+        <p:nvSpPr>
+          <p:cNvPr id="4" name="Rectangle 3"/>
           <p:cNvSpPr/>
           <p:nvPr/>
         </p:nvSpPr>
         <p:spPr>
           <a:xfrm>
-            <a:off x="457200" y="1280160"/>
-            <a:ext cx="137160" cy="5029200"/>
-          </a:xfrm>
-          <a:prstGeom prst="rect">
-            <a:avLst/>
-          </a:prstGeom>
-          <a:solidFill>
-            <a:srgbClr val="0F172A"/>
-          </a:solidFill>
-          <a:ln>
-            <a:noFill/>
-          </a:ln>
-          <a:effectLst/>
-        </p:spPr>
-        <p:style>
-          <a:lnRef idx="1">
-            <a:schemeClr val="accent1"/>
-          </a:lnRef>
-          <a:fillRef idx="3">
-            <a:schemeClr val="accent1"/>
-          </a:fillRef>
-          <a:effectRef idx="2">
-            <a:schemeClr val="accent1"/>
-          </a:effectRef>
-          <a:fontRef idx="minor">
-            <a:schemeClr val="lt1"/>
-          </a:fontRef>
-        </p:style>
-        <p:txBody>
-          <a:bodyPr rtlCol="0" anchor="ctr"/>
-          <a:lstStyle/>
-          <a:p>
-            <a:pPr algn="ctr"/>
-          </a:p>
-        </p:txBody>
-      </p:sp>
-      <p:sp>
-        <p:nvSpPr>
-          <p:cNvPr id="6" name="TextBox 5"/>
-          <p:cNvSpPr txBox="1"/>
-          <p:nvPr/>
-        </p:nvSpPr>
-        <p:spPr>
-          <a:xfrm>
-            <a:off x="731520" y="1280160"/>
-            <a:ext cx="10972800" cy="5029200"/>
-          </a:xfrm>
-          <a:prstGeom prst="rect">
-            <a:avLst/>
-          </a:prstGeom>
-          <a:noFill/>
-        </p:spPr>
-        <p:txBody>
-          <a:bodyPr wrap="square" lIns="45720" rIns="45720" tIns="18288" bIns="18288" anchor="t">
-            <a:spAutoFit/>
-          </a:bodyPr>
-          <a:lstStyle/>
-          <a:p>
-            <a:pPr algn="l"/>
-            <a:r>
-              <a:rPr sz="1600" b="0">
-                <a:solidFill>
-                  <a:srgbClr val="0F172A"/>
-                </a:solidFill>
-                <a:latin typeface="Calibri"/>
-              </a:rPr>
-              <a:t>1.  Approve the 10 Corrective Education plans and support the 1-on-1 sessions.</a:t>
-            </a:r>
-          </a:p>
-          <a:p>
-            <a:pPr algn="l"/>
-            <a:r>
-              <a:rPr sz="1600" b="0">
-                <a:solidFill>
-                  <a:srgbClr val="0F172A"/>
-                </a:solidFill>
-                <a:latin typeface="Calibri"/>
-              </a:rPr>
-              <a:t/>
-            </a:r>
-          </a:p>
-          <a:p>
-            <a:pPr algn="l"/>
-            <a:r>
-              <a:rPr sz="1600" b="0">
-                <a:solidFill>
-                  <a:srgbClr val="0F172A"/>
-                </a:solidFill>
-                <a:latin typeface="Calibri"/>
-              </a:rPr>
-              <a:t>2.  Endorse the systemic root-cause investigation (EHR templates + workflow).</a:t>
-            </a:r>
-          </a:p>
-          <a:p>
-            <a:pPr algn="l"/>
-            <a:r>
-              <a:rPr sz="1600" b="0">
-                <a:solidFill>
-                  <a:srgbClr val="0F172A"/>
-                </a:solidFill>
-                <a:latin typeface="Calibri"/>
-              </a:rPr>
-              <a:t/>
-            </a:r>
-          </a:p>
-          <a:p>
-            <a:pPr algn="l"/>
-            <a:r>
-              <a:rPr sz="1600" b="0">
-                <a:solidFill>
-                  <a:srgbClr val="0F172A"/>
-                </a:solidFill>
-                <a:latin typeface="Calibri"/>
-              </a:rPr>
-              <a:t>3.  Allocate provider time for the October group education session (1 hour).</a:t>
-            </a:r>
-          </a:p>
-          <a:p>
-            <a:pPr algn="l"/>
-            <a:r>
-              <a:rPr sz="1600" b="0">
-                <a:solidFill>
-                  <a:srgbClr val="0F172A"/>
-                </a:solidFill>
-                <a:latin typeface="Calibri"/>
-              </a:rPr>
-              <a:t/>
-            </a:r>
-          </a:p>
-          <a:p>
-            <a:pPr algn="l"/>
-            <a:r>
-              <a:rPr sz="1600" b="0">
-                <a:solidFill>
-                  <a:srgbClr val="0F172A"/>
-                </a:solidFill>
-                <a:latin typeface="Calibri"/>
-              </a:rPr>
-              <a:t>4.  Approve moving forward with the CRC hire business case at 6-month checkpoint.</a:t>
-            </a:r>
-          </a:p>
-          <a:p>
-            <a:pPr algn="l"/>
-            <a:r>
-              <a:rPr sz="1600" b="0">
-                <a:solidFill>
-                  <a:srgbClr val="0F172A"/>
-                </a:solidFill>
-                <a:latin typeface="Calibri"/>
-              </a:rPr>
-              <a:t/>
-            </a:r>
-          </a:p>
-          <a:p>
-            <a:pPr algn="l"/>
-            <a:r>
-              <a:rPr sz="1600" b="0">
-                <a:solidFill>
-                  <a:srgbClr val="0F172A"/>
-                </a:solidFill>
-                <a:latin typeface="Calibri"/>
-              </a:rPr>
-              <a:t>5.  Continue monthly 30-minute Coding &amp; CDI check-in on the executive calendar.</a:t>
-            </a:r>
-          </a:p>
-        </p:txBody>
-      </p:sp>
-      <p:sp>
-        <p:nvSpPr>
-          <p:cNvPr id="7" name="Rectangle 6"/>
-          <p:cNvSpPr/>
-          <p:nvPr/>
-        </p:nvSpPr>
-        <p:spPr>
-          <a:xfrm>
-            <a:off x="0" y="6537960"/>
-            <a:ext cx="12188952" cy="320040"/>
+            <a:off x="457200" y="1371600"/>
+            <a:ext cx="11338560" cy="2743200"/>
           </a:xfrm>
           <a:prstGeom prst="rect">
             <a:avLst/>
@@ -4993,14 +4715,14 @@
       </p:sp>
       <p:sp>
         <p:nvSpPr>
-          <p:cNvPr id="8" name="TextBox 7"/>
+          <p:cNvPr id="5" name="TextBox 4"/>
           <p:cNvSpPr txBox="1"/>
           <p:nvPr/>
         </p:nvSpPr>
         <p:spPr>
           <a:xfrm>
-            <a:off x="365760" y="6565392"/>
-            <a:ext cx="5486400" cy="274320"/>
+            <a:off x="640080" y="1508760"/>
+            <a:ext cx="10972800" cy="457200"/>
           </a:xfrm>
           <a:prstGeom prst="rect">
             <a:avLst/>
@@ -5015,27 +4737,27 @@
           <a:p>
             <a:pPr algn="l"/>
             <a:r>
-              <a:rPr sz="900" b="0">
-                <a:solidFill>
-                  <a:srgbClr val="555555"/>
-                </a:solidFill>
-                <a:latin typeface="Calibri"/>
-              </a:rPr>
-              <a:t>HealthProMed - Q3 2026 Provider Audit Report</a:t>
-            </a:r>
-          </a:p>
-        </p:txBody>
-      </p:sp>
-      <p:sp>
-        <p:nvSpPr>
-          <p:cNvPr id="9" name="TextBox 8"/>
+              <a:rPr sz="1800" b="1">
+                <a:solidFill>
+                  <a:srgbClr val="0F6E6E"/>
+                </a:solidFill>
+                <a:latin typeface="Calibri"/>
+              </a:rPr>
+              <a:t>Alejandra Velez Alicea, MD - included in this quarter's ranking</a:t>
+            </a:r>
+          </a:p>
+        </p:txBody>
+      </p:sp>
+      <p:sp>
+        <p:nvSpPr>
+          <p:cNvPr id="6" name="TextBox 5"/>
           <p:cNvSpPr txBox="1"/>
           <p:nvPr/>
         </p:nvSpPr>
         <p:spPr>
           <a:xfrm>
-            <a:off x="10515600" y="6565392"/>
-            <a:ext cx="1371600" cy="274320"/>
+            <a:off x="640080" y="2011680"/>
+            <a:ext cx="10972800" cy="2286000"/>
           </a:xfrm>
           <a:prstGeom prst="rect">
             <a:avLst/>
@@ -5048,6 +4770,274 @@
           </a:bodyPr>
           <a:lstStyle/>
           <a:p>
+            <a:pPr algn="l"/>
+            <a:r>
+              <a:rPr sz="1400" b="0">
+                <a:solidFill>
+                  <a:srgbClr val="0F172A"/>
+                </a:solidFill>
+                <a:latin typeface="Calibri"/>
+              </a:rPr>
+              <a:t>- Compliance score: 72.9% (Corrective Education Required, rank #11 of 13)</a:t>
+            </a:r>
+          </a:p>
+          <a:p>
+            <a:pPr algn="l"/>
+            <a:r>
+              <a:rPr sz="1400" b="0">
+                <a:solidFill>
+                  <a:srgbClr val="0F172A"/>
+                </a:solidFill>
+                <a:latin typeface="Calibri"/>
+              </a:rPr>
+              <a:t>- 10 claims audited (DOS 06/10/2026 - 09/06/2026)</a:t>
+            </a:r>
+          </a:p>
+          <a:p>
+            <a:pPr algn="l"/>
+            <a:r>
+              <a:rPr sz="1400" b="0">
+                <a:solidFill>
+                  <a:srgbClr val="0F172A"/>
+                </a:solidFill>
+                <a:latin typeface="Calibri"/>
+              </a:rPr>
+              <a:t>- Data source: extracted from PDF export of the Provider Metrics tab</a:t>
+            </a:r>
+          </a:p>
+          <a:p>
+            <a:pPr algn="l"/>
+            <a:r>
+              <a:rPr sz="1400" b="0">
+                <a:solidFill>
+                  <a:srgbClr val="0F172A"/>
+                </a:solidFill>
+                <a:latin typeface="Calibri"/>
+              </a:rPr>
+              <a:t>- Recommendation: migrate to the standard Excel workbook format so</a:t>
+            </a:r>
+          </a:p>
+          <a:p>
+            <a:pPr algn="l"/>
+            <a:r>
+              <a:rPr sz="1400" b="0">
+                <a:solidFill>
+                  <a:srgbClr val="0F172A"/>
+                </a:solidFill>
+                <a:latin typeface="Calibri"/>
+              </a:rPr>
+              <a:t>   future rollups auto-populate without manual PDF conversion.</a:t>
+            </a:r>
+          </a:p>
+        </p:txBody>
+      </p:sp>
+      <p:sp>
+        <p:nvSpPr>
+          <p:cNvPr id="7" name="TextBox 6"/>
+          <p:cNvSpPr txBox="1"/>
+          <p:nvPr/>
+        </p:nvSpPr>
+        <p:spPr>
+          <a:xfrm>
+            <a:off x="457200" y="4480560"/>
+            <a:ext cx="10972800" cy="457200"/>
+          </a:xfrm>
+          <a:prstGeom prst="rect">
+            <a:avLst/>
+          </a:prstGeom>
+          <a:noFill/>
+        </p:spPr>
+        <p:txBody>
+          <a:bodyPr wrap="square" lIns="45720" rIns="45720" tIns="18288" bIns="18288" anchor="t">
+            <a:spAutoFit/>
+          </a:bodyPr>
+          <a:lstStyle/>
+          <a:p>
+            <a:pPr algn="l"/>
+            <a:r>
+              <a:rPr sz="1800" b="1">
+                <a:solidFill>
+                  <a:srgbClr val="0F6E6E"/>
+                </a:solidFill>
+                <a:latin typeface="Calibri"/>
+              </a:rPr>
+              <a:t>Other program follow-ups</a:t>
+            </a:r>
+          </a:p>
+        </p:txBody>
+      </p:sp>
+      <p:sp>
+        <p:nvSpPr>
+          <p:cNvPr id="8" name="TextBox 7"/>
+          <p:cNvSpPr txBox="1"/>
+          <p:nvPr/>
+        </p:nvSpPr>
+        <p:spPr>
+          <a:xfrm>
+            <a:off x="640080" y="4937760"/>
+            <a:ext cx="10972800" cy="1463040"/>
+          </a:xfrm>
+          <a:prstGeom prst="rect">
+            <a:avLst/>
+          </a:prstGeom>
+          <a:noFill/>
+        </p:spPr>
+        <p:txBody>
+          <a:bodyPr wrap="square" lIns="45720" rIns="45720" tIns="18288" bIns="18288" anchor="t">
+            <a:spAutoFit/>
+          </a:bodyPr>
+          <a:lstStyle/>
+          <a:p>
+            <a:pPr algn="l"/>
+            <a:r>
+              <a:rPr sz="1300" b="0">
+                <a:solidFill>
+                  <a:srgbClr val="0F172A"/>
+                </a:solidFill>
+                <a:latin typeface="Calibri"/>
+              </a:rPr>
+              <a:t>- Confirm the 10 corrective-plan providers with Medical Director this week.</a:t>
+            </a:r>
+          </a:p>
+          <a:p>
+            <a:pPr algn="l"/>
+            <a:r>
+              <a:rPr sz="1300" b="0">
+                <a:solidFill>
+                  <a:srgbClr val="0F172A"/>
+                </a:solidFill>
+                <a:latin typeface="Calibri"/>
+              </a:rPr>
+              <a:t>- Schedule group education session in October.</a:t>
+            </a:r>
+          </a:p>
+          <a:p>
+            <a:pPr algn="l"/>
+            <a:r>
+              <a:rPr sz="1300" b="0">
+                <a:solidFill>
+                  <a:srgbClr val="0F172A"/>
+                </a:solidFill>
+                <a:latin typeface="Calibri"/>
+              </a:rPr>
+              <a:t>- Refresh HCC lists for all 13 providers before Q4 cycle.</a:t>
+            </a:r>
+          </a:p>
+          <a:p>
+            <a:pPr algn="l"/>
+            <a:r>
+              <a:rPr sz="1300" b="0">
+                <a:solidFill>
+                  <a:srgbClr val="0F172A"/>
+                </a:solidFill>
+                <a:latin typeface="Calibri"/>
+              </a:rPr>
+              <a:t>- Prepare Q4 audit sample pull (mid-October).</a:t>
+            </a:r>
+          </a:p>
+        </p:txBody>
+      </p:sp>
+      <p:sp>
+        <p:nvSpPr>
+          <p:cNvPr id="9" name="Rectangle 8"/>
+          <p:cNvSpPr/>
+          <p:nvPr/>
+        </p:nvSpPr>
+        <p:spPr>
+          <a:xfrm>
+            <a:off x="0" y="6537960"/>
+            <a:ext cx="12188952" cy="320040"/>
+          </a:xfrm>
+          <a:prstGeom prst="rect">
+            <a:avLst/>
+          </a:prstGeom>
+          <a:solidFill>
+            <a:srgbClr val="E6F4F1"/>
+          </a:solidFill>
+          <a:ln>
+            <a:noFill/>
+          </a:ln>
+          <a:effectLst/>
+        </p:spPr>
+        <p:style>
+          <a:lnRef idx="1">
+            <a:schemeClr val="accent1"/>
+          </a:lnRef>
+          <a:fillRef idx="3">
+            <a:schemeClr val="accent1"/>
+          </a:fillRef>
+          <a:effectRef idx="2">
+            <a:schemeClr val="accent1"/>
+          </a:effectRef>
+          <a:fontRef idx="minor">
+            <a:schemeClr val="lt1"/>
+          </a:fontRef>
+        </p:style>
+        <p:txBody>
+          <a:bodyPr rtlCol="0" anchor="ctr"/>
+          <a:lstStyle/>
+          <a:p>
+            <a:pPr algn="ctr"/>
+          </a:p>
+        </p:txBody>
+      </p:sp>
+      <p:sp>
+        <p:nvSpPr>
+          <p:cNvPr id="10" name="TextBox 9"/>
+          <p:cNvSpPr txBox="1"/>
+          <p:nvPr/>
+        </p:nvSpPr>
+        <p:spPr>
+          <a:xfrm>
+            <a:off x="365760" y="6565392"/>
+            <a:ext cx="5486400" cy="274320"/>
+          </a:xfrm>
+          <a:prstGeom prst="rect">
+            <a:avLst/>
+          </a:prstGeom>
+          <a:noFill/>
+        </p:spPr>
+        <p:txBody>
+          <a:bodyPr wrap="square" lIns="45720" rIns="45720" tIns="18288" bIns="18288" anchor="t">
+            <a:spAutoFit/>
+          </a:bodyPr>
+          <a:lstStyle/>
+          <a:p>
+            <a:pPr algn="l"/>
+            <a:r>
+              <a:rPr sz="900" b="0">
+                <a:solidFill>
+                  <a:srgbClr val="555555"/>
+                </a:solidFill>
+                <a:latin typeface="Calibri"/>
+              </a:rPr>
+              <a:t>HealthProMed - Q3 2026 Provider Audit Report</a:t>
+            </a:r>
+          </a:p>
+        </p:txBody>
+      </p:sp>
+      <p:sp>
+        <p:nvSpPr>
+          <p:cNvPr id="11" name="TextBox 10"/>
+          <p:cNvSpPr txBox="1"/>
+          <p:nvPr/>
+        </p:nvSpPr>
+        <p:spPr>
+          <a:xfrm>
+            <a:off x="10515600" y="6565392"/>
+            <a:ext cx="1371600" cy="274320"/>
+          </a:xfrm>
+          <a:prstGeom prst="rect">
+            <a:avLst/>
+          </a:prstGeom>
+          <a:noFill/>
+        </p:spPr>
+        <p:txBody>
+          <a:bodyPr wrap="square" lIns="45720" rIns="45720" tIns="18288" bIns="18288" anchor="t">
+            <a:spAutoFit/>
+          </a:bodyPr>
+          <a:lstStyle/>
+          <a:p>
             <a:pPr algn="r"/>
             <a:r>
               <a:rPr sz="900" b="0">
@@ -5056,7 +5046,7 @@
                 </a:solidFill>
                 <a:latin typeface="Calibri"/>
               </a:rPr>
-              <a:t>13 / 14</a:t>
+              <a:t>13 / 15</a:t>
             </a:r>
           </a:p>
         </p:txBody>
@@ -5088,6 +5078,427 @@
         <p:spPr>
           <a:xfrm>
             <a:off x="0" y="0"/>
+            <a:ext cx="12188952" cy="822960"/>
+          </a:xfrm>
+          <a:prstGeom prst="rect">
+            <a:avLst/>
+          </a:prstGeom>
+          <a:solidFill>
+            <a:srgbClr val="0F172A"/>
+          </a:solidFill>
+          <a:ln>
+            <a:noFill/>
+          </a:ln>
+          <a:effectLst/>
+        </p:spPr>
+        <p:style>
+          <a:lnRef idx="1">
+            <a:schemeClr val="accent1"/>
+          </a:lnRef>
+          <a:fillRef idx="3">
+            <a:schemeClr val="accent1"/>
+          </a:fillRef>
+          <a:effectRef idx="2">
+            <a:schemeClr val="accent1"/>
+          </a:effectRef>
+          <a:fontRef idx="minor">
+            <a:schemeClr val="lt1"/>
+          </a:fontRef>
+        </p:style>
+        <p:txBody>
+          <a:bodyPr rtlCol="0" anchor="ctr"/>
+          <a:lstStyle/>
+          <a:p>
+            <a:pPr algn="ctr"/>
+          </a:p>
+        </p:txBody>
+      </p:sp>
+      <p:sp>
+        <p:nvSpPr>
+          <p:cNvPr id="3" name="TextBox 2"/>
+          <p:cNvSpPr txBox="1"/>
+          <p:nvPr/>
+        </p:nvSpPr>
+        <p:spPr>
+          <a:xfrm>
+            <a:off x="365760" y="137160"/>
+            <a:ext cx="11430000" cy="548640"/>
+          </a:xfrm>
+          <a:prstGeom prst="rect">
+            <a:avLst/>
+          </a:prstGeom>
+          <a:noFill/>
+        </p:spPr>
+        <p:txBody>
+          <a:bodyPr wrap="square" lIns="45720" rIns="45720" tIns="18288" bIns="18288" anchor="ctr">
+            <a:spAutoFit/>
+          </a:bodyPr>
+          <a:lstStyle/>
+          <a:p>
+            <a:pPr algn="l"/>
+            <a:r>
+              <a:rPr sz="2400" b="1">
+                <a:solidFill>
+                  <a:srgbClr val="FFFFFF"/>
+                </a:solidFill>
+                <a:latin typeface="Calibri"/>
+              </a:rPr>
+              <a:t>Ask of leadership</a:t>
+            </a:r>
+          </a:p>
+        </p:txBody>
+      </p:sp>
+      <p:sp>
+        <p:nvSpPr>
+          <p:cNvPr id="4" name="TextBox 3"/>
+          <p:cNvSpPr txBox="1"/>
+          <p:nvPr/>
+        </p:nvSpPr>
+        <p:spPr>
+          <a:xfrm>
+            <a:off x="365760" y="868680"/>
+            <a:ext cx="11430000" cy="320040"/>
+          </a:xfrm>
+          <a:prstGeom prst="rect">
+            <a:avLst/>
+          </a:prstGeom>
+          <a:noFill/>
+        </p:spPr>
+        <p:txBody>
+          <a:bodyPr wrap="square" lIns="45720" rIns="45720" tIns="18288" bIns="18288" anchor="t">
+            <a:spAutoFit/>
+          </a:bodyPr>
+          <a:lstStyle/>
+          <a:p>
+            <a:pPr algn="l"/>
+            <a:r>
+              <a:rPr sz="1100" b="0">
+                <a:solidFill>
+                  <a:srgbClr val="555555"/>
+                </a:solidFill>
+                <a:latin typeface="Calibri"/>
+              </a:rPr>
+              <a:t>Support needed to execute the corrective plan</a:t>
+            </a:r>
+          </a:p>
+        </p:txBody>
+      </p:sp>
+      <p:sp>
+        <p:nvSpPr>
+          <p:cNvPr id="5" name="Rectangle 4"/>
+          <p:cNvSpPr/>
+          <p:nvPr/>
+        </p:nvSpPr>
+        <p:spPr>
+          <a:xfrm>
+            <a:off x="457200" y="1280160"/>
+            <a:ext cx="137160" cy="5029200"/>
+          </a:xfrm>
+          <a:prstGeom prst="rect">
+            <a:avLst/>
+          </a:prstGeom>
+          <a:solidFill>
+            <a:srgbClr val="0F172A"/>
+          </a:solidFill>
+          <a:ln>
+            <a:noFill/>
+          </a:ln>
+          <a:effectLst/>
+        </p:spPr>
+        <p:style>
+          <a:lnRef idx="1">
+            <a:schemeClr val="accent1"/>
+          </a:lnRef>
+          <a:fillRef idx="3">
+            <a:schemeClr val="accent1"/>
+          </a:fillRef>
+          <a:effectRef idx="2">
+            <a:schemeClr val="accent1"/>
+          </a:effectRef>
+          <a:fontRef idx="minor">
+            <a:schemeClr val="lt1"/>
+          </a:fontRef>
+        </p:style>
+        <p:txBody>
+          <a:bodyPr rtlCol="0" anchor="ctr"/>
+          <a:lstStyle/>
+          <a:p>
+            <a:pPr algn="ctr"/>
+          </a:p>
+        </p:txBody>
+      </p:sp>
+      <p:sp>
+        <p:nvSpPr>
+          <p:cNvPr id="6" name="TextBox 5"/>
+          <p:cNvSpPr txBox="1"/>
+          <p:nvPr/>
+        </p:nvSpPr>
+        <p:spPr>
+          <a:xfrm>
+            <a:off x="731520" y="1280160"/>
+            <a:ext cx="10972800" cy="5029200"/>
+          </a:xfrm>
+          <a:prstGeom prst="rect">
+            <a:avLst/>
+          </a:prstGeom>
+          <a:noFill/>
+        </p:spPr>
+        <p:txBody>
+          <a:bodyPr wrap="square" lIns="45720" rIns="45720" tIns="18288" bIns="18288" anchor="t">
+            <a:spAutoFit/>
+          </a:bodyPr>
+          <a:lstStyle/>
+          <a:p>
+            <a:pPr algn="l"/>
+            <a:r>
+              <a:rPr sz="1600" b="0">
+                <a:solidFill>
+                  <a:srgbClr val="0F172A"/>
+                </a:solidFill>
+                <a:latin typeface="Calibri"/>
+              </a:rPr>
+              <a:t>1.  Approve the 10 Corrective Education plans and support the 1-on-1 sessions.</a:t>
+            </a:r>
+          </a:p>
+          <a:p>
+            <a:pPr algn="l"/>
+            <a:r>
+              <a:rPr sz="1600" b="0">
+                <a:solidFill>
+                  <a:srgbClr val="0F172A"/>
+                </a:solidFill>
+                <a:latin typeface="Calibri"/>
+              </a:rPr>
+              <a:t/>
+            </a:r>
+          </a:p>
+          <a:p>
+            <a:pPr algn="l"/>
+            <a:r>
+              <a:rPr sz="1600" b="0">
+                <a:solidFill>
+                  <a:srgbClr val="0F172A"/>
+                </a:solidFill>
+                <a:latin typeface="Calibri"/>
+              </a:rPr>
+              <a:t>2.  Endorse the systemic root-cause investigation (EHR templates + workflow).</a:t>
+            </a:r>
+          </a:p>
+          <a:p>
+            <a:pPr algn="l"/>
+            <a:r>
+              <a:rPr sz="1600" b="0">
+                <a:solidFill>
+                  <a:srgbClr val="0F172A"/>
+                </a:solidFill>
+                <a:latin typeface="Calibri"/>
+              </a:rPr>
+              <a:t/>
+            </a:r>
+          </a:p>
+          <a:p>
+            <a:pPr algn="l"/>
+            <a:r>
+              <a:rPr sz="1600" b="0">
+                <a:solidFill>
+                  <a:srgbClr val="0F172A"/>
+                </a:solidFill>
+                <a:latin typeface="Calibri"/>
+              </a:rPr>
+              <a:t>3.  Allocate provider time for the October group education session (1 hour).</a:t>
+            </a:r>
+          </a:p>
+          <a:p>
+            <a:pPr algn="l"/>
+            <a:r>
+              <a:rPr sz="1600" b="0">
+                <a:solidFill>
+                  <a:srgbClr val="0F172A"/>
+                </a:solidFill>
+                <a:latin typeface="Calibri"/>
+              </a:rPr>
+              <a:t/>
+            </a:r>
+          </a:p>
+          <a:p>
+            <a:pPr algn="l"/>
+            <a:r>
+              <a:rPr sz="1600" b="0">
+                <a:solidFill>
+                  <a:srgbClr val="0F172A"/>
+                </a:solidFill>
+                <a:latin typeface="Calibri"/>
+              </a:rPr>
+              <a:t>4.  Approve moving forward with the CRC hire business case at 6-month checkpoint.</a:t>
+            </a:r>
+          </a:p>
+          <a:p>
+            <a:pPr algn="l"/>
+            <a:r>
+              <a:rPr sz="1600" b="0">
+                <a:solidFill>
+                  <a:srgbClr val="0F172A"/>
+                </a:solidFill>
+                <a:latin typeface="Calibri"/>
+              </a:rPr>
+              <a:t/>
+            </a:r>
+          </a:p>
+          <a:p>
+            <a:pPr algn="l"/>
+            <a:r>
+              <a:rPr sz="1600" b="0">
+                <a:solidFill>
+                  <a:srgbClr val="0F172A"/>
+                </a:solidFill>
+                <a:latin typeface="Calibri"/>
+              </a:rPr>
+              <a:t>5.  Continue monthly 30-minute Coding &amp; CDI check-in on the executive calendar.</a:t>
+            </a:r>
+          </a:p>
+        </p:txBody>
+      </p:sp>
+      <p:sp>
+        <p:nvSpPr>
+          <p:cNvPr id="7" name="Rectangle 6"/>
+          <p:cNvSpPr/>
+          <p:nvPr/>
+        </p:nvSpPr>
+        <p:spPr>
+          <a:xfrm>
+            <a:off x="0" y="6537960"/>
+            <a:ext cx="12188952" cy="320040"/>
+          </a:xfrm>
+          <a:prstGeom prst="rect">
+            <a:avLst/>
+          </a:prstGeom>
+          <a:solidFill>
+            <a:srgbClr val="E6F4F1"/>
+          </a:solidFill>
+          <a:ln>
+            <a:noFill/>
+          </a:ln>
+          <a:effectLst/>
+        </p:spPr>
+        <p:style>
+          <a:lnRef idx="1">
+            <a:schemeClr val="accent1"/>
+          </a:lnRef>
+          <a:fillRef idx="3">
+            <a:schemeClr val="accent1"/>
+          </a:fillRef>
+          <a:effectRef idx="2">
+            <a:schemeClr val="accent1"/>
+          </a:effectRef>
+          <a:fontRef idx="minor">
+            <a:schemeClr val="lt1"/>
+          </a:fontRef>
+        </p:style>
+        <p:txBody>
+          <a:bodyPr rtlCol="0" anchor="ctr"/>
+          <a:lstStyle/>
+          <a:p>
+            <a:pPr algn="ctr"/>
+          </a:p>
+        </p:txBody>
+      </p:sp>
+      <p:sp>
+        <p:nvSpPr>
+          <p:cNvPr id="8" name="TextBox 7"/>
+          <p:cNvSpPr txBox="1"/>
+          <p:nvPr/>
+        </p:nvSpPr>
+        <p:spPr>
+          <a:xfrm>
+            <a:off x="365760" y="6565392"/>
+            <a:ext cx="5486400" cy="274320"/>
+          </a:xfrm>
+          <a:prstGeom prst="rect">
+            <a:avLst/>
+          </a:prstGeom>
+          <a:noFill/>
+        </p:spPr>
+        <p:txBody>
+          <a:bodyPr wrap="square" lIns="45720" rIns="45720" tIns="18288" bIns="18288" anchor="t">
+            <a:spAutoFit/>
+          </a:bodyPr>
+          <a:lstStyle/>
+          <a:p>
+            <a:pPr algn="l"/>
+            <a:r>
+              <a:rPr sz="900" b="0">
+                <a:solidFill>
+                  <a:srgbClr val="555555"/>
+                </a:solidFill>
+                <a:latin typeface="Calibri"/>
+              </a:rPr>
+              <a:t>HealthProMed - Q3 2026 Provider Audit Report</a:t>
+            </a:r>
+          </a:p>
+        </p:txBody>
+      </p:sp>
+      <p:sp>
+        <p:nvSpPr>
+          <p:cNvPr id="9" name="TextBox 8"/>
+          <p:cNvSpPr txBox="1"/>
+          <p:nvPr/>
+        </p:nvSpPr>
+        <p:spPr>
+          <a:xfrm>
+            <a:off x="10515600" y="6565392"/>
+            <a:ext cx="1371600" cy="274320"/>
+          </a:xfrm>
+          <a:prstGeom prst="rect">
+            <a:avLst/>
+          </a:prstGeom>
+          <a:noFill/>
+        </p:spPr>
+        <p:txBody>
+          <a:bodyPr wrap="square" lIns="45720" rIns="45720" tIns="18288" bIns="18288" anchor="t">
+            <a:spAutoFit/>
+          </a:bodyPr>
+          <a:lstStyle/>
+          <a:p>
+            <a:pPr algn="r"/>
+            <a:r>
+              <a:rPr sz="900" b="0">
+                <a:solidFill>
+                  <a:srgbClr val="555555"/>
+                </a:solidFill>
+                <a:latin typeface="Calibri"/>
+              </a:rPr>
+              <a:t>14 / 15</a:t>
+            </a:r>
+          </a:p>
+        </p:txBody>
+      </p:sp>
+    </p:spTree>
+  </p:cSld>
+  <p:clrMapOvr>
+    <a:masterClrMapping/>
+  </p:clrMapOvr>
+</p:sld>
+</file>
+
+<file path=ppt/slides/slide15.xml><?xml version="1.0" encoding="utf-8"?>
+<p:sld xmlns:a="http://schemas.openxmlformats.org/drawingml/2006/main" xmlns:p="http://schemas.openxmlformats.org/presentationml/2006/main" xmlns:r="http://schemas.openxmlformats.org/officeDocument/2006/relationships">
+  <p:cSld>
+    <p:spTree>
+      <p:nvGrpSpPr>
+        <p:cNvPr id="1" name=""/>
+        <p:cNvGrpSpPr/>
+        <p:nvPr/>
+      </p:nvGrpSpPr>
+      <p:grpSpPr/>
+      <p:sp>
+        <p:nvSpPr>
+          <p:cNvPr id="2" name="Rectangle 1"/>
+          <p:cNvSpPr/>
+          <p:nvPr/>
+        </p:nvSpPr>
+        <p:spPr>
+          <a:xfrm>
+            <a:off x="0" y="0"/>
             <a:ext cx="12188952" cy="6858000"/>
           </a:xfrm>
           <a:prstGeom prst="rect">
@@ -5471,7 +5882,7 @@
                 </a:solidFill>
                 <a:latin typeface="Calibri"/>
               </a:rPr>
-              <a:t>7.  Recommendations (immediate - short-term - structural)</a:t>
+              <a:t>7.  What this means for HealthProMed</a:t>
             </a:r>
           </a:p>
           <a:p>
@@ -5483,7 +5894,19 @@
                 </a:solidFill>
                 <a:latin typeface="Calibri"/>
               </a:rPr>
-              <a:t>8.  Data source note + next steps</a:t>
+              <a:t>8.  Recommendations (immediate - short-term - structural)</a:t>
+            </a:r>
+          </a:p>
+          <a:p>
+            <a:pPr algn="l"/>
+            <a:r>
+              <a:rPr sz="2200" b="0">
+                <a:solidFill>
+                  <a:srgbClr val="0F172A"/>
+                </a:solidFill>
+                <a:latin typeface="Calibri"/>
+              </a:rPr>
+              <a:t>9.  Data source note + next steps</a:t>
             </a:r>
           </a:p>
         </p:txBody>
@@ -5597,7 +6020,7 @@
                 </a:solidFill>
                 <a:latin typeface="Calibri"/>
               </a:rPr>
-              <a:t>2 / 14</a:t>
+              <a:t>2 / 15</a:t>
             </a:r>
           </a:p>
         </p:txBody>
@@ -6462,7 +6885,7 @@
                 </a:solidFill>
                 <a:latin typeface="Calibri"/>
               </a:rPr>
-              <a:t>3 / 14</a:t>
+              <a:t>3 / 15</a:t>
             </a:r>
           </a:p>
         </p:txBody>
@@ -7748,7 +8171,7 @@
                 </a:solidFill>
                 <a:latin typeface="Calibri"/>
               </a:rPr>
-              <a:t>4 / 14</a:t>
+              <a:t>4 / 15</a:t>
             </a:r>
           </a:p>
         </p:txBody>
@@ -9661,7 +10084,7 @@
                 </a:solidFill>
                 <a:latin typeface="Calibri"/>
               </a:rPr>
-              <a:t>5 / 14</a:t>
+              <a:t>5 / 15</a:t>
             </a:r>
           </a:p>
         </p:txBody>
@@ -10461,7 +10884,7 @@
                 </a:solidFill>
                 <a:latin typeface="Calibri"/>
               </a:rPr>
-              <a:t>6 / 14</a:t>
+              <a:t>6 / 15</a:t>
             </a:r>
           </a:p>
         </p:txBody>
@@ -11769,7 +12192,7 @@
                 </a:solidFill>
                 <a:latin typeface="Calibri"/>
               </a:rPr>
-              <a:t>7 / 14</a:t>
+              <a:t>7 / 15</a:t>
             </a:r>
           </a:p>
         </p:txBody>
@@ -12260,7 +12683,7 @@
                 </a:solidFill>
                 <a:latin typeface="Calibri"/>
               </a:rPr>
-              <a:t>8 / 14</a:t>
+              <a:t>8 / 15</a:t>
             </a:r>
           </a:p>
         </p:txBody>
@@ -12357,21 +12780,100 @@
                 </a:solidFill>
                 <a:latin typeface="Calibri"/>
               </a:rPr>
-              <a:t>Recommendations - Immediate (this week)</a:t>
-            </a:r>
-          </a:p>
-        </p:txBody>
-      </p:sp>
-      <p:sp>
-        <p:nvSpPr>
-          <p:cNvPr id="4" name="Rectangle 3"/>
+              <a:t>What this means for HealthProMed</a:t>
+            </a:r>
+          </a:p>
+        </p:txBody>
+      </p:sp>
+      <p:sp>
+        <p:nvSpPr>
+          <p:cNvPr id="4" name="TextBox 3"/>
+          <p:cNvSpPr txBox="1"/>
+          <p:nvPr/>
+        </p:nvSpPr>
+        <p:spPr>
+          <a:xfrm>
+            <a:off x="365760" y="868680"/>
+            <a:ext cx="11430000" cy="320040"/>
+          </a:xfrm>
+          <a:prstGeom prst="rect">
+            <a:avLst/>
+          </a:prstGeom>
+          <a:noFill/>
+        </p:spPr>
+        <p:txBody>
+          <a:bodyPr wrap="square" lIns="45720" rIns="45720" tIns="18288" bIns="18288" anchor="t">
+            <a:spAutoFit/>
+          </a:bodyPr>
+          <a:lstStyle/>
+          <a:p>
+            <a:pPr algn="l"/>
+            <a:r>
+              <a:rPr sz="1100" b="0">
+                <a:solidFill>
+                  <a:srgbClr val="555555"/>
+                </a:solidFill>
+                <a:latin typeface="Calibri"/>
+              </a:rPr>
+              <a:t>Translating the audit finding into business, compliance, and care impact</a:t>
+            </a:r>
+          </a:p>
+        </p:txBody>
+      </p:sp>
+      <p:sp>
+        <p:nvSpPr>
+          <p:cNvPr id="5" name="Rectangle 4"/>
           <p:cNvSpPr/>
           <p:nvPr/>
         </p:nvSpPr>
         <p:spPr>
           <a:xfrm>
-            <a:off x="457200" y="1280160"/>
-            <a:ext cx="137160" cy="5029200"/>
+            <a:off x="365760" y="1234440"/>
+            <a:ext cx="5669280" cy="2286000"/>
+          </a:xfrm>
+          <a:prstGeom prst="rect">
+            <a:avLst/>
+          </a:prstGeom>
+          <a:solidFill>
+            <a:srgbClr val="E6F4F1"/>
+          </a:solidFill>
+          <a:ln>
+            <a:noFill/>
+          </a:ln>
+          <a:effectLst/>
+        </p:spPr>
+        <p:style>
+          <a:lnRef idx="1">
+            <a:schemeClr val="accent1"/>
+          </a:lnRef>
+          <a:fillRef idx="3">
+            <a:schemeClr val="accent1"/>
+          </a:fillRef>
+          <a:effectRef idx="2">
+            <a:schemeClr val="accent1"/>
+          </a:effectRef>
+          <a:fontRef idx="minor">
+            <a:schemeClr val="lt1"/>
+          </a:fontRef>
+        </p:style>
+        <p:txBody>
+          <a:bodyPr rtlCol="0" anchor="ctr"/>
+          <a:lstStyle/>
+          <a:p>
+            <a:pPr algn="ctr"/>
+          </a:p>
+        </p:txBody>
+      </p:sp>
+      <p:sp>
+        <p:nvSpPr>
+          <p:cNvPr id="6" name="Rectangle 5"/>
+          <p:cNvSpPr/>
+          <p:nvPr/>
+        </p:nvSpPr>
+        <p:spPr>
+          <a:xfrm>
+            <a:off x="365760" y="1234440"/>
+            <a:ext cx="137160" cy="2286000"/>
           </a:xfrm>
           <a:prstGeom prst="rect">
             <a:avLst/>
@@ -12408,14 +12910,14 @@
       </p:sp>
       <p:sp>
         <p:nvSpPr>
-          <p:cNvPr id="5" name="TextBox 4"/>
+          <p:cNvPr id="7" name="TextBox 6"/>
           <p:cNvSpPr txBox="1"/>
           <p:nvPr/>
         </p:nvSpPr>
         <p:spPr>
           <a:xfrm>
-            <a:off x="731520" y="1280160"/>
-            <a:ext cx="10972800" cy="5029200"/>
+            <a:off x="685800" y="1325880"/>
+            <a:ext cx="5303520" cy="411480"/>
           </a:xfrm>
           <a:prstGeom prst="rect">
             <a:avLst/>
@@ -12430,147 +12932,98 @@
           <a:p>
             <a:pPr algn="l"/>
             <a:r>
-              <a:rPr sz="1600" b="0">
+              <a:rPr sz="1400" b="1">
+                <a:solidFill>
+                  <a:srgbClr val="B02424"/>
+                </a:solidFill>
+                <a:latin typeface="Calibri"/>
+              </a:rPr>
+              <a:t>1. Revenue integrity risk</a:t>
+            </a:r>
+          </a:p>
+        </p:txBody>
+      </p:sp>
+      <p:sp>
+        <p:nvSpPr>
+          <p:cNvPr id="8" name="TextBox 7"/>
+          <p:cNvSpPr txBox="1"/>
+          <p:nvPr/>
+        </p:nvSpPr>
+        <p:spPr>
+          <a:xfrm>
+            <a:off x="685800" y="1737360"/>
+            <a:ext cx="5212080" cy="1737360"/>
+          </a:xfrm>
+          <a:prstGeom prst="rect">
+            <a:avLst/>
+          </a:prstGeom>
+          <a:noFill/>
+        </p:spPr>
+        <p:txBody>
+          <a:bodyPr wrap="square" lIns="45720" rIns="45720" tIns="18288" bIns="18288" anchor="t">
+            <a:spAutoFit/>
+          </a:bodyPr>
+          <a:lstStyle/>
+          <a:p>
+            <a:pPr algn="l"/>
+            <a:r>
+              <a:rPr sz="1100" b="0">
                 <a:solidFill>
                   <a:srgbClr val="0F172A"/>
                 </a:solidFill>
                 <a:latin typeface="Calibri"/>
               </a:rPr>
-              <a:t>1.  Open Corrective Education plans for all 10 providers in the &lt;80% band.</a:t>
-            </a:r>
-          </a:p>
-          <a:p>
-            <a:pPr algn="l"/>
-            <a:r>
-              <a:rPr sz="1600" b="0">
+              <a:t>- Under-documented HCCs on MA panels lower RAF scores</a:t>
+            </a:r>
+          </a:p>
+          <a:p>
+            <a:pPr algn="l"/>
+            <a:r>
+              <a:rPr sz="1100" b="0">
                 <a:solidFill>
                   <a:srgbClr val="0F172A"/>
                 </a:solidFill>
                 <a:latin typeface="Calibri"/>
               </a:rPr>
-              <a:t/>
-            </a:r>
-          </a:p>
-          <a:p>
-            <a:pPr algn="l"/>
-            <a:r>
-              <a:rPr sz="1600" b="0">
+              <a:t>   -&gt; real revenue loss ($500-$3,000 per patient per year).</a:t>
+            </a:r>
+          </a:p>
+          <a:p>
+            <a:pPr algn="l"/>
+            <a:r>
+              <a:rPr sz="1100" b="0">
                 <a:solidFill>
                   <a:srgbClr val="0F172A"/>
                 </a:solidFill>
                 <a:latin typeface="Calibri"/>
               </a:rPr>
-              <a:t>2.  Schedule 1-on-1 education sessions with each of the 10 providers.</a:t>
-            </a:r>
-          </a:p>
-          <a:p>
-            <a:pPr algn="l"/>
-            <a:r>
-              <a:rPr sz="1600" b="0">
+              <a:t>- Unsupported diagnoses invite payer recoupment.</a:t>
+            </a:r>
+          </a:p>
+          <a:p>
+            <a:pPr algn="l"/>
+            <a:r>
+              <a:rPr sz="1100" b="0">
                 <a:solidFill>
                   <a:srgbClr val="0F172A"/>
                 </a:solidFill>
                 <a:latin typeface="Calibri"/>
               </a:rPr>
-              <a:t/>
-            </a:r>
-          </a:p>
-          <a:p>
-            <a:pPr algn="l"/>
-            <a:r>
-              <a:rPr sz="1600" b="0">
-                <a:solidFill>
-                  <a:srgbClr val="0F172A"/>
-                </a:solidFill>
-                <a:latin typeface="Calibri"/>
-              </a:rPr>
-              <a:t>3.  Send monthly scorecard emails to all 13 providers - include band,</a:t>
-            </a:r>
-          </a:p>
-          <a:p>
-            <a:pPr algn="l"/>
-            <a:r>
-              <a:rPr sz="1600" b="0">
-                <a:solidFill>
-                  <a:srgbClr val="0F172A"/>
-                </a:solidFill>
-                <a:latin typeface="Calibri"/>
-              </a:rPr>
-              <a:t>     top deficiencies, and next audit date.</a:t>
-            </a:r>
-          </a:p>
-          <a:p>
-            <a:pPr algn="l"/>
-            <a:r>
-              <a:rPr sz="1600" b="0">
-                <a:solidFill>
-                  <a:srgbClr val="0F172A"/>
-                </a:solidFill>
-                <a:latin typeface="Calibri"/>
-              </a:rPr>
-              <a:t/>
-            </a:r>
-          </a:p>
-          <a:p>
-            <a:pPr algn="l"/>
-            <a:r>
-              <a:rPr sz="1600" b="0">
-                <a:solidFill>
-                  <a:srgbClr val="0F172A"/>
-                </a:solidFill>
-                <a:latin typeface="Calibri"/>
-              </a:rPr>
-              <a:t>4.  Notify the Medical Director of the 10 corrective-plan providers</a:t>
-            </a:r>
-          </a:p>
-          <a:p>
-            <a:pPr algn="l"/>
-            <a:r>
-              <a:rPr sz="1600" b="0">
-                <a:solidFill>
-                  <a:srgbClr val="0F172A"/>
-                </a:solidFill>
-                <a:latin typeface="Calibri"/>
-              </a:rPr>
-              <a:t>     so leadership can support the education effort.</a:t>
-            </a:r>
-          </a:p>
-          <a:p>
-            <a:pPr algn="l"/>
-            <a:r>
-              <a:rPr sz="1600" b="0">
-                <a:solidFill>
-                  <a:srgbClr val="0F172A"/>
-                </a:solidFill>
-                <a:latin typeface="Calibri"/>
-              </a:rPr>
-              <a:t/>
-            </a:r>
-          </a:p>
-          <a:p>
-            <a:pPr algn="l"/>
-            <a:r>
-              <a:rPr sz="1600" b="0">
-                <a:solidFill>
-                  <a:srgbClr val="0F172A"/>
-                </a:solidFill>
-                <a:latin typeface="Calibri"/>
-              </a:rPr>
-              <a:t>5.  Log all corrective plans in the KPI Tracker under 'Corrective plans opened'.</a:t>
-            </a:r>
-          </a:p>
-        </p:txBody>
-      </p:sp>
-      <p:sp>
-        <p:nvSpPr>
-          <p:cNvPr id="6" name="Rectangle 5"/>
+              <a:t>- Poor documentation drives claim denials + rework cost.</a:t>
+            </a:r>
+          </a:p>
+        </p:txBody>
+      </p:sp>
+      <p:sp>
+        <p:nvSpPr>
+          <p:cNvPr id="9" name="Rectangle 8"/>
           <p:cNvSpPr/>
           <p:nvPr/>
         </p:nvSpPr>
         <p:spPr>
           <a:xfrm>
-            <a:off x="0" y="6537960"/>
-            <a:ext cx="12188952" cy="320040"/>
+            <a:off x="6172200" y="1234440"/>
+            <a:ext cx="5669280" cy="2286000"/>
           </a:xfrm>
           <a:prstGeom prst="rect">
             <a:avLst/>
@@ -12607,14 +13060,58 @@
       </p:sp>
       <p:sp>
         <p:nvSpPr>
-          <p:cNvPr id="7" name="TextBox 6"/>
+          <p:cNvPr id="10" name="Rectangle 9"/>
+          <p:cNvSpPr/>
+          <p:nvPr/>
+        </p:nvSpPr>
+        <p:spPr>
+          <a:xfrm>
+            <a:off x="6172200" y="1234440"/>
+            <a:ext cx="137160" cy="2286000"/>
+          </a:xfrm>
+          <a:prstGeom prst="rect">
+            <a:avLst/>
+          </a:prstGeom>
+          <a:solidFill>
+            <a:srgbClr val="B45309"/>
+          </a:solidFill>
+          <a:ln>
+            <a:noFill/>
+          </a:ln>
+          <a:effectLst/>
+        </p:spPr>
+        <p:style>
+          <a:lnRef idx="1">
+            <a:schemeClr val="accent1"/>
+          </a:lnRef>
+          <a:fillRef idx="3">
+            <a:schemeClr val="accent1"/>
+          </a:fillRef>
+          <a:effectRef idx="2">
+            <a:schemeClr val="accent1"/>
+          </a:effectRef>
+          <a:fontRef idx="minor">
+            <a:schemeClr val="lt1"/>
+          </a:fontRef>
+        </p:style>
+        <p:txBody>
+          <a:bodyPr rtlCol="0" anchor="ctr"/>
+          <a:lstStyle/>
+          <a:p>
+            <a:pPr algn="ctr"/>
+          </a:p>
+        </p:txBody>
+      </p:sp>
+      <p:sp>
+        <p:nvSpPr>
+          <p:cNvPr id="11" name="TextBox 10"/>
           <p:cNvSpPr txBox="1"/>
           <p:nvPr/>
         </p:nvSpPr>
         <p:spPr>
           <a:xfrm>
-            <a:off x="365760" y="6565392"/>
-            <a:ext cx="5486400" cy="274320"/>
+            <a:off x="6492240" y="1325880"/>
+            <a:ext cx="5303520" cy="411480"/>
           </a:xfrm>
           <a:prstGeom prst="rect">
             <a:avLst/>
@@ -12629,27 +13126,27 @@
           <a:p>
             <a:pPr algn="l"/>
             <a:r>
-              <a:rPr sz="900" b="0">
-                <a:solidFill>
-                  <a:srgbClr val="555555"/>
-                </a:solidFill>
-                <a:latin typeface="Calibri"/>
-              </a:rPr>
-              <a:t>HealthProMed - Q3 2026 Provider Audit Report</a:t>
-            </a:r>
-          </a:p>
-        </p:txBody>
-      </p:sp>
-      <p:sp>
-        <p:nvSpPr>
-          <p:cNvPr id="8" name="TextBox 7"/>
+              <a:rPr sz="1400" b="1">
+                <a:solidFill>
+                  <a:srgbClr val="B45309"/>
+                </a:solidFill>
+                <a:latin typeface="Calibri"/>
+              </a:rPr>
+              <a:t>2. Compliance / regulatory exposure</a:t>
+            </a:r>
+          </a:p>
+        </p:txBody>
+      </p:sp>
+      <p:sp>
+        <p:nvSpPr>
+          <p:cNvPr id="12" name="TextBox 11"/>
           <p:cNvSpPr txBox="1"/>
           <p:nvPr/>
         </p:nvSpPr>
         <p:spPr>
           <a:xfrm>
-            <a:off x="10515600" y="6565392"/>
-            <a:ext cx="1371600" cy="274320"/>
+            <a:off x="6492240" y="1737360"/>
+            <a:ext cx="5212080" cy="1737360"/>
           </a:xfrm>
           <a:prstGeom prst="rect">
             <a:avLst/>
@@ -12662,6 +13159,647 @@
           </a:bodyPr>
           <a:lstStyle/>
           <a:p>
+            <a:pPr algn="l"/>
+            <a:r>
+              <a:rPr sz="1100" b="0">
+                <a:solidFill>
+                  <a:srgbClr val="0F172A"/>
+                </a:solidFill>
+                <a:latin typeface="Calibri"/>
+              </a:rPr>
+              <a:t>- 10 of 13 providers below 80% signals a pattern that</a:t>
+            </a:r>
+          </a:p>
+          <a:p>
+            <a:pPr algn="l"/>
+            <a:r>
+              <a:rPr sz="1100" b="0">
+                <a:solidFill>
+                  <a:srgbClr val="0F172A"/>
+                </a:solidFill>
+                <a:latin typeface="Calibri"/>
+              </a:rPr>
+              <a:t>   would fail external audits (RADV, OIG, payer review).</a:t>
+            </a:r>
+          </a:p>
+          <a:p>
+            <a:pPr algn="l"/>
+            <a:r>
+              <a:rPr sz="1100" b="0">
+                <a:solidFill>
+                  <a:srgbClr val="0F172A"/>
+                </a:solidFill>
+                <a:latin typeface="Calibri"/>
+              </a:rPr>
+              <a:t>- Documented internal audit + corrective action is our</a:t>
+            </a:r>
+          </a:p>
+          <a:p>
+            <a:pPr algn="l"/>
+            <a:r>
+              <a:rPr sz="1100" b="0">
+                <a:solidFill>
+                  <a:srgbClr val="0F172A"/>
+                </a:solidFill>
+                <a:latin typeface="Calibri"/>
+              </a:rPr>
+              <a:t>   protection under OIG Compliance Program element #4.</a:t>
+            </a:r>
+          </a:p>
+        </p:txBody>
+      </p:sp>
+      <p:sp>
+        <p:nvSpPr>
+          <p:cNvPr id="13" name="Rectangle 12"/>
+          <p:cNvSpPr/>
+          <p:nvPr/>
+        </p:nvSpPr>
+        <p:spPr>
+          <a:xfrm>
+            <a:off x="365760" y="3657600"/>
+            <a:ext cx="5669280" cy="2286000"/>
+          </a:xfrm>
+          <a:prstGeom prst="rect">
+            <a:avLst/>
+          </a:prstGeom>
+          <a:solidFill>
+            <a:srgbClr val="E6F4F1"/>
+          </a:solidFill>
+          <a:ln>
+            <a:noFill/>
+          </a:ln>
+          <a:effectLst/>
+        </p:spPr>
+        <p:style>
+          <a:lnRef idx="1">
+            <a:schemeClr val="accent1"/>
+          </a:lnRef>
+          <a:fillRef idx="3">
+            <a:schemeClr val="accent1"/>
+          </a:fillRef>
+          <a:effectRef idx="2">
+            <a:schemeClr val="accent1"/>
+          </a:effectRef>
+          <a:fontRef idx="minor">
+            <a:schemeClr val="lt1"/>
+          </a:fontRef>
+        </p:style>
+        <p:txBody>
+          <a:bodyPr rtlCol="0" anchor="ctr"/>
+          <a:lstStyle/>
+          <a:p>
+            <a:pPr algn="ctr"/>
+          </a:p>
+        </p:txBody>
+      </p:sp>
+      <p:sp>
+        <p:nvSpPr>
+          <p:cNvPr id="14" name="Rectangle 13"/>
+          <p:cNvSpPr/>
+          <p:nvPr/>
+        </p:nvSpPr>
+        <p:spPr>
+          <a:xfrm>
+            <a:off x="365760" y="3657600"/>
+            <a:ext cx="137160" cy="2286000"/>
+          </a:xfrm>
+          <a:prstGeom prst="rect">
+            <a:avLst/>
+          </a:prstGeom>
+          <a:solidFill>
+            <a:srgbClr val="0F6E6E"/>
+          </a:solidFill>
+          <a:ln>
+            <a:noFill/>
+          </a:ln>
+          <a:effectLst/>
+        </p:spPr>
+        <p:style>
+          <a:lnRef idx="1">
+            <a:schemeClr val="accent1"/>
+          </a:lnRef>
+          <a:fillRef idx="3">
+            <a:schemeClr val="accent1"/>
+          </a:fillRef>
+          <a:effectRef idx="2">
+            <a:schemeClr val="accent1"/>
+          </a:effectRef>
+          <a:fontRef idx="minor">
+            <a:schemeClr val="lt1"/>
+          </a:fontRef>
+        </p:style>
+        <p:txBody>
+          <a:bodyPr rtlCol="0" anchor="ctr"/>
+          <a:lstStyle/>
+          <a:p>
+            <a:pPr algn="ctr"/>
+          </a:p>
+        </p:txBody>
+      </p:sp>
+      <p:sp>
+        <p:nvSpPr>
+          <p:cNvPr id="15" name="TextBox 14"/>
+          <p:cNvSpPr txBox="1"/>
+          <p:nvPr/>
+        </p:nvSpPr>
+        <p:spPr>
+          <a:xfrm>
+            <a:off x="685800" y="3749040"/>
+            <a:ext cx="5303520" cy="411480"/>
+          </a:xfrm>
+          <a:prstGeom prst="rect">
+            <a:avLst/>
+          </a:prstGeom>
+          <a:noFill/>
+        </p:spPr>
+        <p:txBody>
+          <a:bodyPr wrap="square" lIns="45720" rIns="45720" tIns="18288" bIns="18288" anchor="t">
+            <a:spAutoFit/>
+          </a:bodyPr>
+          <a:lstStyle/>
+          <a:p>
+            <a:pPr algn="l"/>
+            <a:r>
+              <a:rPr sz="1400" b="1">
+                <a:solidFill>
+                  <a:srgbClr val="0F6E6E"/>
+                </a:solidFill>
+                <a:latin typeface="Calibri"/>
+              </a:rPr>
+              <a:t>3. Quality reporting impact</a:t>
+            </a:r>
+          </a:p>
+        </p:txBody>
+      </p:sp>
+      <p:sp>
+        <p:nvSpPr>
+          <p:cNvPr id="16" name="TextBox 15"/>
+          <p:cNvSpPr txBox="1"/>
+          <p:nvPr/>
+        </p:nvSpPr>
+        <p:spPr>
+          <a:xfrm>
+            <a:off x="685800" y="4160520"/>
+            <a:ext cx="5212080" cy="1737360"/>
+          </a:xfrm>
+          <a:prstGeom prst="rect">
+            <a:avLst/>
+          </a:prstGeom>
+          <a:noFill/>
+        </p:spPr>
+        <p:txBody>
+          <a:bodyPr wrap="square" lIns="45720" rIns="45720" tIns="18288" bIns="18288" anchor="t">
+            <a:spAutoFit/>
+          </a:bodyPr>
+          <a:lstStyle/>
+          <a:p>
+            <a:pPr algn="l"/>
+            <a:r>
+              <a:rPr sz="1100" b="0">
+                <a:solidFill>
+                  <a:srgbClr val="0F172A"/>
+                </a:solidFill>
+                <a:latin typeface="Calibri"/>
+              </a:rPr>
+              <a:t>- Missing screening values (BMI, PHQ-9, A1c) means</a:t>
+            </a:r>
+          </a:p>
+          <a:p>
+            <a:pPr algn="l"/>
+            <a:r>
+              <a:rPr sz="1100" b="0">
+                <a:solidFill>
+                  <a:srgbClr val="0F172A"/>
+                </a:solidFill>
+                <a:latin typeface="Calibri"/>
+              </a:rPr>
+              <a:t>   CPT II codes don't capture -&gt; HEDIS + Star scores drop.</a:t>
+            </a:r>
+          </a:p>
+          <a:p>
+            <a:pPr algn="l"/>
+            <a:r>
+              <a:rPr sz="1100" b="0">
+                <a:solidFill>
+                  <a:srgbClr val="0F172A"/>
+                </a:solidFill>
+                <a:latin typeface="Calibri"/>
+              </a:rPr>
+              <a:t>- Missing follow-up documentation drops measures even</a:t>
+            </a:r>
+          </a:p>
+          <a:p>
+            <a:pPr algn="l"/>
+            <a:r>
+              <a:rPr sz="1100" b="0">
+                <a:solidFill>
+                  <a:srgbClr val="0F172A"/>
+                </a:solidFill>
+                <a:latin typeface="Calibri"/>
+              </a:rPr>
+              <a:t>   when the clinical work was actually done.</a:t>
+            </a:r>
+          </a:p>
+          <a:p>
+            <a:pPr algn="l"/>
+            <a:r>
+              <a:rPr sz="1100" b="0">
+                <a:solidFill>
+                  <a:srgbClr val="0F172A"/>
+                </a:solidFill>
+                <a:latin typeface="Calibri"/>
+              </a:rPr>
+              <a:t>- Weak UDS reporting for FQHC-relevant metrics.</a:t>
+            </a:r>
+          </a:p>
+        </p:txBody>
+      </p:sp>
+      <p:sp>
+        <p:nvSpPr>
+          <p:cNvPr id="17" name="Rectangle 16"/>
+          <p:cNvSpPr/>
+          <p:nvPr/>
+        </p:nvSpPr>
+        <p:spPr>
+          <a:xfrm>
+            <a:off x="6172200" y="3657600"/>
+            <a:ext cx="5669280" cy="2286000"/>
+          </a:xfrm>
+          <a:prstGeom prst="rect">
+            <a:avLst/>
+          </a:prstGeom>
+          <a:solidFill>
+            <a:srgbClr val="E6F4F1"/>
+          </a:solidFill>
+          <a:ln>
+            <a:noFill/>
+          </a:ln>
+          <a:effectLst/>
+        </p:spPr>
+        <p:style>
+          <a:lnRef idx="1">
+            <a:schemeClr val="accent1"/>
+          </a:lnRef>
+          <a:fillRef idx="3">
+            <a:schemeClr val="accent1"/>
+          </a:fillRef>
+          <a:effectRef idx="2">
+            <a:schemeClr val="accent1"/>
+          </a:effectRef>
+          <a:fontRef idx="minor">
+            <a:schemeClr val="lt1"/>
+          </a:fontRef>
+        </p:style>
+        <p:txBody>
+          <a:bodyPr rtlCol="0" anchor="ctr"/>
+          <a:lstStyle/>
+          <a:p>
+            <a:pPr algn="ctr"/>
+          </a:p>
+        </p:txBody>
+      </p:sp>
+      <p:sp>
+        <p:nvSpPr>
+          <p:cNvPr id="18" name="Rectangle 17"/>
+          <p:cNvSpPr/>
+          <p:nvPr/>
+        </p:nvSpPr>
+        <p:spPr>
+          <a:xfrm>
+            <a:off x="6172200" y="3657600"/>
+            <a:ext cx="137160" cy="2286000"/>
+          </a:xfrm>
+          <a:prstGeom prst="rect">
+            <a:avLst/>
+          </a:prstGeom>
+          <a:solidFill>
+            <a:srgbClr val="16A34A"/>
+          </a:solidFill>
+          <a:ln>
+            <a:noFill/>
+          </a:ln>
+          <a:effectLst/>
+        </p:spPr>
+        <p:style>
+          <a:lnRef idx="1">
+            <a:schemeClr val="accent1"/>
+          </a:lnRef>
+          <a:fillRef idx="3">
+            <a:schemeClr val="accent1"/>
+          </a:fillRef>
+          <a:effectRef idx="2">
+            <a:schemeClr val="accent1"/>
+          </a:effectRef>
+          <a:fontRef idx="minor">
+            <a:schemeClr val="lt1"/>
+          </a:fontRef>
+        </p:style>
+        <p:txBody>
+          <a:bodyPr rtlCol="0" anchor="ctr"/>
+          <a:lstStyle/>
+          <a:p>
+            <a:pPr algn="ctr"/>
+          </a:p>
+        </p:txBody>
+      </p:sp>
+      <p:sp>
+        <p:nvSpPr>
+          <p:cNvPr id="19" name="TextBox 18"/>
+          <p:cNvSpPr txBox="1"/>
+          <p:nvPr/>
+        </p:nvSpPr>
+        <p:spPr>
+          <a:xfrm>
+            <a:off x="6492240" y="3749040"/>
+            <a:ext cx="5303520" cy="411480"/>
+          </a:xfrm>
+          <a:prstGeom prst="rect">
+            <a:avLst/>
+          </a:prstGeom>
+          <a:noFill/>
+        </p:spPr>
+        <p:txBody>
+          <a:bodyPr wrap="square" lIns="45720" rIns="45720" tIns="18288" bIns="18288" anchor="t">
+            <a:spAutoFit/>
+          </a:bodyPr>
+          <a:lstStyle/>
+          <a:p>
+            <a:pPr algn="l"/>
+            <a:r>
+              <a:rPr sz="1400" b="1">
+                <a:solidFill>
+                  <a:srgbClr val="16A34A"/>
+                </a:solidFill>
+                <a:latin typeface="Calibri"/>
+              </a:rPr>
+              <a:t>4. Opportunity, not crisis</a:t>
+            </a:r>
+          </a:p>
+        </p:txBody>
+      </p:sp>
+      <p:sp>
+        <p:nvSpPr>
+          <p:cNvPr id="20" name="TextBox 19"/>
+          <p:cNvSpPr txBox="1"/>
+          <p:nvPr/>
+        </p:nvSpPr>
+        <p:spPr>
+          <a:xfrm>
+            <a:off x="6492240" y="4160520"/>
+            <a:ext cx="5212080" cy="1737360"/>
+          </a:xfrm>
+          <a:prstGeom prst="rect">
+            <a:avLst/>
+          </a:prstGeom>
+          <a:noFill/>
+        </p:spPr>
+        <p:txBody>
+          <a:bodyPr wrap="square" lIns="45720" rIns="45720" tIns="18288" bIns="18288" anchor="t">
+            <a:spAutoFit/>
+          </a:bodyPr>
+          <a:lstStyle/>
+          <a:p>
+            <a:pPr algn="l"/>
+            <a:r>
+              <a:rPr sz="1100" b="0">
+                <a:solidFill>
+                  <a:srgbClr val="0F172A"/>
+                </a:solidFill>
+                <a:latin typeface="Calibri"/>
+              </a:rPr>
+              <a:t>- Baseline is captured. Every future cycle is measurable.</a:t>
+            </a:r>
+          </a:p>
+          <a:p>
+            <a:pPr algn="l"/>
+            <a:r>
+              <a:rPr sz="1100" b="0">
+                <a:solidFill>
+                  <a:srgbClr val="0F172A"/>
+                </a:solidFill>
+                <a:latin typeface="Calibri"/>
+              </a:rPr>
+              <a:t>- Systemic root cause = one intervention fixes many providers.</a:t>
+            </a:r>
+          </a:p>
+          <a:p>
+            <a:pPr algn="l"/>
+            <a:r>
+              <a:rPr sz="1100" b="0">
+                <a:solidFill>
+                  <a:srgbClr val="0F172A"/>
+                </a:solidFill>
+                <a:latin typeface="Calibri"/>
+              </a:rPr>
+              <a:t>- Corrective education programs consistently move scores</a:t>
+            </a:r>
+          </a:p>
+          <a:p>
+            <a:pPr algn="l"/>
+            <a:r>
+              <a:rPr sz="1100" b="0">
+                <a:solidFill>
+                  <a:srgbClr val="0F172A"/>
+                </a:solidFill>
+                <a:latin typeface="Calibri"/>
+              </a:rPr>
+              <a:t>   into the 85-90%+ range within 2-3 cycles.</a:t>
+            </a:r>
+          </a:p>
+          <a:p>
+            <a:pPr algn="l"/>
+            <a:r>
+              <a:rPr sz="1100" b="0">
+                <a:solidFill>
+                  <a:srgbClr val="0F172A"/>
+                </a:solidFill>
+                <a:latin typeface="Calibri"/>
+              </a:rPr>
+              <a:t>- This is exactly what a CDI program is built to fix.</a:t>
+            </a:r>
+          </a:p>
+        </p:txBody>
+      </p:sp>
+      <p:sp>
+        <p:nvSpPr>
+          <p:cNvPr id="21" name="Rectangle 20"/>
+          <p:cNvSpPr/>
+          <p:nvPr/>
+        </p:nvSpPr>
+        <p:spPr>
+          <a:xfrm>
+            <a:off x="365760" y="5989320"/>
+            <a:ext cx="11475720" cy="457200"/>
+          </a:xfrm>
+          <a:prstGeom prst="rect">
+            <a:avLst/>
+          </a:prstGeom>
+          <a:solidFill>
+            <a:srgbClr val="0F172A"/>
+          </a:solidFill>
+          <a:ln>
+            <a:noFill/>
+          </a:ln>
+          <a:effectLst/>
+        </p:spPr>
+        <p:style>
+          <a:lnRef idx="1">
+            <a:schemeClr val="accent1"/>
+          </a:lnRef>
+          <a:fillRef idx="3">
+            <a:schemeClr val="accent1"/>
+          </a:fillRef>
+          <a:effectRef idx="2">
+            <a:schemeClr val="accent1"/>
+          </a:effectRef>
+          <a:fontRef idx="minor">
+            <a:schemeClr val="lt1"/>
+          </a:fontRef>
+        </p:style>
+        <p:txBody>
+          <a:bodyPr rtlCol="0" anchor="ctr"/>
+          <a:lstStyle/>
+          <a:p>
+            <a:pPr algn="ctr"/>
+          </a:p>
+        </p:txBody>
+      </p:sp>
+      <p:sp>
+        <p:nvSpPr>
+          <p:cNvPr id="22" name="TextBox 21"/>
+          <p:cNvSpPr txBox="1"/>
+          <p:nvPr/>
+        </p:nvSpPr>
+        <p:spPr>
+          <a:xfrm>
+            <a:off x="548640" y="6035040"/>
+            <a:ext cx="11247120" cy="365760"/>
+          </a:xfrm>
+          <a:prstGeom prst="rect">
+            <a:avLst/>
+          </a:prstGeom>
+          <a:noFill/>
+        </p:spPr>
+        <p:txBody>
+          <a:bodyPr wrap="square" lIns="45720" rIns="45720" tIns="18288" bIns="18288" anchor="ctr">
+            <a:spAutoFit/>
+          </a:bodyPr>
+          <a:lstStyle/>
+          <a:p>
+            <a:pPr algn="l"/>
+            <a:r>
+              <a:rPr sz="1300" b="1">
+                <a:solidFill>
+                  <a:srgbClr val="FFFFFF"/>
+                </a:solidFill>
+                <a:latin typeface="Calibri"/>
+              </a:rPr>
+              <a:t>Bottom line: this is a fixable, high-value opportunity - not a personnel problem.</a:t>
+            </a:r>
+          </a:p>
+        </p:txBody>
+      </p:sp>
+      <p:sp>
+        <p:nvSpPr>
+          <p:cNvPr id="23" name="Rectangle 22"/>
+          <p:cNvSpPr/>
+          <p:nvPr/>
+        </p:nvSpPr>
+        <p:spPr>
+          <a:xfrm>
+            <a:off x="0" y="6537960"/>
+            <a:ext cx="12188952" cy="320040"/>
+          </a:xfrm>
+          <a:prstGeom prst="rect">
+            <a:avLst/>
+          </a:prstGeom>
+          <a:solidFill>
+            <a:srgbClr val="E6F4F1"/>
+          </a:solidFill>
+          <a:ln>
+            <a:noFill/>
+          </a:ln>
+          <a:effectLst/>
+        </p:spPr>
+        <p:style>
+          <a:lnRef idx="1">
+            <a:schemeClr val="accent1"/>
+          </a:lnRef>
+          <a:fillRef idx="3">
+            <a:schemeClr val="accent1"/>
+          </a:fillRef>
+          <a:effectRef idx="2">
+            <a:schemeClr val="accent1"/>
+          </a:effectRef>
+          <a:fontRef idx="minor">
+            <a:schemeClr val="lt1"/>
+          </a:fontRef>
+        </p:style>
+        <p:txBody>
+          <a:bodyPr rtlCol="0" anchor="ctr"/>
+          <a:lstStyle/>
+          <a:p>
+            <a:pPr algn="ctr"/>
+          </a:p>
+        </p:txBody>
+      </p:sp>
+      <p:sp>
+        <p:nvSpPr>
+          <p:cNvPr id="24" name="TextBox 23"/>
+          <p:cNvSpPr txBox="1"/>
+          <p:nvPr/>
+        </p:nvSpPr>
+        <p:spPr>
+          <a:xfrm>
+            <a:off x="365760" y="6565392"/>
+            <a:ext cx="5486400" cy="274320"/>
+          </a:xfrm>
+          <a:prstGeom prst="rect">
+            <a:avLst/>
+          </a:prstGeom>
+          <a:noFill/>
+        </p:spPr>
+        <p:txBody>
+          <a:bodyPr wrap="square" lIns="45720" rIns="45720" tIns="18288" bIns="18288" anchor="t">
+            <a:spAutoFit/>
+          </a:bodyPr>
+          <a:lstStyle/>
+          <a:p>
+            <a:pPr algn="l"/>
+            <a:r>
+              <a:rPr sz="900" b="0">
+                <a:solidFill>
+                  <a:srgbClr val="555555"/>
+                </a:solidFill>
+                <a:latin typeface="Calibri"/>
+              </a:rPr>
+              <a:t>HealthProMed - Q3 2026 Provider Audit Report</a:t>
+            </a:r>
+          </a:p>
+        </p:txBody>
+      </p:sp>
+      <p:sp>
+        <p:nvSpPr>
+          <p:cNvPr id="25" name="TextBox 24"/>
+          <p:cNvSpPr txBox="1"/>
+          <p:nvPr/>
+        </p:nvSpPr>
+        <p:spPr>
+          <a:xfrm>
+            <a:off x="10515600" y="6565392"/>
+            <a:ext cx="1371600" cy="274320"/>
+          </a:xfrm>
+          <a:prstGeom prst="rect">
+            <a:avLst/>
+          </a:prstGeom>
+          <a:noFill/>
+        </p:spPr>
+        <p:txBody>
+          <a:bodyPr wrap="square" lIns="45720" rIns="45720" tIns="18288" bIns="18288" anchor="t">
+            <a:spAutoFit/>
+          </a:bodyPr>
+          <a:lstStyle/>
+          <a:p>
             <a:pPr algn="r"/>
             <a:r>
               <a:rPr sz="900" b="0">
@@ -12670,7 +13808,7 @@
                 </a:solidFill>
                 <a:latin typeface="Calibri"/>
               </a:rPr>
-              <a:t>9 / 14</a:t>
+              <a:t>9 / 15</a:t>
             </a:r>
           </a:p>
         </p:txBody>

</xml_diff>